<commit_message>
Atualiza apresentações: Aula 1, Aula 2, Aula 3 e Desenvolvimento Rápido de Aplicações em Python
</commit_message>
<xml_diff>
--- a/Aula3_RAD_de_ponta_a_ponta.pptx
+++ b/Aula3_RAD_de_ponta_a_ponta.pptx
@@ -20,6 +20,8 @@
     <p:sldId id="268" r:id="rId14"/>
     <p:sldId id="269" r:id="rId15"/>
     <p:sldId id="270" r:id="rId16"/>
+    <p:sldId id="279" r:id="rId30"/>
+    <p:sldId id="280" r:id="rId31"/>
     <p:sldId id="271" r:id="rId17"/>
     <p:sldId id="272" r:id="rId18"/>
     <p:sldId id="273" r:id="rId19"/>
@@ -1800,7 +1802,7 @@
           <a:p>
             <a:r>
               <a:rPr lang="en-US" dirty="0"/>
-              <a:t>Até o fim da aula. O critério de saída é o teste do zero do slide 18 passando numa pasta limpa, com 0 FALHA. Quem terminar revisa o README de outro grupo.</a:t>
+              <a:t>Até o fim da aula. O critério de saída é o teste do zero do slide 20 passando numa pasta limpa, com 0 FALHA. Quem terminar revisa o README de outro grupo.</a:t>
             </a:r>
             <a:endParaRPr lang="en-US" dirty="0"/>
           </a:p>
@@ -3683,7 +3685,7 @@
           <a:ln/>
         </p:spPr>
         <p:txBody>
-          <a:bodyPr wrap="square" lIns="0" tIns="0" rIns="0" bIns="0" rtlCol="0" anchor="ctr"/>
+          <a:bodyPr wrap="none" lIns="0" tIns="0" rIns="0" bIns="0" rtlCol="0" anchor="ctr"/>
           <a:lstStyle/>
           <a:p>
             <a:pPr indent="0" marL="0">
@@ -3694,9 +3696,9 @@
                 <a:solidFill>
                   <a:srgbClr val="8B949E"/>
                 </a:solidFill>
-                <a:latin typeface="Consolas" pitchFamily="34" charset="0"/>
-                <a:ea typeface="Consolas" pitchFamily="34" charset="-122"/>
-                <a:cs typeface="Consolas" pitchFamily="34" charset="-120"/>
+                <a:latin typeface="Courier New" pitchFamily="49" charset="0"/>
+                <a:ea typeface="Courier New" pitchFamily="49" charset="-122"/>
+                <a:cs typeface="Courier New" pitchFamily="49" charset="-120"/>
               </a:rPr>
               <a:t>terminal</a:t>
             </a:r>
@@ -3722,7 +3724,7 @@
           <a:ln/>
         </p:spPr>
         <p:txBody>
-          <a:bodyPr wrap="square" lIns="0" tIns="0" rIns="0" bIns="0" rtlCol="0" anchor="t"/>
+          <a:bodyPr wrap="none" lIns="0" tIns="0" rIns="0" bIns="0" rtlCol="0" anchor="t"/>
           <a:lstStyle/>
           <a:p>
             <a:pPr indent="0" marL="0">
@@ -3733,9 +3735,9 @@
                 <a:solidFill>
                   <a:srgbClr val="E6EDF3"/>
                 </a:solidFill>
-                <a:latin typeface="Consolas" pitchFamily="34" charset="0"/>
-                <a:ea typeface="Consolas" pitchFamily="34" charset="-122"/>
-                <a:cs typeface="Consolas" pitchFamily="34" charset="-120"/>
+                <a:latin typeface="Courier New" pitchFamily="49" charset="0"/>
+                <a:ea typeface="Courier New" pitchFamily="49" charset="-122"/>
+                <a:cs typeface="Courier New" pitchFamily="49" charset="-120"/>
               </a:rPr>
               <a:t>python manage.py test academico</a:t>
             </a:r>
@@ -3750,9 +3752,9 @@
                 <a:solidFill>
                   <a:srgbClr val="E6EDF3"/>
                 </a:solidFill>
-                <a:latin typeface="Consolas" pitchFamily="34" charset="0"/>
-                <a:ea typeface="Consolas" pitchFamily="34" charset="-122"/>
-                <a:cs typeface="Consolas" pitchFamily="34" charset="-120"/>
+                <a:latin typeface="Courier New" pitchFamily="49" charset="0"/>
+                <a:ea typeface="Courier New" pitchFamily="49" charset="-122"/>
+                <a:cs typeface="Courier New" pitchFamily="49" charset="-120"/>
               </a:rPr>
               <a:t>python manage.py check --deploy</a:t>
             </a:r>
@@ -3767,9 +3769,9 @@
                 <a:solidFill>
                   <a:srgbClr val="E6EDF3"/>
                 </a:solidFill>
-                <a:latin typeface="Consolas" pitchFamily="34" charset="0"/>
-                <a:ea typeface="Consolas" pitchFamily="34" charset="-122"/>
-                <a:cs typeface="Consolas" pitchFamily="34" charset="-120"/>
+                <a:latin typeface="Courier New" pitchFamily="49" charset="0"/>
+                <a:ea typeface="Courier New" pitchFamily="49" charset="-122"/>
+                <a:cs typeface="Courier New" pitchFamily="49" charset="-120"/>
               </a:rPr>
               <a:t>python verificar.py</a:t>
             </a:r>
@@ -3960,7 +3962,7 @@
           <a:ln/>
         </p:spPr>
         <p:txBody>
-          <a:bodyPr wrap="square" lIns="0" tIns="0" rIns="0" bIns="0" rtlCol="0" anchor="ctr"/>
+          <a:bodyPr wrap="none" lIns="0" tIns="0" rIns="0" bIns="0" rtlCol="0" anchor="ctr"/>
           <a:lstStyle/>
           <a:p>
             <a:pPr indent="0" marL="0">
@@ -3971,9 +3973,9 @@
                 <a:solidFill>
                   <a:srgbClr val="8B949E"/>
                 </a:solidFill>
-                <a:latin typeface="Consolas" pitchFamily="34" charset="0"/>
-                <a:ea typeface="Consolas" pitchFamily="34" charset="-122"/>
-                <a:cs typeface="Consolas" pitchFamily="34" charset="-120"/>
+                <a:latin typeface="Courier New" pitchFamily="49" charset="0"/>
+                <a:ea typeface="Courier New" pitchFamily="49" charset="-122"/>
+                <a:cs typeface="Courier New" pitchFamily="49" charset="-120"/>
               </a:rPr>
               <a:t>academico/tests/test_media.py</a:t>
             </a:r>
@@ -3999,20 +4001,20 @@
           <a:ln/>
         </p:spPr>
         <p:txBody>
-          <a:bodyPr wrap="square" lIns="0" tIns="0" rIns="0" bIns="0" rtlCol="0" anchor="t"/>
-          <a:lstStyle/>
-          <a:p>
-            <a:pPr indent="0" marL="0">
-              <a:buNone/>
-            </a:pPr>
-            <a:r>
-              <a:rPr lang="en-US" sz="1100" dirty="0">
+          <a:bodyPr wrap="none" lIns="0" tIns="0" rIns="0" bIns="0" rtlCol="0" anchor="t"/>
+          <a:lstStyle/>
+          <a:p>
+            <a:pPr indent="0" marL="0">
+              <a:buNone/>
+            </a:pPr>
+            <a:r>
+              <a:rPr lang="en-US" sz="1050" dirty="0">
                 <a:solidFill>
                   <a:srgbClr val="7DCFFF"/>
                 </a:solidFill>
-                <a:latin typeface="Consolas" pitchFamily="34" charset="0"/>
-                <a:ea typeface="Consolas" pitchFamily="34" charset="-122"/>
-                <a:cs typeface="Consolas" pitchFamily="34" charset="-120"/>
+                <a:latin typeface="Courier New" pitchFamily="49" charset="0"/>
+                <a:ea typeface="Courier New" pitchFamily="49" charset="-122"/>
+                <a:cs typeface="Courier New" pitchFamily="49" charset="-120"/>
               </a:rPr>
               <a:t>from</a:t>
             </a:r>
@@ -4020,13 +4022,13 @@
               <a:buNone/>
             </a:pPr>
             <a:r>
-              <a:rPr lang="en-US" sz="1100" dirty="0">
+              <a:rPr lang="en-US" sz="1050" dirty="0">
                 <a:solidFill>
                   <a:srgbClr val="E6EDF3"/>
                 </a:solidFill>
-                <a:latin typeface="Consolas" pitchFamily="34" charset="0"/>
-                <a:ea typeface="Consolas" pitchFamily="34" charset="-122"/>
-                <a:cs typeface="Consolas" pitchFamily="34" charset="-120"/>
+                <a:latin typeface="Courier New" pitchFamily="49" charset="0"/>
+                <a:ea typeface="Courier New" pitchFamily="49" charset="-122"/>
+                <a:cs typeface="Courier New" pitchFamily="49" charset="-120"/>
               </a:rPr>
               <a:t> django.test </a:t>
             </a:r>
@@ -4034,13 +4036,13 @@
               <a:buNone/>
             </a:pPr>
             <a:r>
-              <a:rPr lang="en-US" sz="1100" dirty="0">
+              <a:rPr lang="en-US" sz="1050" dirty="0">
                 <a:solidFill>
                   <a:srgbClr val="7DCFFF"/>
                 </a:solidFill>
-                <a:latin typeface="Consolas" pitchFamily="34" charset="0"/>
-                <a:ea typeface="Consolas" pitchFamily="34" charset="-122"/>
-                <a:cs typeface="Consolas" pitchFamily="34" charset="-120"/>
+                <a:latin typeface="Courier New" pitchFamily="49" charset="0"/>
+                <a:ea typeface="Courier New" pitchFamily="49" charset="-122"/>
+                <a:cs typeface="Courier New" pitchFamily="49" charset="-120"/>
               </a:rPr>
               <a:t>import</a:t>
             </a:r>
@@ -4048,30 +4050,30 @@
               <a:buNone/>
             </a:pPr>
             <a:r>
-              <a:rPr lang="en-US" sz="1100" dirty="0">
+              <a:rPr lang="en-US" sz="1050" dirty="0">
                 <a:solidFill>
                   <a:srgbClr val="E6EDF3"/>
                 </a:solidFill>
-                <a:latin typeface="Consolas" pitchFamily="34" charset="0"/>
-                <a:ea typeface="Consolas" pitchFamily="34" charset="-122"/>
-                <a:cs typeface="Consolas" pitchFamily="34" charset="-120"/>
+                <a:latin typeface="Courier New" pitchFamily="49" charset="0"/>
+                <a:ea typeface="Courier New" pitchFamily="49" charset="-122"/>
+                <a:cs typeface="Courier New" pitchFamily="49" charset="-120"/>
               </a:rPr>
               <a:t> TestCase</a:t>
             </a:r>
-            <a:endParaRPr lang="en-US" sz="1100" dirty="0"/>
-          </a:p>
-          <a:p>
-            <a:pPr indent="0" marL="0">
-              <a:buNone/>
-            </a:pPr>
-            <a:r>
-              <a:rPr lang="en-US" sz="1100" dirty="0">
+            <a:endParaRPr lang="en-US" sz="1050" dirty="0"/>
+          </a:p>
+          <a:p>
+            <a:pPr indent="0" marL="0">
+              <a:buNone/>
+            </a:pPr>
+            <a:r>
+              <a:rPr lang="en-US" sz="1050" dirty="0">
                 <a:solidFill>
                   <a:srgbClr val="7DCFFF"/>
                 </a:solidFill>
-                <a:latin typeface="Consolas" pitchFamily="34" charset="0"/>
-                <a:ea typeface="Consolas" pitchFamily="34" charset="-122"/>
-                <a:cs typeface="Consolas" pitchFamily="34" charset="-120"/>
+                <a:latin typeface="Courier New" pitchFamily="49" charset="0"/>
+                <a:ea typeface="Courier New" pitchFamily="49" charset="-122"/>
+                <a:cs typeface="Courier New" pitchFamily="49" charset="-120"/>
               </a:rPr>
               <a:t>from</a:t>
             </a:r>
@@ -4079,13 +4081,13 @@
               <a:buNone/>
             </a:pPr>
             <a:r>
-              <a:rPr lang="en-US" sz="1100" dirty="0">
+              <a:rPr lang="en-US" sz="1050" dirty="0">
                 <a:solidFill>
                   <a:srgbClr val="E6EDF3"/>
                 </a:solidFill>
-                <a:latin typeface="Consolas" pitchFamily="34" charset="0"/>
-                <a:ea typeface="Consolas" pitchFamily="34" charset="-122"/>
-                <a:cs typeface="Consolas" pitchFamily="34" charset="-120"/>
+                <a:latin typeface="Courier New" pitchFamily="49" charset="0"/>
+                <a:ea typeface="Courier New" pitchFamily="49" charset="-122"/>
+                <a:cs typeface="Courier New" pitchFamily="49" charset="-120"/>
               </a:rPr>
               <a:t> academico.models </a:t>
             </a:r>
@@ -4093,13 +4095,13 @@
               <a:buNone/>
             </a:pPr>
             <a:r>
-              <a:rPr lang="en-US" sz="1100" dirty="0">
+              <a:rPr lang="en-US" sz="1050" dirty="0">
                 <a:solidFill>
                   <a:srgbClr val="7DCFFF"/>
                 </a:solidFill>
-                <a:latin typeface="Consolas" pitchFamily="34" charset="0"/>
-                <a:ea typeface="Consolas" pitchFamily="34" charset="-122"/>
-                <a:cs typeface="Consolas" pitchFamily="34" charset="-120"/>
+                <a:latin typeface="Courier New" pitchFamily="49" charset="0"/>
+                <a:ea typeface="Courier New" pitchFamily="49" charset="-122"/>
+                <a:cs typeface="Courier New" pitchFamily="49" charset="-120"/>
               </a:rPr>
               <a:t>import</a:t>
             </a:r>
@@ -4107,47 +4109,47 @@
               <a:buNone/>
             </a:pPr>
             <a:r>
-              <a:rPr lang="en-US" sz="1100" dirty="0">
+              <a:rPr lang="en-US" sz="1050" dirty="0">
                 <a:solidFill>
                   <a:srgbClr val="E6EDF3"/>
                 </a:solidFill>
-                <a:latin typeface="Consolas" pitchFamily="34" charset="0"/>
-                <a:ea typeface="Consolas" pitchFamily="34" charset="-122"/>
-                <a:cs typeface="Consolas" pitchFamily="34" charset="-120"/>
+                <a:latin typeface="Courier New" pitchFamily="49" charset="0"/>
+                <a:ea typeface="Courier New" pitchFamily="49" charset="-122"/>
+                <a:cs typeface="Courier New" pitchFamily="49" charset="-120"/>
               </a:rPr>
               <a:t> Aluno, Disciplina, Inscricao</a:t>
             </a:r>
-            <a:endParaRPr lang="en-US" sz="1100" dirty="0"/>
-          </a:p>
-          <a:p>
-            <a:pPr indent="0" marL="0">
-              <a:buNone/>
-            </a:pPr>
-            <a:r>
-              <a:rPr lang="en-US" sz="1100" dirty="0">
+            <a:endParaRPr lang="en-US" sz="1050" dirty="0"/>
+          </a:p>
+          <a:p>
+            <a:pPr indent="0" marL="0">
+              <a:buNone/>
+            </a:pPr>
+            <a:r>
+              <a:rPr lang="en-US" sz="1050" dirty="0">
                 <a:solidFill>
                   <a:srgbClr val="E6EDF3"/>
                 </a:solidFill>
-                <a:latin typeface="Consolas" pitchFamily="34" charset="0"/>
-                <a:ea typeface="Consolas" pitchFamily="34" charset="-122"/>
-                <a:cs typeface="Consolas" pitchFamily="34" charset="-120"/>
+                <a:latin typeface="Courier New" pitchFamily="49" charset="0"/>
+                <a:ea typeface="Courier New" pitchFamily="49" charset="-122"/>
+                <a:cs typeface="Courier New" pitchFamily="49" charset="-120"/>
               </a:rPr>
               <a:t> </a:t>
             </a:r>
-            <a:endParaRPr lang="en-US" sz="1100" dirty="0"/>
-          </a:p>
-          <a:p>
-            <a:pPr indent="0" marL="0">
-              <a:buNone/>
-            </a:pPr>
-            <a:r>
-              <a:rPr lang="en-US" sz="1100" dirty="0">
+            <a:endParaRPr lang="en-US" sz="1050" dirty="0"/>
+          </a:p>
+          <a:p>
+            <a:pPr indent="0" marL="0">
+              <a:buNone/>
+            </a:pPr>
+            <a:r>
+              <a:rPr lang="en-US" sz="1050" dirty="0">
                 <a:solidFill>
                   <a:srgbClr val="7DCFFF"/>
                 </a:solidFill>
-                <a:latin typeface="Consolas" pitchFamily="34" charset="0"/>
-                <a:ea typeface="Consolas" pitchFamily="34" charset="-122"/>
-                <a:cs typeface="Consolas" pitchFamily="34" charset="-120"/>
+                <a:latin typeface="Courier New" pitchFamily="49" charset="0"/>
+                <a:ea typeface="Courier New" pitchFamily="49" charset="-122"/>
+                <a:cs typeface="Courier New" pitchFamily="49" charset="-120"/>
               </a:rPr>
               <a:t>class</a:t>
             </a:r>
@@ -4155,30 +4157,30 @@
               <a:buNone/>
             </a:pPr>
             <a:r>
-              <a:rPr lang="en-US" sz="1100" dirty="0">
+              <a:rPr lang="en-US" sz="1050" dirty="0">
                 <a:solidFill>
                   <a:srgbClr val="E6EDF3"/>
                 </a:solidFill>
-                <a:latin typeface="Consolas" pitchFamily="34" charset="0"/>
-                <a:ea typeface="Consolas" pitchFamily="34" charset="-122"/>
-                <a:cs typeface="Consolas" pitchFamily="34" charset="-120"/>
+                <a:latin typeface="Courier New" pitchFamily="49" charset="0"/>
+                <a:ea typeface="Courier New" pitchFamily="49" charset="-122"/>
+                <a:cs typeface="Courier New" pitchFamily="49" charset="-120"/>
               </a:rPr>
               <a:t> MediaTest(TestCase):</a:t>
             </a:r>
-            <a:endParaRPr lang="en-US" sz="1100" dirty="0"/>
-          </a:p>
-          <a:p>
-            <a:pPr indent="0" marL="0">
-              <a:buNone/>
-            </a:pPr>
-            <a:r>
-              <a:rPr lang="en-US" sz="1100" dirty="0">
+            <a:endParaRPr lang="en-US" sz="1050" dirty="0"/>
+          </a:p>
+          <a:p>
+            <a:pPr indent="0" marL="0">
+              <a:buNone/>
+            </a:pPr>
+            <a:r>
+              <a:rPr lang="en-US" sz="1050" dirty="0">
                 <a:solidFill>
                   <a:srgbClr val="E6EDF3"/>
                 </a:solidFill>
-                <a:latin typeface="Consolas" pitchFamily="34" charset="0"/>
-                <a:ea typeface="Consolas" pitchFamily="34" charset="-122"/>
-                <a:cs typeface="Consolas" pitchFamily="34" charset="-120"/>
+                <a:latin typeface="Courier New" pitchFamily="49" charset="0"/>
+                <a:ea typeface="Courier New" pitchFamily="49" charset="-122"/>
+                <a:cs typeface="Courier New" pitchFamily="49" charset="-120"/>
               </a:rPr>
               <a:t>    </a:t>
             </a:r>
@@ -4186,13 +4188,13 @@
               <a:buNone/>
             </a:pPr>
             <a:r>
-              <a:rPr lang="en-US" sz="1100" dirty="0">
+              <a:rPr lang="en-US" sz="1050" dirty="0">
                 <a:solidFill>
                   <a:srgbClr val="7DCFFF"/>
                 </a:solidFill>
-                <a:latin typeface="Consolas" pitchFamily="34" charset="0"/>
-                <a:ea typeface="Consolas" pitchFamily="34" charset="-122"/>
-                <a:cs typeface="Consolas" pitchFamily="34" charset="-120"/>
+                <a:latin typeface="Courier New" pitchFamily="49" charset="0"/>
+                <a:ea typeface="Courier New" pitchFamily="49" charset="-122"/>
+                <a:cs typeface="Courier New" pitchFamily="49" charset="-120"/>
               </a:rPr>
               <a:t>def</a:t>
             </a:r>
@@ -4200,30 +4202,30 @@
               <a:buNone/>
             </a:pPr>
             <a:r>
-              <a:rPr lang="en-US" sz="1100" dirty="0">
+              <a:rPr lang="en-US" sz="1050" dirty="0">
                 <a:solidFill>
                   <a:srgbClr val="E6EDF3"/>
                 </a:solidFill>
-                <a:latin typeface="Consolas" pitchFamily="34" charset="0"/>
-                <a:ea typeface="Consolas" pitchFamily="34" charset="-122"/>
-                <a:cs typeface="Consolas" pitchFamily="34" charset="-120"/>
+                <a:latin typeface="Courier New" pitchFamily="49" charset="0"/>
+                <a:ea typeface="Courier New" pitchFamily="49" charset="-122"/>
+                <a:cs typeface="Courier New" pitchFamily="49" charset="-120"/>
               </a:rPr>
               <a:t> test_nota_zero_entra_na_media(self):</a:t>
             </a:r>
-            <a:endParaRPr lang="en-US" sz="1100" dirty="0"/>
-          </a:p>
-          <a:p>
-            <a:pPr indent="0" marL="0">
-              <a:buNone/>
-            </a:pPr>
-            <a:r>
-              <a:rPr lang="en-US" sz="1100" dirty="0">
+            <a:endParaRPr lang="en-US" sz="1050" dirty="0"/>
+          </a:p>
+          <a:p>
+            <a:pPr indent="0" marL="0">
+              <a:buNone/>
+            </a:pPr>
+            <a:r>
+              <a:rPr lang="en-US" sz="1050" dirty="0">
                 <a:solidFill>
                   <a:srgbClr val="E6EDF3"/>
                 </a:solidFill>
-                <a:latin typeface="Consolas" pitchFamily="34" charset="0"/>
-                <a:ea typeface="Consolas" pitchFamily="34" charset="-122"/>
-                <a:cs typeface="Consolas" pitchFamily="34" charset="-120"/>
+                <a:latin typeface="Courier New" pitchFamily="49" charset="0"/>
+                <a:ea typeface="Courier New" pitchFamily="49" charset="-122"/>
+                <a:cs typeface="Courier New" pitchFamily="49" charset="-120"/>
               </a:rPr>
               <a:t>        a = Aluno.objects.create(matricula=</a:t>
             </a:r>
@@ -4231,13 +4233,13 @@
               <a:buNone/>
             </a:pPr>
             <a:r>
-              <a:rPr lang="en-US" sz="1100" dirty="0">
+              <a:rPr lang="en-US" sz="1050" dirty="0">
                 <a:solidFill>
                   <a:srgbClr val="F0C674"/>
                 </a:solidFill>
-                <a:latin typeface="Consolas" pitchFamily="34" charset="0"/>
-                <a:ea typeface="Consolas" pitchFamily="34" charset="-122"/>
-                <a:cs typeface="Consolas" pitchFamily="34" charset="-120"/>
+                <a:latin typeface="Courier New" pitchFamily="49" charset="0"/>
+                <a:ea typeface="Courier New" pitchFamily="49" charset="-122"/>
+                <a:cs typeface="Courier New" pitchFamily="49" charset="-120"/>
               </a:rPr>
               <a:t>"2024001"</a:t>
             </a:r>
@@ -4245,30 +4247,30 @@
               <a:buNone/>
             </a:pPr>
             <a:r>
-              <a:rPr lang="en-US" sz="1100" dirty="0">
+              <a:rPr lang="en-US" sz="1050" dirty="0">
                 <a:solidFill>
                   <a:srgbClr val="E6EDF3"/>
                 </a:solidFill>
-                <a:latin typeface="Consolas" pitchFamily="34" charset="0"/>
-                <a:ea typeface="Consolas" pitchFamily="34" charset="-122"/>
-                <a:cs typeface="Consolas" pitchFamily="34" charset="-120"/>
+                <a:latin typeface="Courier New" pitchFamily="49" charset="0"/>
+                <a:ea typeface="Courier New" pitchFamily="49" charset="-122"/>
+                <a:cs typeface="Courier New" pitchFamily="49" charset="-120"/>
               </a:rPr>
               <a:t>,</a:t>
             </a:r>
-            <a:endParaRPr lang="en-US" sz="1100" dirty="0"/>
-          </a:p>
-          <a:p>
-            <a:pPr indent="0" marL="0">
-              <a:buNone/>
-            </a:pPr>
-            <a:r>
-              <a:rPr lang="en-US" sz="1100" dirty="0">
+            <a:endParaRPr lang="en-US" sz="1050" dirty="0"/>
+          </a:p>
+          <a:p>
+            <a:pPr indent="0" marL="0">
+              <a:buNone/>
+            </a:pPr>
+            <a:r>
+              <a:rPr lang="en-US" sz="1050" dirty="0">
                 <a:solidFill>
                   <a:srgbClr val="E6EDF3"/>
                 </a:solidFill>
-                <a:latin typeface="Consolas" pitchFamily="34" charset="0"/>
-                <a:ea typeface="Consolas" pitchFamily="34" charset="-122"/>
-                <a:cs typeface="Consolas" pitchFamily="34" charset="-120"/>
+                <a:latin typeface="Courier New" pitchFamily="49" charset="0"/>
+                <a:ea typeface="Courier New" pitchFamily="49" charset="-122"/>
+                <a:cs typeface="Courier New" pitchFamily="49" charset="-120"/>
               </a:rPr>
               <a:t>                                 nome=</a:t>
             </a:r>
@@ -4276,13 +4278,13 @@
               <a:buNone/>
             </a:pPr>
             <a:r>
-              <a:rPr lang="en-US" sz="1100" dirty="0">
+              <a:rPr lang="en-US" sz="1050" dirty="0">
                 <a:solidFill>
                   <a:srgbClr val="F0C674"/>
                 </a:solidFill>
-                <a:latin typeface="Consolas" pitchFamily="34" charset="0"/>
-                <a:ea typeface="Consolas" pitchFamily="34" charset="-122"/>
-                <a:cs typeface="Consolas" pitchFamily="34" charset="-120"/>
+                <a:latin typeface="Courier New" pitchFamily="49" charset="0"/>
+                <a:ea typeface="Courier New" pitchFamily="49" charset="-122"/>
+                <a:cs typeface="Courier New" pitchFamily="49" charset="-120"/>
               </a:rPr>
               <a:t>"Ana"</a:t>
             </a:r>
@@ -4290,30 +4292,30 @@
               <a:buNone/>
             </a:pPr>
             <a:r>
-              <a:rPr lang="en-US" sz="1100" dirty="0">
+              <a:rPr lang="en-US" sz="1050" dirty="0">
                 <a:solidFill>
                   <a:srgbClr val="E6EDF3"/>
                 </a:solidFill>
-                <a:latin typeface="Consolas" pitchFamily="34" charset="0"/>
-                <a:ea typeface="Consolas" pitchFamily="34" charset="-122"/>
-                <a:cs typeface="Consolas" pitchFamily="34" charset="-120"/>
+                <a:latin typeface="Courier New" pitchFamily="49" charset="0"/>
+                <a:ea typeface="Courier New" pitchFamily="49" charset="-122"/>
+                <a:cs typeface="Courier New" pitchFamily="49" charset="-120"/>
               </a:rPr>
               <a:t>)</a:t>
             </a:r>
-            <a:endParaRPr lang="en-US" sz="1100" dirty="0"/>
-          </a:p>
-          <a:p>
-            <a:pPr indent="0" marL="0">
-              <a:buNone/>
-            </a:pPr>
-            <a:r>
-              <a:rPr lang="en-US" sz="1100" dirty="0">
+            <a:endParaRPr lang="en-US" sz="1050" dirty="0"/>
+          </a:p>
+          <a:p>
+            <a:pPr indent="0" marL="0">
+              <a:buNone/>
+            </a:pPr>
+            <a:r>
+              <a:rPr lang="en-US" sz="1050" dirty="0">
                 <a:solidFill>
                   <a:srgbClr val="E6EDF3"/>
                 </a:solidFill>
-                <a:latin typeface="Consolas" pitchFamily="34" charset="0"/>
-                <a:ea typeface="Consolas" pitchFamily="34" charset="-122"/>
-                <a:cs typeface="Consolas" pitchFamily="34" charset="-120"/>
+                <a:latin typeface="Courier New" pitchFamily="49" charset="0"/>
+                <a:ea typeface="Courier New" pitchFamily="49" charset="-122"/>
+                <a:cs typeface="Courier New" pitchFamily="49" charset="-120"/>
               </a:rPr>
               <a:t>        d = Disciplina.objects.create(codigo=</a:t>
             </a:r>
@@ -4321,13 +4323,13 @@
               <a:buNone/>
             </a:pPr>
             <a:r>
-              <a:rPr lang="en-US" sz="1100" dirty="0">
+              <a:rPr lang="en-US" sz="1050" dirty="0">
                 <a:solidFill>
                   <a:srgbClr val="F0C674"/>
                 </a:solidFill>
-                <a:latin typeface="Consolas" pitchFamily="34" charset="0"/>
-                <a:ea typeface="Consolas" pitchFamily="34" charset="-122"/>
-                <a:cs typeface="Consolas" pitchFamily="34" charset="-120"/>
+                <a:latin typeface="Courier New" pitchFamily="49" charset="0"/>
+                <a:ea typeface="Courier New" pitchFamily="49" charset="-122"/>
+                <a:cs typeface="Courier New" pitchFamily="49" charset="-120"/>
               </a:rPr>
               <a:t>"ARA0095"</a:t>
             </a:r>
@@ -4335,30 +4337,30 @@
               <a:buNone/>
             </a:pPr>
             <a:r>
-              <a:rPr lang="en-US" sz="1100" dirty="0">
+              <a:rPr lang="en-US" sz="1050" dirty="0">
                 <a:solidFill>
                   <a:srgbClr val="E6EDF3"/>
                 </a:solidFill>
-                <a:latin typeface="Consolas" pitchFamily="34" charset="0"/>
-                <a:ea typeface="Consolas" pitchFamily="34" charset="-122"/>
-                <a:cs typeface="Consolas" pitchFamily="34" charset="-120"/>
+                <a:latin typeface="Courier New" pitchFamily="49" charset="0"/>
+                <a:ea typeface="Courier New" pitchFamily="49" charset="-122"/>
+                <a:cs typeface="Courier New" pitchFamily="49" charset="-120"/>
               </a:rPr>
               <a:t>,</a:t>
             </a:r>
-            <a:endParaRPr lang="en-US" sz="1100" dirty="0"/>
-          </a:p>
-          <a:p>
-            <a:pPr indent="0" marL="0">
-              <a:buNone/>
-            </a:pPr>
-            <a:r>
-              <a:rPr lang="en-US" sz="1100" dirty="0">
+            <a:endParaRPr lang="en-US" sz="1050" dirty="0"/>
+          </a:p>
+          <a:p>
+            <a:pPr indent="0" marL="0">
+              <a:buNone/>
+            </a:pPr>
+            <a:r>
+              <a:rPr lang="en-US" sz="1050" dirty="0">
                 <a:solidFill>
                   <a:srgbClr val="E6EDF3"/>
                 </a:solidFill>
-                <a:latin typeface="Consolas" pitchFamily="34" charset="0"/>
-                <a:ea typeface="Consolas" pitchFamily="34" charset="-122"/>
-                <a:cs typeface="Consolas" pitchFamily="34" charset="-120"/>
+                <a:latin typeface="Courier New" pitchFamily="49" charset="0"/>
+                <a:ea typeface="Courier New" pitchFamily="49" charset="-122"/>
+                <a:cs typeface="Courier New" pitchFamily="49" charset="-120"/>
               </a:rPr>
               <a:t>                                      nome=</a:t>
             </a:r>
@@ -4366,13 +4368,13 @@
               <a:buNone/>
             </a:pPr>
             <a:r>
-              <a:rPr lang="en-US" sz="1100" dirty="0">
+              <a:rPr lang="en-US" sz="1050" dirty="0">
                 <a:solidFill>
                   <a:srgbClr val="F0C674"/>
                 </a:solidFill>
-                <a:latin typeface="Consolas" pitchFamily="34" charset="0"/>
-                <a:ea typeface="Consolas" pitchFamily="34" charset="-122"/>
-                <a:cs typeface="Consolas" pitchFamily="34" charset="-120"/>
+                <a:latin typeface="Courier New" pitchFamily="49" charset="0"/>
+                <a:ea typeface="Courier New" pitchFamily="49" charset="-122"/>
+                <a:cs typeface="Courier New" pitchFamily="49" charset="-120"/>
               </a:rPr>
               <a:t>"RAD"</a:t>
             </a:r>
@@ -4380,30 +4382,30 @@
               <a:buNone/>
             </a:pPr>
             <a:r>
-              <a:rPr lang="en-US" sz="1100" dirty="0">
+              <a:rPr lang="en-US" sz="1050" dirty="0">
                 <a:solidFill>
                   <a:srgbClr val="E6EDF3"/>
                 </a:solidFill>
-                <a:latin typeface="Consolas" pitchFamily="34" charset="0"/>
-                <a:ea typeface="Consolas" pitchFamily="34" charset="-122"/>
-                <a:cs typeface="Consolas" pitchFamily="34" charset="-120"/>
+                <a:latin typeface="Courier New" pitchFamily="49" charset="0"/>
+                <a:ea typeface="Courier New" pitchFamily="49" charset="-122"/>
+                <a:cs typeface="Courier New" pitchFamily="49" charset="-120"/>
               </a:rPr>
               <a:t>,</a:t>
             </a:r>
-            <a:endParaRPr lang="en-US" sz="1100" dirty="0"/>
-          </a:p>
-          <a:p>
-            <a:pPr indent="0" marL="0">
-              <a:buNone/>
-            </a:pPr>
-            <a:r>
-              <a:rPr lang="en-US" sz="1100" dirty="0">
+            <a:endParaRPr lang="en-US" sz="1050" dirty="0"/>
+          </a:p>
+          <a:p>
+            <a:pPr indent="0" marL="0">
+              <a:buNone/>
+            </a:pPr>
+            <a:r>
+              <a:rPr lang="en-US" sz="1050" dirty="0">
                 <a:solidFill>
                   <a:srgbClr val="E6EDF3"/>
                 </a:solidFill>
-                <a:latin typeface="Consolas" pitchFamily="34" charset="0"/>
-                <a:ea typeface="Consolas" pitchFamily="34" charset="-122"/>
-                <a:cs typeface="Consolas" pitchFamily="34" charset="-120"/>
+                <a:latin typeface="Courier New" pitchFamily="49" charset="0"/>
+                <a:ea typeface="Courier New" pitchFamily="49" charset="-122"/>
+                <a:cs typeface="Courier New" pitchFamily="49" charset="-120"/>
               </a:rPr>
               <a:t>                                      carga_horaria=</a:t>
             </a:r>
@@ -4411,13 +4413,13 @@
               <a:buNone/>
             </a:pPr>
             <a:r>
-              <a:rPr lang="en-US" sz="1100" dirty="0">
+              <a:rPr lang="en-US" sz="1050" dirty="0">
                 <a:solidFill>
                   <a:srgbClr val="F78C6C"/>
                 </a:solidFill>
-                <a:latin typeface="Consolas" pitchFamily="34" charset="0"/>
-                <a:ea typeface="Consolas" pitchFamily="34" charset="-122"/>
-                <a:cs typeface="Consolas" pitchFamily="34" charset="-120"/>
+                <a:latin typeface="Courier New" pitchFamily="49" charset="0"/>
+                <a:ea typeface="Courier New" pitchFamily="49" charset="-122"/>
+                <a:cs typeface="Courier New" pitchFamily="49" charset="-120"/>
               </a:rPr>
               <a:t>60</a:t>
             </a:r>
@@ -4425,47 +4427,47 @@
               <a:buNone/>
             </a:pPr>
             <a:r>
-              <a:rPr lang="en-US" sz="1100" dirty="0">
+              <a:rPr lang="en-US" sz="1050" dirty="0">
                 <a:solidFill>
                   <a:srgbClr val="E6EDF3"/>
                 </a:solidFill>
-                <a:latin typeface="Consolas" pitchFamily="34" charset="0"/>
-                <a:ea typeface="Consolas" pitchFamily="34" charset="-122"/>
-                <a:cs typeface="Consolas" pitchFamily="34" charset="-120"/>
+                <a:latin typeface="Courier New" pitchFamily="49" charset="0"/>
+                <a:ea typeface="Courier New" pitchFamily="49" charset="-122"/>
+                <a:cs typeface="Courier New" pitchFamily="49" charset="-120"/>
               </a:rPr>
               <a:t>)</a:t>
             </a:r>
-            <a:endParaRPr lang="en-US" sz="1100" dirty="0"/>
-          </a:p>
-          <a:p>
-            <a:pPr indent="0" marL="0">
-              <a:buNone/>
-            </a:pPr>
-            <a:r>
-              <a:rPr lang="en-US" sz="1100" dirty="0">
+            <a:endParaRPr lang="en-US" sz="1050" dirty="0"/>
+          </a:p>
+          <a:p>
+            <a:pPr indent="0" marL="0">
+              <a:buNone/>
+            </a:pPr>
+            <a:r>
+              <a:rPr lang="en-US" sz="1050" dirty="0">
                 <a:solidFill>
                   <a:srgbClr val="E6EDF3"/>
                 </a:solidFill>
-                <a:latin typeface="Consolas" pitchFamily="34" charset="0"/>
-                <a:ea typeface="Consolas" pitchFamily="34" charset="-122"/>
-                <a:cs typeface="Consolas" pitchFamily="34" charset="-120"/>
+                <a:latin typeface="Courier New" pitchFamily="49" charset="0"/>
+                <a:ea typeface="Courier New" pitchFamily="49" charset="-122"/>
+                <a:cs typeface="Courier New" pitchFamily="49" charset="-120"/>
               </a:rPr>
               <a:t>        i = Inscricao.objects.create(aluno=a, disciplina=d,</a:t>
             </a:r>
-            <a:endParaRPr lang="en-US" sz="1100" dirty="0"/>
-          </a:p>
-          <a:p>
-            <a:pPr indent="0" marL="0">
-              <a:buNone/>
-            </a:pPr>
-            <a:r>
-              <a:rPr lang="en-US" sz="1100" dirty="0">
+            <a:endParaRPr lang="en-US" sz="1050" dirty="0"/>
+          </a:p>
+          <a:p>
+            <a:pPr indent="0" marL="0">
+              <a:buNone/>
+            </a:pPr>
+            <a:r>
+              <a:rPr lang="en-US" sz="1050" dirty="0">
                 <a:solidFill>
                   <a:srgbClr val="E6EDF3"/>
                 </a:solidFill>
-                <a:latin typeface="Consolas" pitchFamily="34" charset="0"/>
-                <a:ea typeface="Consolas" pitchFamily="34" charset="-122"/>
-                <a:cs typeface="Consolas" pitchFamily="34" charset="-120"/>
+                <a:latin typeface="Courier New" pitchFamily="49" charset="0"/>
+                <a:ea typeface="Courier New" pitchFamily="49" charset="-122"/>
+                <a:cs typeface="Courier New" pitchFamily="49" charset="-120"/>
               </a:rPr>
               <a:t>                                     nota1=</a:t>
             </a:r>
@@ -4473,13 +4475,13 @@
               <a:buNone/>
             </a:pPr>
             <a:r>
-              <a:rPr lang="en-US" sz="1100" dirty="0">
+              <a:rPr lang="en-US" sz="1050" dirty="0">
                 <a:solidFill>
                   <a:srgbClr val="F78C6C"/>
                 </a:solidFill>
-                <a:latin typeface="Consolas" pitchFamily="34" charset="0"/>
-                <a:ea typeface="Consolas" pitchFamily="34" charset="-122"/>
-                <a:cs typeface="Consolas" pitchFamily="34" charset="-120"/>
+                <a:latin typeface="Courier New" pitchFamily="49" charset="0"/>
+                <a:ea typeface="Courier New" pitchFamily="49" charset="-122"/>
+                <a:cs typeface="Courier New" pitchFamily="49" charset="-120"/>
               </a:rPr>
               <a:t>0</a:t>
             </a:r>
@@ -4487,13 +4489,13 @@
               <a:buNone/>
             </a:pPr>
             <a:r>
-              <a:rPr lang="en-US" sz="1100" dirty="0">
+              <a:rPr lang="en-US" sz="1050" dirty="0">
                 <a:solidFill>
                   <a:srgbClr val="E6EDF3"/>
                 </a:solidFill>
-                <a:latin typeface="Consolas" pitchFamily="34" charset="0"/>
-                <a:ea typeface="Consolas" pitchFamily="34" charset="-122"/>
-                <a:cs typeface="Consolas" pitchFamily="34" charset="-120"/>
+                <a:latin typeface="Courier New" pitchFamily="49" charset="0"/>
+                <a:ea typeface="Courier New" pitchFamily="49" charset="-122"/>
+                <a:cs typeface="Courier New" pitchFamily="49" charset="-120"/>
               </a:rPr>
               <a:t>, nota2=</a:t>
             </a:r>
@@ -4501,13 +4503,13 @@
               <a:buNone/>
             </a:pPr>
             <a:r>
-              <a:rPr lang="en-US" sz="1100" dirty="0">
+              <a:rPr lang="en-US" sz="1050" dirty="0">
                 <a:solidFill>
                   <a:srgbClr val="F78C6C"/>
                 </a:solidFill>
-                <a:latin typeface="Consolas" pitchFamily="34" charset="0"/>
-                <a:ea typeface="Consolas" pitchFamily="34" charset="-122"/>
-                <a:cs typeface="Consolas" pitchFamily="34" charset="-120"/>
+                <a:latin typeface="Courier New" pitchFamily="49" charset="0"/>
+                <a:ea typeface="Courier New" pitchFamily="49" charset="-122"/>
+                <a:cs typeface="Courier New" pitchFamily="49" charset="-120"/>
               </a:rPr>
               <a:t>8</a:t>
             </a:r>
@@ -4515,30 +4517,30 @@
               <a:buNone/>
             </a:pPr>
             <a:r>
-              <a:rPr lang="en-US" sz="1100" dirty="0">
+              <a:rPr lang="en-US" sz="1050" dirty="0">
                 <a:solidFill>
                   <a:srgbClr val="E6EDF3"/>
                 </a:solidFill>
-                <a:latin typeface="Consolas" pitchFamily="34" charset="0"/>
-                <a:ea typeface="Consolas" pitchFamily="34" charset="-122"/>
-                <a:cs typeface="Consolas" pitchFamily="34" charset="-120"/>
+                <a:latin typeface="Courier New" pitchFamily="49" charset="0"/>
+                <a:ea typeface="Courier New" pitchFamily="49" charset="-122"/>
+                <a:cs typeface="Courier New" pitchFamily="49" charset="-120"/>
               </a:rPr>
               <a:t>)</a:t>
             </a:r>
-            <a:endParaRPr lang="en-US" sz="1100" dirty="0"/>
-          </a:p>
-          <a:p>
-            <a:pPr indent="0" marL="0">
-              <a:buNone/>
-            </a:pPr>
-            <a:r>
-              <a:rPr lang="en-US" sz="1100" dirty="0">
+            <a:endParaRPr lang="en-US" sz="1050" dirty="0"/>
+          </a:p>
+          <a:p>
+            <a:pPr indent="0" marL="0">
+              <a:buNone/>
+            </a:pPr>
+            <a:r>
+              <a:rPr lang="en-US" sz="1050" dirty="0">
                 <a:solidFill>
                   <a:srgbClr val="E6EDF3"/>
                 </a:solidFill>
-                <a:latin typeface="Consolas" pitchFamily="34" charset="0"/>
-                <a:ea typeface="Consolas" pitchFamily="34" charset="-122"/>
-                <a:cs typeface="Consolas" pitchFamily="34" charset="-120"/>
+                <a:latin typeface="Courier New" pitchFamily="49" charset="0"/>
+                <a:ea typeface="Courier New" pitchFamily="49" charset="-122"/>
+                <a:cs typeface="Courier New" pitchFamily="49" charset="-120"/>
               </a:rPr>
               <a:t>        self.assertEqual(i.media, </a:t>
             </a:r>
@@ -4546,13 +4548,13 @@
               <a:buNone/>
             </a:pPr>
             <a:r>
-              <a:rPr lang="en-US" sz="1100" dirty="0">
+              <a:rPr lang="en-US" sz="1050" dirty="0">
                 <a:solidFill>
                   <a:srgbClr val="F78C6C"/>
                 </a:solidFill>
-                <a:latin typeface="Consolas" pitchFamily="34" charset="0"/>
-                <a:ea typeface="Consolas" pitchFamily="34" charset="-122"/>
-                <a:cs typeface="Consolas" pitchFamily="34" charset="-120"/>
+                <a:latin typeface="Courier New" pitchFamily="49" charset="0"/>
+                <a:ea typeface="Courier New" pitchFamily="49" charset="-122"/>
+                <a:cs typeface="Courier New" pitchFamily="49" charset="-120"/>
               </a:rPr>
               <a:t>4</a:t>
             </a:r>
@@ -4560,17 +4562,17 @@
               <a:buNone/>
             </a:pPr>
             <a:r>
-              <a:rPr lang="en-US" sz="1100" dirty="0">
+              <a:rPr lang="en-US" sz="1050" dirty="0">
                 <a:solidFill>
                   <a:srgbClr val="E6EDF3"/>
                 </a:solidFill>
-                <a:latin typeface="Consolas" pitchFamily="34" charset="0"/>
-                <a:ea typeface="Consolas" pitchFamily="34" charset="-122"/>
-                <a:cs typeface="Consolas" pitchFamily="34" charset="-120"/>
+                <a:latin typeface="Courier New" pitchFamily="49" charset="0"/>
+                <a:ea typeface="Courier New" pitchFamily="49" charset="-122"/>
+                <a:cs typeface="Courier New" pitchFamily="49" charset="-120"/>
               </a:rPr>
               <a:t>)</a:t>
             </a:r>
-            <a:endParaRPr lang="en-US" sz="1100" dirty="0"/>
+            <a:endParaRPr lang="en-US" sz="1050" dirty="0"/>
           </a:p>
         </p:txBody>
       </p:sp>
@@ -4824,13 +4826,13 @@
               <a:buNone/>
             </a:pPr>
             <a:r>
-              <a:rPr lang="en-US" sz="1300" b="1" dirty="0">
+              <a:rPr lang="en-US" sz="1150" b="1" dirty="0">
                 <a:solidFill>
                   <a:srgbClr val="00397B"/>
                 </a:solidFill>
-                <a:latin typeface="Consolas" pitchFamily="34" charset="0"/>
-                <a:ea typeface="Consolas" pitchFamily="34" charset="-122"/>
-                <a:cs typeface="Consolas" pitchFamily="34" charset="-120"/>
+                <a:latin typeface="Courier New" pitchFamily="49" charset="0"/>
+                <a:ea typeface="Courier New" pitchFamily="49" charset="-122"/>
+                <a:cs typeface="Courier New" pitchFamily="49" charset="-120"/>
               </a:rPr>
               <a:t>verificar.py</a:t>
             </a:r>
@@ -5042,7 +5044,7 @@
           <a:ln/>
         </p:spPr>
         <p:txBody>
-          <a:bodyPr wrap="square" lIns="0" tIns="0" rIns="0" bIns="0" rtlCol="0" anchor="ctr"/>
+          <a:bodyPr wrap="none" lIns="0" tIns="0" rIns="0" bIns="0" rtlCol="0" anchor="ctr"/>
           <a:lstStyle/>
           <a:p>
             <a:pPr indent="0" marL="0">
@@ -5053,9 +5055,9 @@
                 <a:solidFill>
                   <a:srgbClr val="00397B"/>
                 </a:solidFill>
-                <a:latin typeface="Consolas" pitchFamily="34" charset="0"/>
-                <a:ea typeface="Consolas" pitchFamily="34" charset="-122"/>
-                <a:cs typeface="Consolas" pitchFamily="34" charset="-120"/>
+                <a:latin typeface="Courier New" pitchFamily="49" charset="0"/>
+                <a:ea typeface="Courier New" pitchFamily="49" charset="-122"/>
+                <a:cs typeface="Courier New" pitchFamily="49" charset="-120"/>
               </a:rPr>
               <a:t>DEBUG = False</a:t>
             </a:r>
@@ -5105,13 +5107,13 @@
               <a:buNone/>
             </a:pPr>
             <a:r>
-              <a:rPr lang="en-US" sz="1200" dirty="0">
+              <a:rPr lang="en-US" sz="1100" dirty="0">
                 <a:solidFill>
                   <a:srgbClr val="00397B"/>
                 </a:solidFill>
-                <a:latin typeface="Consolas" pitchFamily="34" charset="0"/>
-                <a:ea typeface="Consolas" pitchFamily="34" charset="-122"/>
-                <a:cs typeface="Consolas" pitchFamily="34" charset="-120"/>
+                <a:latin typeface="Courier New" pitchFamily="49" charset="0"/>
+                <a:ea typeface="Courier New" pitchFamily="49" charset="-122"/>
+                <a:cs typeface="Courier New" pitchFamily="49" charset="-120"/>
               </a:rPr>
               <a:t>True</a:t>
             </a:r>
@@ -5234,13 +5236,13 @@
               <a:buNone/>
             </a:pPr>
             <a:r>
-              <a:rPr lang="en-US" sz="1300" b="1" dirty="0">
+              <a:rPr lang="en-US" sz="1150" b="1" dirty="0">
                 <a:solidFill>
                   <a:srgbClr val="00397B"/>
                 </a:solidFill>
-                <a:latin typeface="Consolas" pitchFamily="34" charset="0"/>
-                <a:ea typeface="Consolas" pitchFamily="34" charset="-122"/>
-                <a:cs typeface="Consolas" pitchFamily="34" charset="-120"/>
+                <a:latin typeface="Courier New" pitchFamily="49" charset="0"/>
+                <a:ea typeface="Courier New" pitchFamily="49" charset="-122"/>
+                <a:cs typeface="Courier New" pitchFamily="49" charset="-120"/>
               </a:rPr>
               <a:t>SECRET_KEY</a:t>
             </a:r>
@@ -5301,13 +5303,13 @@
               <a:buNone/>
             </a:pPr>
             <a:r>
-              <a:rPr lang="en-US" sz="1200" dirty="0">
+              <a:rPr lang="en-US" sz="1100" dirty="0">
                 <a:solidFill>
                   <a:srgbClr val="00397B"/>
                 </a:solidFill>
-                <a:latin typeface="Consolas" pitchFamily="34" charset="0"/>
-                <a:ea typeface="Consolas" pitchFamily="34" charset="-122"/>
-                <a:cs typeface="Consolas" pitchFamily="34" charset="-120"/>
+                <a:latin typeface="Courier New" pitchFamily="49" charset="0"/>
+                <a:ea typeface="Courier New" pitchFamily="49" charset="-122"/>
+                <a:cs typeface="Courier New" pitchFamily="49" charset="-120"/>
               </a:rPr>
               <a:t>.env</a:t>
             </a:r>
@@ -5423,7 +5425,7 @@
           <a:ln/>
         </p:spPr>
         <p:txBody>
-          <a:bodyPr wrap="square" lIns="0" tIns="0" rIns="0" bIns="0" rtlCol="0" anchor="ctr"/>
+          <a:bodyPr wrap="none" lIns="0" tIns="0" rIns="0" bIns="0" rtlCol="0" anchor="ctr"/>
           <a:lstStyle/>
           <a:p>
             <a:pPr indent="0" marL="0">
@@ -5434,9 +5436,9 @@
                 <a:solidFill>
                   <a:srgbClr val="00397B"/>
                 </a:solidFill>
-                <a:latin typeface="Consolas" pitchFamily="34" charset="0"/>
-                <a:ea typeface="Consolas" pitchFamily="34" charset="-122"/>
-                <a:cs typeface="Consolas" pitchFamily="34" charset="-120"/>
+                <a:latin typeface="Courier New" pitchFamily="49" charset="0"/>
+                <a:ea typeface="Courier New" pitchFamily="49" charset="-122"/>
+                <a:cs typeface="Courier New" pitchFamily="49" charset="-120"/>
               </a:rPr>
               <a:t>ALLOWED_HOSTS</a:t>
             </a:r>
@@ -5623,13 +5625,13 @@
               <a:buNone/>
             </a:pPr>
             <a:r>
-              <a:rPr lang="en-US" sz="1200" dirty="0">
+              <a:rPr lang="en-US" sz="1100" dirty="0">
                 <a:solidFill>
                   <a:srgbClr val="00397B"/>
                 </a:solidFill>
-                <a:latin typeface="Consolas" pitchFamily="34" charset="0"/>
-                <a:ea typeface="Consolas" pitchFamily="34" charset="-122"/>
-                <a:cs typeface="Consolas" pitchFamily="34" charset="-120"/>
+                <a:latin typeface="Courier New" pitchFamily="49" charset="0"/>
+                <a:ea typeface="Courier New" pitchFamily="49" charset="-122"/>
+                <a:cs typeface="Courier New" pitchFamily="49" charset="-120"/>
               </a:rPr>
               <a:t>runserver</a:t>
             </a:r>
@@ -5942,13 +5944,13 @@
               <a:buNone/>
             </a:pPr>
             <a:r>
-              <a:rPr lang="en-US" sz="1200" dirty="0">
+              <a:rPr lang="en-US" sz="1100" dirty="0">
                 <a:solidFill>
                   <a:srgbClr val="00397B"/>
                 </a:solidFill>
-                <a:latin typeface="Consolas" pitchFamily="34" charset="0"/>
-                <a:ea typeface="Consolas" pitchFamily="34" charset="-122"/>
-                <a:cs typeface="Consolas" pitchFamily="34" charset="-120"/>
+                <a:latin typeface="Courier New" pitchFamily="49" charset="0"/>
+                <a:ea typeface="Courier New" pitchFamily="49" charset="-122"/>
+                <a:cs typeface="Courier New" pitchFamily="49" charset="-120"/>
               </a:rPr>
               <a:t>collectstatic</a:t>
             </a:r>
@@ -5995,13 +5997,13 @@
               <a:buNone/>
             </a:pPr>
             <a:r>
-              <a:rPr lang="en-US" sz="1500" i="1" dirty="0">
+              <a:rPr lang="en-US" sz="1350" i="1" dirty="0">
                 <a:solidFill>
                   <a:srgbClr val="1185AA"/>
                 </a:solidFill>
-                <a:latin typeface="Consolas" pitchFamily="34" charset="0"/>
-                <a:ea typeface="Consolas" pitchFamily="34" charset="-122"/>
-                <a:cs typeface="Consolas" pitchFamily="34" charset="-120"/>
+                <a:latin typeface="Courier New" pitchFamily="49" charset="0"/>
+                <a:ea typeface="Courier New" pitchFamily="49" charset="-122"/>
+                <a:cs typeface="Courier New" pitchFamily="49" charset="-120"/>
               </a:rPr>
               <a:t>python manage.py check --deploy</a:t>
             </a:r>
@@ -6243,38 +6245,38 @@
               <a:buNone/>
             </a:pPr>
             <a:r>
+              <a:rPr lang="en-US" sz="1100" dirty="0">
+                <a:solidFill>
+                  <a:srgbClr val="00397B"/>
+                </a:solidFill>
+                <a:latin typeface="Courier New" pitchFamily="49" charset="0"/>
+                <a:ea typeface="Courier New" pitchFamily="49" charset="-122"/>
+                <a:cs typeface="Courier New" pitchFamily="49" charset="-120"/>
+              </a:rPr>
+              <a:t>.env</a:t>
+            </a:r>
+            <a:pPr algn="ctr" indent="0" marL="0">
+              <a:buNone/>
+            </a:pPr>
+            <a:r>
               <a:rPr lang="en-US" sz="1200" dirty="0">
                 <a:solidFill>
+                  <a:srgbClr val="3A3F44"/>
+                </a:solidFill>
+              </a:rPr>
+              <a:t>, </a:t>
+            </a:r>
+            <a:pPr algn="ctr" indent="0" marL="0">
+              <a:buNone/>
+            </a:pPr>
+            <a:r>
+              <a:rPr lang="en-US" sz="1100" dirty="0">
+                <a:solidFill>
                   <a:srgbClr val="00397B"/>
                 </a:solidFill>
-                <a:latin typeface="Consolas" pitchFamily="34" charset="0"/>
-                <a:ea typeface="Consolas" pitchFamily="34" charset="-122"/>
-                <a:cs typeface="Consolas" pitchFamily="34" charset="-120"/>
-              </a:rPr>
-              <a:t>.env</a:t>
-            </a:r>
-            <a:pPr algn="ctr" indent="0" marL="0">
-              <a:buNone/>
-            </a:pPr>
-            <a:r>
-              <a:rPr lang="en-US" sz="1200" dirty="0">
-                <a:solidFill>
-                  <a:srgbClr val="3A3F44"/>
-                </a:solidFill>
-              </a:rPr>
-              <a:t>, </a:t>
-            </a:r>
-            <a:pPr algn="ctr" indent="0" marL="0">
-              <a:buNone/>
-            </a:pPr>
-            <a:r>
-              <a:rPr lang="en-US" sz="1200" dirty="0">
-                <a:solidFill>
-                  <a:srgbClr val="00397B"/>
-                </a:solidFill>
-                <a:latin typeface="Consolas" pitchFamily="34" charset="0"/>
-                <a:ea typeface="Consolas" pitchFamily="34" charset="-122"/>
-                <a:cs typeface="Consolas" pitchFamily="34" charset="-120"/>
+                <a:latin typeface="Courier New" pitchFamily="49" charset="0"/>
+                <a:ea typeface="Courier New" pitchFamily="49" charset="-122"/>
+                <a:cs typeface="Courier New" pitchFamily="49" charset="-120"/>
               </a:rPr>
               <a:t>.venv</a:t>
             </a:r>
@@ -6661,13 +6663,13 @@
               <a:buNone/>
             </a:pPr>
             <a:r>
-              <a:rPr lang="en-US" sz="1200" dirty="0">
+              <a:rPr lang="en-US" sz="1100" dirty="0">
                 <a:solidFill>
                   <a:srgbClr val="00397B"/>
                 </a:solidFill>
-                <a:latin typeface="Consolas" pitchFamily="34" charset="0"/>
-                <a:ea typeface="Consolas" pitchFamily="34" charset="-122"/>
-                <a:cs typeface="Consolas" pitchFamily="34" charset="-120"/>
+                <a:latin typeface="Courier New" pitchFamily="49" charset="0"/>
+                <a:ea typeface="Courier New" pitchFamily="49" charset="-122"/>
+                <a:cs typeface="Courier New" pitchFamily="49" charset="-120"/>
               </a:rPr>
               <a:t>venv</a:t>
             </a:r>
@@ -6859,38 +6861,38 @@
               <a:buNone/>
             </a:pPr>
             <a:r>
+              <a:rPr lang="en-US" sz="1100" dirty="0">
+                <a:solidFill>
+                  <a:srgbClr val="00397B"/>
+                </a:solidFill>
+                <a:latin typeface="Courier New" pitchFamily="49" charset="0"/>
+                <a:ea typeface="Courier New" pitchFamily="49" charset="-122"/>
+                <a:cs typeface="Courier New" pitchFamily="49" charset="-120"/>
+              </a:rPr>
+              <a:t>migrate</a:t>
+            </a:r>
+            <a:pPr algn="ctr" indent="0" marL="0">
+              <a:buNone/>
+            </a:pPr>
+            <a:r>
               <a:rPr lang="en-US" sz="1200" dirty="0">
                 <a:solidFill>
+                  <a:srgbClr val="3A3F44"/>
+                </a:solidFill>
+              </a:rPr>
+              <a:t> + </a:t>
+            </a:r>
+            <a:pPr algn="ctr" indent="0" marL="0">
+              <a:buNone/>
+            </a:pPr>
+            <a:r>
+              <a:rPr lang="en-US" sz="1100" dirty="0">
+                <a:solidFill>
                   <a:srgbClr val="00397B"/>
                 </a:solidFill>
-                <a:latin typeface="Consolas" pitchFamily="34" charset="0"/>
-                <a:ea typeface="Consolas" pitchFamily="34" charset="-122"/>
-                <a:cs typeface="Consolas" pitchFamily="34" charset="-120"/>
-              </a:rPr>
-              <a:t>migrate</a:t>
-            </a:r>
-            <a:pPr algn="ctr" indent="0" marL="0">
-              <a:buNone/>
-            </a:pPr>
-            <a:r>
-              <a:rPr lang="en-US" sz="1200" dirty="0">
-                <a:solidFill>
-                  <a:srgbClr val="3A3F44"/>
-                </a:solidFill>
-              </a:rPr>
-              <a:t> + </a:t>
-            </a:r>
-            <a:pPr algn="ctr" indent="0" marL="0">
-              <a:buNone/>
-            </a:pPr>
-            <a:r>
-              <a:rPr lang="en-US" sz="1200" dirty="0">
-                <a:solidFill>
-                  <a:srgbClr val="00397B"/>
-                </a:solidFill>
-                <a:latin typeface="Consolas" pitchFamily="34" charset="0"/>
-                <a:ea typeface="Consolas" pitchFamily="34" charset="-122"/>
-                <a:cs typeface="Consolas" pitchFamily="34" charset="-120"/>
+                <a:latin typeface="Courier New" pitchFamily="49" charset="0"/>
+                <a:ea typeface="Courier New" pitchFamily="49" charset="-122"/>
+                <a:cs typeface="Courier New" pitchFamily="49" charset="-120"/>
               </a:rPr>
               <a:t>collectstatic</a:t>
             </a:r>
@@ -7071,13 +7073,13 @@
               <a:buNone/>
             </a:pPr>
             <a:r>
-              <a:rPr lang="en-US" sz="1200" dirty="0">
+              <a:rPr lang="en-US" sz="1100" dirty="0">
                 <a:solidFill>
                   <a:srgbClr val="00397B"/>
                 </a:solidFill>
-                <a:latin typeface="Consolas" pitchFamily="34" charset="0"/>
-                <a:ea typeface="Consolas" pitchFamily="34" charset="-122"/>
-                <a:cs typeface="Consolas" pitchFamily="34" charset="-120"/>
+                <a:latin typeface="Courier New" pitchFamily="49" charset="0"/>
+                <a:ea typeface="Courier New" pitchFamily="49" charset="-122"/>
+                <a:cs typeface="Courier New" pitchFamily="49" charset="-120"/>
               </a:rPr>
               <a:t>.env</a:t>
             </a:r>
@@ -7213,7 +7215,7 @@
                   <a:srgbClr val="3A3F44"/>
                 </a:solidFill>
               </a:rPr>
-              <a:t>não é preciso publicar. Mas o projeto precisa subir do zero numa máquina limpa (slide 18).</a:t>
+              <a:t>não é preciso publicar. Mas o projeto precisa subir do zero numa máquina limpa (slide 20).</a:t>
             </a:r>
             <a:endParaRPr lang="en-US" sz="1500" dirty="0"/>
           </a:p>
@@ -8640,38 +8642,38 @@
               <a:buNone/>
             </a:pPr>
             <a:r>
+              <a:rPr lang="en-US" sz="1250" dirty="0">
+                <a:solidFill>
+                  <a:srgbClr val="00397B"/>
+                </a:solidFill>
+                <a:latin typeface="Courier New" pitchFamily="49" charset="0"/>
+                <a:ea typeface="Courier New" pitchFamily="49" charset="-122"/>
+                <a:cs typeface="Courier New" pitchFamily="49" charset="-120"/>
+              </a:rPr>
+              <a:t>nota1</a:t>
+            </a:r>
+            <a:pPr indent="0" marL="0">
+              <a:buNone/>
+            </a:pPr>
+            <a:r>
               <a:rPr lang="en-US" sz="1400" dirty="0">
                 <a:solidFill>
+                  <a:srgbClr val="3A3F44"/>
+                </a:solidFill>
+              </a:rPr>
+              <a:t> fica em </a:t>
+            </a:r>
+            <a:pPr indent="0" marL="0">
+              <a:buNone/>
+            </a:pPr>
+            <a:r>
+              <a:rPr lang="en-US" sz="1250" dirty="0">
+                <a:solidFill>
                   <a:srgbClr val="00397B"/>
                 </a:solidFill>
-                <a:latin typeface="Consolas" pitchFamily="34" charset="0"/>
-                <a:ea typeface="Consolas" pitchFamily="34" charset="-122"/>
-                <a:cs typeface="Consolas" pitchFamily="34" charset="-120"/>
-              </a:rPr>
-              <a:t>nota1</a:t>
-            </a:r>
-            <a:pPr indent="0" marL="0">
-              <a:buNone/>
-            </a:pPr>
-            <a:r>
-              <a:rPr lang="en-US" sz="1400" dirty="0">
-                <a:solidFill>
-                  <a:srgbClr val="3A3F44"/>
-                </a:solidFill>
-              </a:rPr>
-              <a:t> fica em </a:t>
-            </a:r>
-            <a:pPr indent="0" marL="0">
-              <a:buNone/>
-            </a:pPr>
-            <a:r>
-              <a:rPr lang="en-US" sz="1400" dirty="0">
-                <a:solidFill>
-                  <a:srgbClr val="00397B"/>
-                </a:solidFill>
-                <a:latin typeface="Consolas" pitchFamily="34" charset="0"/>
-                <a:ea typeface="Consolas" pitchFamily="34" charset="-122"/>
-                <a:cs typeface="Consolas" pitchFamily="34" charset="-120"/>
+                <a:latin typeface="Courier New" pitchFamily="49" charset="0"/>
+                <a:ea typeface="Courier New" pitchFamily="49" charset="-122"/>
+                <a:cs typeface="Courier New" pitchFamily="49" charset="-120"/>
               </a:rPr>
               <a:t>inscricao</a:t>
             </a:r>
@@ -8814,38 +8816,38 @@
               <a:buNone/>
             </a:pPr>
             <a:r>
+              <a:rPr lang="en-US" sz="1250" dirty="0">
+                <a:solidFill>
+                  <a:srgbClr val="00397B"/>
+                </a:solidFill>
+                <a:latin typeface="Courier New" pitchFamily="49" charset="0"/>
+                <a:ea typeface="Courier New" pitchFamily="49" charset="-122"/>
+                <a:cs typeface="Courier New" pitchFamily="49" charset="-120"/>
+              </a:rPr>
+              <a:t>PROTECT</a:t>
+            </a:r>
+            <a:pPr indent="0" marL="0">
+              <a:buNone/>
+            </a:pPr>
+            <a:r>
               <a:rPr lang="en-US" sz="1400" dirty="0">
                 <a:solidFill>
+                  <a:srgbClr val="3A3F44"/>
+                </a:solidFill>
+              </a:rPr>
+              <a:t>, e não </a:t>
+            </a:r>
+            <a:pPr indent="0" marL="0">
+              <a:buNone/>
+            </a:pPr>
+            <a:r>
+              <a:rPr lang="en-US" sz="1250" dirty="0">
+                <a:solidFill>
                   <a:srgbClr val="00397B"/>
                 </a:solidFill>
-                <a:latin typeface="Consolas" pitchFamily="34" charset="0"/>
-                <a:ea typeface="Consolas" pitchFamily="34" charset="-122"/>
-                <a:cs typeface="Consolas" pitchFamily="34" charset="-120"/>
-              </a:rPr>
-              <a:t>PROTECT</a:t>
-            </a:r>
-            <a:pPr indent="0" marL="0">
-              <a:buNone/>
-            </a:pPr>
-            <a:r>
-              <a:rPr lang="en-US" sz="1400" dirty="0">
-                <a:solidFill>
-                  <a:srgbClr val="3A3F44"/>
-                </a:solidFill>
-              </a:rPr>
-              <a:t>, e não </a:t>
-            </a:r>
-            <a:pPr indent="0" marL="0">
-              <a:buNone/>
-            </a:pPr>
-            <a:r>
-              <a:rPr lang="en-US" sz="1400" dirty="0">
-                <a:solidFill>
-                  <a:srgbClr val="00397B"/>
-                </a:solidFill>
-                <a:latin typeface="Consolas" pitchFamily="34" charset="0"/>
-                <a:ea typeface="Consolas" pitchFamily="34" charset="-122"/>
-                <a:cs typeface="Consolas" pitchFamily="34" charset="-120"/>
+                <a:latin typeface="Courier New" pitchFamily="49" charset="0"/>
+                <a:ea typeface="Courier New" pitchFamily="49" charset="-122"/>
+                <a:cs typeface="Courier New" pitchFamily="49" charset="-120"/>
               </a:rPr>
               <a:t>CASCADE</a:t>
             </a:r>
@@ -9360,13 +9362,13 @@
               <a:buNone/>
             </a:pPr>
             <a:r>
-              <a:rPr lang="en-US" sz="1400" dirty="0">
+              <a:rPr lang="en-US" sz="1250" dirty="0">
                 <a:solidFill>
                   <a:srgbClr val="00397B"/>
                 </a:solidFill>
-                <a:latin typeface="Consolas" pitchFamily="34" charset="0"/>
-                <a:ea typeface="Consolas" pitchFamily="34" charset="-122"/>
-                <a:cs typeface="Consolas" pitchFamily="34" charset="-120"/>
+                <a:latin typeface="Courier New" pitchFamily="49" charset="0"/>
+                <a:ea typeface="Courier New" pitchFamily="49" charset="-122"/>
+                <a:cs typeface="Courier New" pitchFamily="49" charset="-120"/>
               </a:rPr>
               <a:t>select_related</a:t>
             </a:r>
@@ -9669,13 +9671,13 @@
               <a:buNone/>
             </a:pPr>
             <a:r>
-              <a:rPr lang="en-US" sz="1500" i="1" dirty="0">
+              <a:rPr lang="en-US" sz="1350" i="1" dirty="0">
                 <a:solidFill>
                   <a:srgbClr val="1185AA"/>
                 </a:solidFill>
-                <a:latin typeface="Consolas" pitchFamily="34" charset="0"/>
-                <a:ea typeface="Consolas" pitchFamily="34" charset="-122"/>
-                <a:cs typeface="Consolas" pitchFamily="34" charset="-120"/>
+                <a:latin typeface="Courier New" pitchFamily="49" charset="0"/>
+                <a:ea typeface="Courier New" pitchFamily="49" charset="-122"/>
+                <a:cs typeface="Courier New" pitchFamily="49" charset="-120"/>
               </a:rPr>
               <a:t>material/07-tour-do-app-contas.md</a:t>
             </a:r>
@@ -9904,13 +9906,13 @@
                         <a:buNone/>
                       </a:pPr>
                       <a:r>
-                        <a:rPr lang="en-US" sz="1300" dirty="0">
+                        <a:rPr lang="en-US" sz="1150" dirty="0">
                           <a:solidFill>
                             <a:srgbClr val="00397B"/>
                           </a:solidFill>
-                          <a:latin typeface="Consolas" pitchFamily="34" charset="0"/>
-                          <a:ea typeface="Consolas" pitchFamily="34" charset="-122"/>
-                          <a:cs typeface="Consolas" pitchFamily="34" charset="-120"/>
+                          <a:latin typeface="Courier New" pitchFamily="49" charset="0"/>
+                          <a:ea typeface="Courier New" pitchFamily="49" charset="-122"/>
+                          <a:cs typeface="Courier New" pitchFamily="49" charset="-120"/>
                         </a:rPr>
                         <a:t>telefone</a:t>
                       </a:r>
@@ -9967,13 +9969,13 @@
                         <a:buNone/>
                       </a:pPr>
                       <a:r>
-                        <a:rPr lang="en-US" sz="1300" dirty="0">
+                        <a:rPr lang="en-US" sz="1150" dirty="0">
                           <a:solidFill>
                             <a:srgbClr val="00397B"/>
                           </a:solidFill>
-                          <a:latin typeface="Consolas" pitchFamily="34" charset="0"/>
-                          <a:ea typeface="Consolas" pitchFamily="34" charset="-122"/>
-                          <a:cs typeface="Consolas" pitchFamily="34" charset="-120"/>
+                          <a:latin typeface="Courier New" pitchFamily="49" charset="0"/>
+                          <a:ea typeface="Courier New" pitchFamily="49" charset="-122"/>
+                          <a:cs typeface="Courier New" pitchFamily="49" charset="-120"/>
                         </a:rPr>
                         <a:t>models.py</a:t>
                       </a:r>
@@ -9992,13 +9994,13 @@
                         <a:buNone/>
                       </a:pPr>
                       <a:r>
-                        <a:rPr lang="en-US" sz="1300" dirty="0">
+                        <a:rPr lang="en-US" sz="1150" dirty="0">
                           <a:solidFill>
                             <a:srgbClr val="00397B"/>
                           </a:solidFill>
-                          <a:latin typeface="Consolas" pitchFamily="34" charset="0"/>
-                          <a:ea typeface="Consolas" pitchFamily="34" charset="-122"/>
-                          <a:cs typeface="Consolas" pitchFamily="34" charset="-120"/>
+                          <a:latin typeface="Courier New" pitchFamily="49" charset="0"/>
+                          <a:ea typeface="Courier New" pitchFamily="49" charset="-122"/>
+                          <a:cs typeface="Courier New" pitchFamily="49" charset="-120"/>
                         </a:rPr>
                         <a:t>makemigrations</a:t>
                       </a:r>
@@ -10017,13 +10019,13 @@
                         <a:buNone/>
                       </a:pPr>
                       <a:r>
-                        <a:rPr lang="en-US" sz="1300" dirty="0">
+                        <a:rPr lang="en-US" sz="1150" dirty="0">
                           <a:solidFill>
                             <a:srgbClr val="00397B"/>
                           </a:solidFill>
-                          <a:latin typeface="Consolas" pitchFamily="34" charset="0"/>
-                          <a:ea typeface="Consolas" pitchFamily="34" charset="-122"/>
-                          <a:cs typeface="Consolas" pitchFamily="34" charset="-120"/>
+                          <a:latin typeface="Courier New" pitchFamily="49" charset="0"/>
+                          <a:ea typeface="Courier New" pitchFamily="49" charset="-122"/>
+                          <a:cs typeface="Courier New" pitchFamily="49" charset="-120"/>
                         </a:rPr>
                         <a:t>migrate</a:t>
                       </a:r>
@@ -10042,13 +10044,13 @@
                         <a:buNone/>
                       </a:pPr>
                       <a:r>
-                        <a:rPr lang="en-US" sz="1300" dirty="0">
+                        <a:rPr lang="en-US" sz="1150" dirty="0">
                           <a:solidFill>
                             <a:srgbClr val="00397B"/>
                           </a:solidFill>
-                          <a:latin typeface="Consolas" pitchFamily="34" charset="0"/>
-                          <a:ea typeface="Consolas" pitchFamily="34" charset="-122"/>
-                          <a:cs typeface="Consolas" pitchFamily="34" charset="-120"/>
+                          <a:latin typeface="Courier New" pitchFamily="49" charset="0"/>
+                          <a:ea typeface="Courier New" pitchFamily="49" charset="-122"/>
+                          <a:cs typeface="Courier New" pitchFamily="49" charset="-120"/>
                         </a:rPr>
                         <a:t>fields</a:t>
                       </a:r>
@@ -10067,13 +10069,13 @@
                         <a:buNone/>
                       </a:pPr>
                       <a:r>
-                        <a:rPr lang="en-US" sz="1300" dirty="0">
+                        <a:rPr lang="en-US" sz="1150" dirty="0">
                           <a:solidFill>
                             <a:srgbClr val="00397B"/>
                           </a:solidFill>
-                          <a:latin typeface="Consolas" pitchFamily="34" charset="0"/>
-                          <a:ea typeface="Consolas" pitchFamily="34" charset="-122"/>
-                          <a:cs typeface="Consolas" pitchFamily="34" charset="-120"/>
+                          <a:latin typeface="Courier New" pitchFamily="49" charset="0"/>
+                          <a:ea typeface="Courier New" pitchFamily="49" charset="-122"/>
+                          <a:cs typeface="Courier New" pitchFamily="49" charset="-120"/>
                         </a:rPr>
                         <a:t>AlunoForm</a:t>
                       </a:r>
@@ -10170,13 +10172,13 @@
                         <a:buNone/>
                       </a:pPr>
                       <a:r>
-                        <a:rPr lang="en-US" sz="1300" dirty="0">
+                        <a:rPr lang="en-US" sz="1150" dirty="0">
                           <a:solidFill>
                             <a:srgbClr val="00397B"/>
                           </a:solidFill>
-                          <a:latin typeface="Consolas" pitchFamily="34" charset="0"/>
-                          <a:ea typeface="Consolas" pitchFamily="34" charset="-122"/>
-                          <a:cs typeface="Consolas" pitchFamily="34" charset="-120"/>
+                          <a:latin typeface="Courier New" pitchFamily="49" charset="0"/>
+                          <a:ea typeface="Courier New" pitchFamily="49" charset="-122"/>
+                          <a:cs typeface="Courier New" pitchFamily="49" charset="-120"/>
                         </a:rPr>
                         <a:t>views.py</a:t>
                       </a:r>
@@ -10195,13 +10197,13 @@
                         <a:buNone/>
                       </a:pPr>
                       <a:r>
-                        <a:rPr lang="en-US" sz="1300" dirty="0">
+                        <a:rPr lang="en-US" sz="1150" dirty="0">
                           <a:solidFill>
                             <a:srgbClr val="00397B"/>
                           </a:solidFill>
-                          <a:latin typeface="Consolas" pitchFamily="34" charset="0"/>
-                          <a:ea typeface="Consolas" pitchFamily="34" charset="-122"/>
-                          <a:cs typeface="Consolas" pitchFamily="34" charset="-120"/>
+                          <a:latin typeface="Courier New" pitchFamily="49" charset="0"/>
+                          <a:ea typeface="Courier New" pitchFamily="49" charset="-122"/>
+                          <a:cs typeface="Courier New" pitchFamily="49" charset="-120"/>
                         </a:rPr>
                         <a:t>Aluno.objects.filter(ativo=True)</a:t>
                       </a:r>
@@ -10298,13 +10300,13 @@
                         <a:buNone/>
                       </a:pPr>
                       <a:r>
-                        <a:rPr lang="en-US" sz="1300" dirty="0">
+                        <a:rPr lang="en-US" sz="1150" dirty="0">
                           <a:solidFill>
                             <a:srgbClr val="00397B"/>
                           </a:solidFill>
-                          <a:latin typeface="Consolas" pitchFamily="34" charset="0"/>
-                          <a:ea typeface="Consolas" pitchFamily="34" charset="-122"/>
-                          <a:cs typeface="Consolas" pitchFamily="34" charset="-120"/>
+                          <a:latin typeface="Courier New" pitchFamily="49" charset="0"/>
+                          <a:ea typeface="Courier New" pitchFamily="49" charset="-122"/>
+                          <a:cs typeface="Courier New" pitchFamily="49" charset="-120"/>
                         </a:rPr>
                         <a:t>ordering</a:t>
                       </a:r>
@@ -10323,13 +10325,13 @@
                         <a:buNone/>
                       </a:pPr>
                       <a:r>
-                        <a:rPr lang="en-US" sz="1300" dirty="0">
+                        <a:rPr lang="en-US" sz="1150" dirty="0">
                           <a:solidFill>
                             <a:srgbClr val="00397B"/>
                           </a:solidFill>
-                          <a:latin typeface="Consolas" pitchFamily="34" charset="0"/>
-                          <a:ea typeface="Consolas" pitchFamily="34" charset="-122"/>
-                          <a:cs typeface="Consolas" pitchFamily="34" charset="-120"/>
+                          <a:latin typeface="Courier New" pitchFamily="49" charset="0"/>
+                          <a:ea typeface="Courier New" pitchFamily="49" charset="-122"/>
+                          <a:cs typeface="Courier New" pitchFamily="49" charset="-120"/>
                         </a:rPr>
                         <a:t>Meta</a:t>
                       </a:r>
@@ -10348,13 +10350,13 @@
                         <a:buNone/>
                       </a:pPr>
                       <a:r>
-                        <a:rPr lang="en-US" sz="1300" dirty="0">
+                        <a:rPr lang="en-US" sz="1150" dirty="0">
                           <a:solidFill>
                             <a:srgbClr val="00397B"/>
                           </a:solidFill>
-                          <a:latin typeface="Consolas" pitchFamily="34" charset="0"/>
-                          <a:ea typeface="Consolas" pitchFamily="34" charset="-122"/>
-                          <a:cs typeface="Consolas" pitchFamily="34" charset="-120"/>
+                          <a:latin typeface="Courier New" pitchFamily="49" charset="0"/>
+                          <a:ea typeface="Courier New" pitchFamily="49" charset="-122"/>
+                          <a:cs typeface="Courier New" pitchFamily="49" charset="-120"/>
                         </a:rPr>
                         <a:t>makemigrations</a:t>
                       </a:r>
@@ -10462,13 +10464,13 @@
                         <a:buNone/>
                       </a:pPr>
                       <a:r>
-                        <a:rPr lang="en-US" sz="1300" dirty="0">
+                        <a:rPr lang="en-US" sz="1150" dirty="0">
                           <a:solidFill>
                             <a:srgbClr val="00397B"/>
                           </a:solidFill>
-                          <a:latin typeface="Consolas" pitchFamily="34" charset="0"/>
-                          <a:ea typeface="Consolas" pitchFamily="34" charset="-122"/>
-                          <a:cs typeface="Consolas" pitchFamily="34" charset="-120"/>
+                          <a:latin typeface="Courier New" pitchFamily="49" charset="0"/>
+                          <a:ea typeface="Courier New" pitchFamily="49" charset="-122"/>
+                          <a:cs typeface="Courier New" pitchFamily="49" charset="-120"/>
                         </a:rPr>
                         <a:t>{{ i.media }}</a:t>
                       </a:r>
@@ -10565,13 +10567,13 @@
                         <a:buNone/>
                       </a:pPr>
                       <a:r>
-                        <a:rPr lang="en-US" sz="1300" dirty="0">
+                        <a:rPr lang="en-US" sz="1150" dirty="0">
                           <a:solidFill>
                             <a:srgbClr val="00397B"/>
                           </a:solidFill>
-                          <a:latin typeface="Consolas" pitchFamily="34" charset="0"/>
-                          <a:ea typeface="Consolas" pitchFamily="34" charset="-122"/>
-                          <a:cs typeface="Consolas" pitchFamily="34" charset="-120"/>
+                          <a:latin typeface="Courier New" pitchFamily="49" charset="0"/>
+                          <a:ea typeface="Courier New" pitchFamily="49" charset="-122"/>
+                          <a:cs typeface="Courier New" pitchFamily="49" charset="-120"/>
                         </a:rPr>
                         <a:t>error_messages</a:t>
                       </a:r>
@@ -10590,13 +10592,13 @@
                         <a:buNone/>
                       </a:pPr>
                       <a:r>
-                        <a:rPr lang="en-US" sz="1300" dirty="0">
+                        <a:rPr lang="en-US" sz="1150" dirty="0">
                           <a:solidFill>
                             <a:srgbClr val="00397B"/>
                           </a:solidFill>
-                          <a:latin typeface="Consolas" pitchFamily="34" charset="0"/>
-                          <a:ea typeface="Consolas" pitchFamily="34" charset="-122"/>
-                          <a:cs typeface="Consolas" pitchFamily="34" charset="-120"/>
+                          <a:latin typeface="Courier New" pitchFamily="49" charset="0"/>
+                          <a:ea typeface="Courier New" pitchFamily="49" charset="-122"/>
+                          <a:cs typeface="Courier New" pitchFamily="49" charset="-120"/>
                         </a:rPr>
                         <a:t>InscricaoForm</a:t>
                       </a:r>
@@ -10885,13 +10887,13 @@
               <a:buNone/>
             </a:pPr>
             <a:r>
-              <a:rPr lang="en-US" sz="1400" dirty="0">
+              <a:rPr lang="en-US" sz="1250" dirty="0">
                 <a:solidFill>
                   <a:srgbClr val="00397B"/>
                 </a:solidFill>
-                <a:latin typeface="Consolas" pitchFamily="34" charset="0"/>
-                <a:ea typeface="Consolas" pitchFamily="34" charset="-122"/>
-                <a:cs typeface="Consolas" pitchFamily="34" charset="-120"/>
+                <a:latin typeface="Courier New" pitchFamily="49" charset="0"/>
+                <a:ea typeface="Courier New" pitchFamily="49" charset="-122"/>
+                <a:cs typeface="Courier New" pitchFamily="49" charset="-120"/>
               </a:rPr>
               <a:t>migrations/</a:t>
             </a:r>
@@ -10924,13 +10926,13 @@
               <a:buNone/>
             </a:pPr>
             <a:r>
-              <a:rPr lang="en-US" sz="1400" dirty="0">
+              <a:rPr lang="en-US" sz="1250" dirty="0">
                 <a:solidFill>
                   <a:srgbClr val="00397B"/>
                 </a:solidFill>
-                <a:latin typeface="Consolas" pitchFamily="34" charset="0"/>
-                <a:ea typeface="Consolas" pitchFamily="34" charset="-122"/>
-                <a:cs typeface="Consolas" pitchFamily="34" charset="-120"/>
+                <a:latin typeface="Courier New" pitchFamily="49" charset="0"/>
+                <a:ea typeface="Courier New" pitchFamily="49" charset="-122"/>
+                <a:cs typeface="Courier New" pitchFamily="49" charset="-120"/>
               </a:rPr>
               <a:t>README.md</a:t>
             </a:r>
@@ -10967,7 +10969,7 @@
           <a:ln/>
         </p:spPr>
         <p:txBody>
-          <a:bodyPr wrap="square" lIns="0" tIns="0" rIns="0" bIns="0" rtlCol="0" anchor="ctr"/>
+          <a:bodyPr wrap="none" lIns="0" tIns="0" rIns="0" bIns="0" rtlCol="0" anchor="ctr"/>
           <a:lstStyle/>
           <a:p>
             <a:pPr indent="0" marL="0">
@@ -10978,9 +10980,9 @@
                 <a:solidFill>
                   <a:srgbClr val="00397B"/>
                 </a:solidFill>
-                <a:latin typeface="Consolas" pitchFamily="34" charset="0"/>
-                <a:ea typeface="Consolas" pitchFamily="34" charset="-122"/>
-                <a:cs typeface="Consolas" pitchFamily="34" charset="-120"/>
+                <a:latin typeface="Courier New" pitchFamily="49" charset="0"/>
+                <a:ea typeface="Courier New" pitchFamily="49" charset="-122"/>
+                <a:cs typeface="Courier New" pitchFamily="49" charset="-120"/>
               </a:rPr>
               <a:t>modelo_dados.png</a:t>
             </a:r>
@@ -11006,7 +11008,7 @@
           <a:ln/>
         </p:spPr>
         <p:txBody>
-          <a:bodyPr wrap="square" lIns="0" tIns="0" rIns="0" bIns="0" rtlCol="0" anchor="ctr"/>
+          <a:bodyPr wrap="none" lIns="0" tIns="0" rIns="0" bIns="0" rtlCol="0" anchor="ctr"/>
           <a:lstStyle/>
           <a:p>
             <a:pPr indent="0" marL="0">
@@ -11017,9 +11019,9 @@
                 <a:solidFill>
                   <a:srgbClr val="00397B"/>
                 </a:solidFill>
-                <a:latin typeface="Consolas" pitchFamily="34" charset="0"/>
-                <a:ea typeface="Consolas" pitchFamily="34" charset="-122"/>
-                <a:cs typeface="Consolas" pitchFamily="34" charset="-120"/>
+                <a:latin typeface="Courier New" pitchFamily="49" charset="0"/>
+                <a:ea typeface="Courier New" pitchFamily="49" charset="-122"/>
+                <a:cs typeface="Courier New" pitchFamily="49" charset="-120"/>
               </a:rPr>
               <a:t>requirements.txt</a:t>
             </a:r>
@@ -11157,7 +11159,7 @@
           <a:ln/>
         </p:spPr>
         <p:txBody>
-          <a:bodyPr wrap="square" lIns="0" tIns="0" rIns="0" bIns="0" rtlCol="0" anchor="ctr"/>
+          <a:bodyPr wrap="none" lIns="0" tIns="0" rIns="0" bIns="0" rtlCol="0" anchor="ctr"/>
           <a:lstStyle/>
           <a:p>
             <a:pPr indent="0" marL="0">
@@ -11168,9 +11170,9 @@
                 <a:solidFill>
                   <a:srgbClr val="00397B"/>
                 </a:solidFill>
-                <a:latin typeface="Consolas" pitchFamily="34" charset="0"/>
-                <a:ea typeface="Consolas" pitchFamily="34" charset="-122"/>
-                <a:cs typeface="Consolas" pitchFamily="34" charset="-120"/>
+                <a:latin typeface="Courier New" pitchFamily="49" charset="0"/>
+                <a:ea typeface="Courier New" pitchFamily="49" charset="-122"/>
+                <a:cs typeface="Courier New" pitchFamily="49" charset="-120"/>
               </a:rPr>
               <a:t>escola.sqlite3</a:t>
             </a:r>
@@ -11196,7 +11198,7 @@
           <a:ln/>
         </p:spPr>
         <p:txBody>
-          <a:bodyPr wrap="square" lIns="0" tIns="0" rIns="0" bIns="0" rtlCol="0" anchor="ctr"/>
+          <a:bodyPr wrap="none" lIns="0" tIns="0" rIns="0" bIns="0" rtlCol="0" anchor="ctr"/>
           <a:lstStyle/>
           <a:p>
             <a:pPr indent="0" marL="0">
@@ -11207,9 +11209,9 @@
                 <a:solidFill>
                   <a:srgbClr val="00397B"/>
                 </a:solidFill>
-                <a:latin typeface="Consolas" pitchFamily="34" charset="0"/>
-                <a:ea typeface="Consolas" pitchFamily="34" charset="-122"/>
-                <a:cs typeface="Consolas" pitchFamily="34" charset="-120"/>
+                <a:latin typeface="Courier New" pitchFamily="49" charset="0"/>
+                <a:ea typeface="Courier New" pitchFamily="49" charset="-122"/>
+                <a:cs typeface="Courier New" pitchFamily="49" charset="-120"/>
               </a:rPr>
               <a:t>.venv/</a:t>
             </a:r>
@@ -11235,7 +11237,7 @@
           <a:ln/>
         </p:spPr>
         <p:txBody>
-          <a:bodyPr wrap="square" lIns="0" tIns="0" rIns="0" bIns="0" rtlCol="0" anchor="ctr"/>
+          <a:bodyPr wrap="none" lIns="0" tIns="0" rIns="0" bIns="0" rtlCol="0" anchor="ctr"/>
           <a:lstStyle/>
           <a:p>
             <a:pPr indent="0" marL="0">
@@ -11246,9 +11248,9 @@
                 <a:solidFill>
                   <a:srgbClr val="00397B"/>
                 </a:solidFill>
-                <a:latin typeface="Consolas" pitchFamily="34" charset="0"/>
-                <a:ea typeface="Consolas" pitchFamily="34" charset="-122"/>
-                <a:cs typeface="Consolas" pitchFamily="34" charset="-120"/>
+                <a:latin typeface="Courier New" pitchFamily="49" charset="0"/>
+                <a:ea typeface="Courier New" pitchFamily="49" charset="-122"/>
+                <a:cs typeface="Courier New" pitchFamily="49" charset="-120"/>
               </a:rPr>
               <a:t>__pycache__/</a:t>
             </a:r>
@@ -11274,7 +11276,7 @@
           <a:ln/>
         </p:spPr>
         <p:txBody>
-          <a:bodyPr wrap="square" lIns="0" tIns="0" rIns="0" bIns="0" rtlCol="0" anchor="ctr"/>
+          <a:bodyPr wrap="none" lIns="0" tIns="0" rIns="0" bIns="0" rtlCol="0" anchor="ctr"/>
           <a:lstStyle/>
           <a:p>
             <a:pPr indent="0" marL="0">
@@ -11285,9 +11287,9 @@
                 <a:solidFill>
                   <a:srgbClr val="00397B"/>
                 </a:solidFill>
-                <a:latin typeface="Consolas" pitchFamily="34" charset="0"/>
-                <a:ea typeface="Consolas" pitchFamily="34" charset="-122"/>
-                <a:cs typeface="Consolas" pitchFamily="34" charset="-120"/>
+                <a:latin typeface="Courier New" pitchFamily="49" charset="0"/>
+                <a:ea typeface="Courier New" pitchFamily="49" charset="-122"/>
+                <a:cs typeface="Courier New" pitchFamily="49" charset="-120"/>
               </a:rPr>
               <a:t>.env</a:t>
             </a:r>
@@ -11601,7 +11603,7 @@
           <a:ln/>
         </p:spPr>
         <p:txBody>
-          <a:bodyPr wrap="square" lIns="0" tIns="0" rIns="0" bIns="0" rtlCol="0" anchor="ctr"/>
+          <a:bodyPr wrap="none" lIns="0" tIns="0" rIns="0" bIns="0" rtlCol="0" anchor="ctr"/>
           <a:lstStyle/>
           <a:p>
             <a:pPr indent="0" marL="0">
@@ -11612,9 +11614,9 @@
                 <a:solidFill>
                   <a:srgbClr val="8B949E"/>
                 </a:solidFill>
-                <a:latin typeface="Consolas" pitchFamily="34" charset="0"/>
-                <a:ea typeface="Consolas" pitchFamily="34" charset="-122"/>
-                <a:cs typeface="Consolas" pitchFamily="34" charset="-120"/>
+                <a:latin typeface="Courier New" pitchFamily="49" charset="0"/>
+                <a:ea typeface="Courier New" pitchFamily="49" charset="-122"/>
+                <a:cs typeface="Courier New" pitchFamily="49" charset="-120"/>
               </a:rPr>
               <a:t>PowerShell, numa pasta nova</a:t>
             </a:r>
@@ -11640,7 +11642,7 @@
           <a:ln/>
         </p:spPr>
         <p:txBody>
-          <a:bodyPr wrap="square" lIns="0" tIns="0" rIns="0" bIns="0" rtlCol="0" anchor="t"/>
+          <a:bodyPr wrap="none" lIns="0" tIns="0" rIns="0" bIns="0" rtlCol="0" anchor="t"/>
           <a:lstStyle/>
           <a:p>
             <a:pPr indent="0" marL="0">
@@ -11651,9 +11653,9 @@
                 <a:solidFill>
                   <a:srgbClr val="8B949E"/>
                 </a:solidFill>
-                <a:latin typeface="Consolas" pitchFamily="34" charset="0"/>
-                <a:ea typeface="Consolas" pitchFamily="34" charset="-122"/>
-                <a:cs typeface="Consolas" pitchFamily="34" charset="-120"/>
+                <a:latin typeface="Courier New" pitchFamily="49" charset="0"/>
+                <a:ea typeface="Courier New" pitchFamily="49" charset="-122"/>
+                <a:cs typeface="Courier New" pitchFamily="49" charset="-120"/>
               </a:rPr>
               <a:t># descompacte o zip da entrega aqui</a:t>
             </a:r>
@@ -11668,9 +11670,9 @@
                 <a:solidFill>
                   <a:srgbClr val="7DCFFF"/>
                 </a:solidFill>
-                <a:latin typeface="Consolas" pitchFamily="34" charset="0"/>
-                <a:ea typeface="Consolas" pitchFamily="34" charset="-122"/>
-                <a:cs typeface="Consolas" pitchFamily="34" charset="-120"/>
+                <a:latin typeface="Courier New" pitchFamily="49" charset="0"/>
+                <a:ea typeface="Courier New" pitchFamily="49" charset="-122"/>
+                <a:cs typeface="Courier New" pitchFamily="49" charset="-120"/>
               </a:rPr>
               <a:t>python</a:t>
             </a:r>
@@ -11682,9 +11684,9 @@
                 <a:solidFill>
                   <a:srgbClr val="E6EDF3"/>
                 </a:solidFill>
-                <a:latin typeface="Consolas" pitchFamily="34" charset="0"/>
-                <a:ea typeface="Consolas" pitchFamily="34" charset="-122"/>
-                <a:cs typeface="Consolas" pitchFamily="34" charset="-120"/>
+                <a:latin typeface="Courier New" pitchFamily="49" charset="0"/>
+                <a:ea typeface="Courier New" pitchFamily="49" charset="-122"/>
+                <a:cs typeface="Courier New" pitchFamily="49" charset="-120"/>
               </a:rPr>
               <a:t> -m venv .venv</a:t>
             </a:r>
@@ -11699,9 +11701,9 @@
                 <a:solidFill>
                   <a:srgbClr val="7DCFFF"/>
                 </a:solidFill>
-                <a:latin typeface="Consolas" pitchFamily="34" charset="0"/>
-                <a:ea typeface="Consolas" pitchFamily="34" charset="-122"/>
-                <a:cs typeface="Consolas" pitchFamily="34" charset="-120"/>
+                <a:latin typeface="Courier New" pitchFamily="49" charset="0"/>
+                <a:ea typeface="Courier New" pitchFamily="49" charset="-122"/>
+                <a:cs typeface="Courier New" pitchFamily="49" charset="-120"/>
               </a:rPr>
               <a:t>.venv\Scripts\activate</a:t>
             </a:r>
@@ -11716,9 +11718,9 @@
                 <a:solidFill>
                   <a:srgbClr val="7DCFFF"/>
                 </a:solidFill>
-                <a:latin typeface="Consolas" pitchFamily="34" charset="0"/>
-                <a:ea typeface="Consolas" pitchFamily="34" charset="-122"/>
-                <a:cs typeface="Consolas" pitchFamily="34" charset="-120"/>
+                <a:latin typeface="Courier New" pitchFamily="49" charset="0"/>
+                <a:ea typeface="Courier New" pitchFamily="49" charset="-122"/>
+                <a:cs typeface="Courier New" pitchFamily="49" charset="-120"/>
               </a:rPr>
               <a:t>pip</a:t>
             </a:r>
@@ -11730,9 +11732,9 @@
                 <a:solidFill>
                   <a:srgbClr val="E6EDF3"/>
                 </a:solidFill>
-                <a:latin typeface="Consolas" pitchFamily="34" charset="0"/>
-                <a:ea typeface="Consolas" pitchFamily="34" charset="-122"/>
-                <a:cs typeface="Consolas" pitchFamily="34" charset="-120"/>
+                <a:latin typeface="Courier New" pitchFamily="49" charset="0"/>
+                <a:ea typeface="Courier New" pitchFamily="49" charset="-122"/>
+                <a:cs typeface="Courier New" pitchFamily="49" charset="-120"/>
               </a:rPr>
               <a:t> install -r requirements.txt</a:t>
             </a:r>
@@ -11747,9 +11749,9 @@
                 <a:solidFill>
                   <a:srgbClr val="7DCFFF"/>
                 </a:solidFill>
-                <a:latin typeface="Consolas" pitchFamily="34" charset="0"/>
-                <a:ea typeface="Consolas" pitchFamily="34" charset="-122"/>
-                <a:cs typeface="Consolas" pitchFamily="34" charset="-120"/>
+                <a:latin typeface="Courier New" pitchFamily="49" charset="0"/>
+                <a:ea typeface="Courier New" pitchFamily="49" charset="-122"/>
+                <a:cs typeface="Courier New" pitchFamily="49" charset="-120"/>
               </a:rPr>
               <a:t>python</a:t>
             </a:r>
@@ -11761,9 +11763,9 @@
                 <a:solidFill>
                   <a:srgbClr val="E6EDF3"/>
                 </a:solidFill>
-                <a:latin typeface="Consolas" pitchFamily="34" charset="0"/>
-                <a:ea typeface="Consolas" pitchFamily="34" charset="-122"/>
-                <a:cs typeface="Consolas" pitchFamily="34" charset="-120"/>
+                <a:latin typeface="Courier New" pitchFamily="49" charset="0"/>
+                <a:ea typeface="Courier New" pitchFamily="49" charset="-122"/>
+                <a:cs typeface="Courier New" pitchFamily="49" charset="-120"/>
               </a:rPr>
               <a:t> manage.py migrate</a:t>
             </a:r>
@@ -11778,9 +11780,9 @@
                 <a:solidFill>
                   <a:srgbClr val="7DCFFF"/>
                 </a:solidFill>
-                <a:latin typeface="Consolas" pitchFamily="34" charset="0"/>
-                <a:ea typeface="Consolas" pitchFamily="34" charset="-122"/>
-                <a:cs typeface="Consolas" pitchFamily="34" charset="-120"/>
+                <a:latin typeface="Courier New" pitchFamily="49" charset="0"/>
+                <a:ea typeface="Courier New" pitchFamily="49" charset="-122"/>
+                <a:cs typeface="Courier New" pitchFamily="49" charset="-120"/>
               </a:rPr>
               <a:t>python</a:t>
             </a:r>
@@ -11792,9 +11794,9 @@
                 <a:solidFill>
                   <a:srgbClr val="E6EDF3"/>
                 </a:solidFill>
-                <a:latin typeface="Consolas" pitchFamily="34" charset="0"/>
-                <a:ea typeface="Consolas" pitchFamily="34" charset="-122"/>
-                <a:cs typeface="Consolas" pitchFamily="34" charset="-120"/>
+                <a:latin typeface="Courier New" pitchFamily="49" charset="0"/>
+                <a:ea typeface="Courier New" pitchFamily="49" charset="-122"/>
+                <a:cs typeface="Courier New" pitchFamily="49" charset="-120"/>
               </a:rPr>
               <a:t> manage.py seed_demo</a:t>
             </a:r>
@@ -11809,9 +11811,9 @@
                 <a:solidFill>
                   <a:srgbClr val="7DCFFF"/>
                 </a:solidFill>
-                <a:latin typeface="Consolas" pitchFamily="34" charset="0"/>
-                <a:ea typeface="Consolas" pitchFamily="34" charset="-122"/>
-                <a:cs typeface="Consolas" pitchFamily="34" charset="-120"/>
+                <a:latin typeface="Courier New" pitchFamily="49" charset="0"/>
+                <a:ea typeface="Courier New" pitchFamily="49" charset="-122"/>
+                <a:cs typeface="Courier New" pitchFamily="49" charset="-120"/>
               </a:rPr>
               <a:t>python</a:t>
             </a:r>
@@ -11823,9 +11825,9 @@
                 <a:solidFill>
                   <a:srgbClr val="E6EDF3"/>
                 </a:solidFill>
-                <a:latin typeface="Consolas" pitchFamily="34" charset="0"/>
-                <a:ea typeface="Consolas" pitchFamily="34" charset="-122"/>
-                <a:cs typeface="Consolas" pitchFamily="34" charset="-120"/>
+                <a:latin typeface="Courier New" pitchFamily="49" charset="0"/>
+                <a:ea typeface="Courier New" pitchFamily="49" charset="-122"/>
+                <a:cs typeface="Courier New" pitchFamily="49" charset="-120"/>
               </a:rPr>
               <a:t> verificar.py        </a:t>
             </a:r>
@@ -11837,9 +11839,9 @@
                 <a:solidFill>
                   <a:srgbClr val="8B949E"/>
                 </a:solidFill>
-                <a:latin typeface="Consolas" pitchFamily="34" charset="0"/>
-                <a:ea typeface="Consolas" pitchFamily="34" charset="-122"/>
-                <a:cs typeface="Consolas" pitchFamily="34" charset="-120"/>
+                <a:latin typeface="Courier New" pitchFamily="49" charset="0"/>
+                <a:ea typeface="Courier New" pitchFamily="49" charset="-122"/>
+                <a:cs typeface="Courier New" pitchFamily="49" charset="-120"/>
               </a:rPr>
               <a:t>  # 0 FALHA</a:t>
             </a:r>
@@ -11854,9 +11856,9 @@
                 <a:solidFill>
                   <a:srgbClr val="7DCFFF"/>
                 </a:solidFill>
-                <a:latin typeface="Consolas" pitchFamily="34" charset="0"/>
-                <a:ea typeface="Consolas" pitchFamily="34" charset="-122"/>
-                <a:cs typeface="Consolas" pitchFamily="34" charset="-120"/>
+                <a:latin typeface="Courier New" pitchFamily="49" charset="0"/>
+                <a:ea typeface="Courier New" pitchFamily="49" charset="-122"/>
+                <a:cs typeface="Courier New" pitchFamily="49" charset="-120"/>
               </a:rPr>
               <a:t>python</a:t>
             </a:r>
@@ -11868,9 +11870,9 @@
                 <a:solidFill>
                   <a:srgbClr val="E6EDF3"/>
                 </a:solidFill>
-                <a:latin typeface="Consolas" pitchFamily="34" charset="0"/>
-                <a:ea typeface="Consolas" pitchFamily="34" charset="-122"/>
-                <a:cs typeface="Consolas" pitchFamily="34" charset="-120"/>
+                <a:latin typeface="Courier New" pitchFamily="49" charset="0"/>
+                <a:ea typeface="Courier New" pitchFamily="49" charset="-122"/>
+                <a:cs typeface="Courier New" pitchFamily="49" charset="-120"/>
               </a:rPr>
               <a:t> manage.py runserver</a:t>
             </a:r>
@@ -13709,7 +13711,7 @@
           <a:ln/>
         </p:spPr>
         <p:txBody>
-          <a:bodyPr wrap="square" lIns="0" tIns="0" rIns="0" bIns="0" rtlCol="0" anchor="ctr"/>
+          <a:bodyPr wrap="none" lIns="0" tIns="0" rIns="0" bIns="0" rtlCol="0" anchor="ctr"/>
           <a:lstStyle/>
           <a:p>
             <a:pPr indent="0" marL="0">
@@ -13720,9 +13722,9 @@
                 <a:solidFill>
                   <a:srgbClr val="8B949E"/>
                 </a:solidFill>
-                <a:latin typeface="Consolas" pitchFamily="34" charset="0"/>
-                <a:ea typeface="Consolas" pitchFamily="34" charset="-122"/>
-                <a:cs typeface="Consolas" pitchFamily="34" charset="-120"/>
+                <a:latin typeface="Courier New" pitchFamily="49" charset="0"/>
+                <a:ea typeface="Courier New" pitchFamily="49" charset="-122"/>
+                <a:cs typeface="Courier New" pitchFamily="49" charset="-120"/>
               </a:rPr>
               <a:t>terminal</a:t>
             </a:r>
@@ -13748,7 +13750,7 @@
           <a:ln/>
         </p:spPr>
         <p:txBody>
-          <a:bodyPr wrap="square" lIns="0" tIns="0" rIns="0" bIns="0" rtlCol="0" anchor="t"/>
+          <a:bodyPr wrap="none" lIns="0" tIns="0" rIns="0" bIns="0" rtlCol="0" anchor="t"/>
           <a:lstStyle/>
           <a:p>
             <a:pPr indent="0" marL="0">
@@ -13759,9 +13761,9 @@
                 <a:solidFill>
                   <a:srgbClr val="E6EDF3"/>
                 </a:solidFill>
-                <a:latin typeface="Consolas" pitchFamily="34" charset="0"/>
-                <a:ea typeface="Consolas" pitchFamily="34" charset="-122"/>
-                <a:cs typeface="Consolas" pitchFamily="34" charset="-120"/>
+                <a:latin typeface="Courier New" pitchFamily="49" charset="0"/>
+                <a:ea typeface="Courier New" pitchFamily="49" charset="-122"/>
+                <a:cs typeface="Courier New" pitchFamily="49" charset="-120"/>
               </a:rPr>
               <a:t>python manage.py runserver</a:t>
             </a:r>
@@ -13776,9 +13778,9 @@
                 <a:solidFill>
                   <a:srgbClr val="E6EDF3"/>
                 </a:solidFill>
-                <a:latin typeface="Consolas" pitchFamily="34" charset="0"/>
-                <a:ea typeface="Consolas" pitchFamily="34" charset="-122"/>
-                <a:cs typeface="Consolas" pitchFamily="34" charset="-120"/>
+                <a:latin typeface="Courier New" pitchFamily="49" charset="0"/>
+                <a:ea typeface="Courier New" pitchFamily="49" charset="-122"/>
+                <a:cs typeface="Courier New" pitchFamily="49" charset="-120"/>
               </a:rPr>
               <a:t>python verificar.py</a:t>
             </a:r>
@@ -14386,7 +14388,7 @@
                   <a:srgbClr val="3A3F44"/>
                 </a:solidFill>
               </a:rPr>
-              <a:t>O grupo arguidor escolhe um pedido do slide 16.</a:t>
+              <a:t>O grupo arguidor escolhe um pedido do slide 18.</a:t>
             </a:r>
             <a:endParaRPr lang="en-US" sz="1300" dirty="0"/>
           </a:p>
@@ -15188,7 +15190,7 @@
                   <a:srgbClr val="3A3F44"/>
                 </a:solidFill>
               </a:rPr>
-              <a:t>Do próprio zip, numa pasta nova, com os comandos do slide 18.</a:t>
+              <a:t>Do próprio zip, numa pasta nova, com os comandos do slide 20.</a:t>
             </a:r>
             <a:endParaRPr lang="en-US" sz="1300" dirty="0"/>
           </a:p>
@@ -15354,38 +15356,38 @@
               <a:buNone/>
             </a:pPr>
             <a:r>
+              <a:rPr lang="en-US" sz="1150" dirty="0">
+                <a:solidFill>
+                  <a:srgbClr val="00397B"/>
+                </a:solidFill>
+                <a:latin typeface="Courier New" pitchFamily="49" charset="0"/>
+                <a:ea typeface="Courier New" pitchFamily="49" charset="-122"/>
+                <a:cs typeface="Courier New" pitchFamily="49" charset="-120"/>
+              </a:rPr>
+              <a:t>.venv</a:t>
+            </a:r>
+            <a:pPr indent="0" marL="0">
+              <a:buNone/>
+            </a:pPr>
+            <a:r>
               <a:rPr lang="en-US" sz="1300" dirty="0">
                 <a:solidFill>
+                  <a:srgbClr val="3A3F44"/>
+                </a:solidFill>
+              </a:rPr>
+              <a:t> e </a:t>
+            </a:r>
+            <a:pPr indent="0" marL="0">
+              <a:buNone/>
+            </a:pPr>
+            <a:r>
+              <a:rPr lang="en-US" sz="1150" dirty="0">
+                <a:solidFill>
                   <a:srgbClr val="00397B"/>
                 </a:solidFill>
-                <a:latin typeface="Consolas" pitchFamily="34" charset="0"/>
-                <a:ea typeface="Consolas" pitchFamily="34" charset="-122"/>
-                <a:cs typeface="Consolas" pitchFamily="34" charset="-120"/>
-              </a:rPr>
-              <a:t>.venv</a:t>
-            </a:r>
-            <a:pPr indent="0" marL="0">
-              <a:buNone/>
-            </a:pPr>
-            <a:r>
-              <a:rPr lang="en-US" sz="1300" dirty="0">
-                <a:solidFill>
-                  <a:srgbClr val="3A3F44"/>
-                </a:solidFill>
-              </a:rPr>
-              <a:t> e </a:t>
-            </a:r>
-            <a:pPr indent="0" marL="0">
-              <a:buNone/>
-            </a:pPr>
-            <a:r>
-              <a:rPr lang="en-US" sz="1300" dirty="0">
-                <a:solidFill>
-                  <a:srgbClr val="00397B"/>
-                </a:solidFill>
-                <a:latin typeface="Consolas" pitchFamily="34" charset="0"/>
-                <a:ea typeface="Consolas" pitchFamily="34" charset="-122"/>
-                <a:cs typeface="Consolas" pitchFamily="34" charset="-120"/>
+                <a:latin typeface="Courier New" pitchFamily="49" charset="0"/>
+                <a:ea typeface="Courier New" pitchFamily="49" charset="-122"/>
+                <a:cs typeface="Courier New" pitchFamily="49" charset="-120"/>
               </a:rPr>
               <a:t>__pycache__</a:t>
             </a:r>
@@ -15564,13 +15566,13 @@
               <a:buNone/>
             </a:pPr>
             <a:r>
-              <a:rPr lang="en-US" sz="1300" dirty="0">
+              <a:rPr lang="en-US" sz="1150" dirty="0">
                 <a:solidFill>
                   <a:srgbClr val="00397B"/>
                 </a:solidFill>
-                <a:latin typeface="Consolas" pitchFamily="34" charset="0"/>
-                <a:ea typeface="Consolas" pitchFamily="34" charset="-122"/>
-                <a:cs typeface="Consolas" pitchFamily="34" charset="-120"/>
+                <a:latin typeface="Courier New" pitchFamily="49" charset="0"/>
+                <a:ea typeface="Courier New" pitchFamily="49" charset="-122"/>
+                <a:cs typeface="Courier New" pitchFamily="49" charset="-120"/>
               </a:rPr>
               <a:t>on_delete</a:t>
             </a:r>
@@ -15772,13 +15774,13 @@
               <a:buNone/>
             </a:pPr>
             <a:r>
-              <a:rPr lang="en-US" sz="1300" dirty="0">
+              <a:rPr lang="en-US" sz="1150" dirty="0">
                 <a:solidFill>
                   <a:srgbClr val="00397B"/>
                 </a:solidFill>
-                <a:latin typeface="Consolas" pitchFamily="34" charset="0"/>
-                <a:ea typeface="Consolas" pitchFamily="34" charset="-122"/>
-                <a:cs typeface="Consolas" pitchFamily="34" charset="-120"/>
+                <a:latin typeface="Courier New" pitchFamily="49" charset="0"/>
+                <a:ea typeface="Courier New" pitchFamily="49" charset="-122"/>
+                <a:cs typeface="Courier New" pitchFamily="49" charset="-120"/>
               </a:rPr>
               <a:t>on_delete</a:t>
             </a:r>
@@ -16201,7 +16203,7 @@
           <a:ln/>
         </p:spPr>
         <p:txBody>
-          <a:bodyPr wrap="square" lIns="0" tIns="0" rIns="0" bIns="0" rtlCol="0" anchor="ctr"/>
+          <a:bodyPr wrap="none" lIns="0" tIns="0" rIns="0" bIns="0" rtlCol="0" anchor="ctr"/>
           <a:lstStyle/>
           <a:p>
             <a:pPr indent="0" marL="0">
@@ -16212,9 +16214,9 @@
                 <a:solidFill>
                   <a:srgbClr val="8B949E"/>
                 </a:solidFill>
-                <a:latin typeface="Consolas" pitchFamily="34" charset="0"/>
-                <a:ea typeface="Consolas" pitchFamily="34" charset="-122"/>
-                <a:cs typeface="Consolas" pitchFamily="34" charset="-120"/>
+                <a:latin typeface="Courier New" pitchFamily="49" charset="0"/>
+                <a:ea typeface="Courier New" pitchFamily="49" charset="-122"/>
+                <a:cs typeface="Courier New" pitchFamily="49" charset="-120"/>
               </a:rPr>
               <a:t>terminal</a:t>
             </a:r>
@@ -16240,7 +16242,7 @@
           <a:ln/>
         </p:spPr>
         <p:txBody>
-          <a:bodyPr wrap="square" lIns="0" tIns="0" rIns="0" bIns="0" rtlCol="0" anchor="t"/>
+          <a:bodyPr wrap="none" lIns="0" tIns="0" rIns="0" bIns="0" rtlCol="0" anchor="t"/>
           <a:lstStyle/>
           <a:p>
             <a:pPr indent="0" marL="0">
@@ -16251,9 +16253,9 @@
                 <a:solidFill>
                   <a:srgbClr val="E6EDF3"/>
                 </a:solidFill>
-                <a:latin typeface="Consolas" pitchFamily="34" charset="0"/>
-                <a:ea typeface="Consolas" pitchFamily="34" charset="-122"/>
-                <a:cs typeface="Consolas" pitchFamily="34" charset="-120"/>
+                <a:latin typeface="Courier New" pitchFamily="49" charset="0"/>
+                <a:ea typeface="Courier New" pitchFamily="49" charset="-122"/>
+                <a:cs typeface="Courier New" pitchFamily="49" charset="-120"/>
               </a:rPr>
               <a:t>python verificar.py</a:t>
             </a:r>
@@ -16268,13 +16270,1757 @@
                 <a:solidFill>
                   <a:srgbClr val="8B949E"/>
                 </a:solidFill>
-                <a:latin typeface="Consolas" pitchFamily="34" charset="0"/>
-                <a:ea typeface="Consolas" pitchFamily="34" charset="-122"/>
-                <a:cs typeface="Consolas" pitchFamily="34" charset="-120"/>
+                <a:latin typeface="Courier New" pitchFamily="49" charset="0"/>
+                <a:ea typeface="Courier New" pitchFamily="49" charset="-122"/>
+                <a:cs typeface="Courier New" pitchFamily="49" charset="-120"/>
               </a:rPr>
               <a:t># 0 FALHA</a:t>
             </a:r>
             <a:endParaRPr lang="en-US" sz="1100" dirty="0"/>
+          </a:p>
+        </p:txBody>
+      </p:sp>
+    </p:spTree>
+  </p:cSld>
+  <p:clrMapOvr>
+    <a:masterClrMapping/>
+  </p:clrMapOvr>
+</p:sld>
+</file>
+
+<file path=ppt/slides/slide24.xml><?xml version="1.0" encoding="utf-8"?>
+<p:sld xmlns:a="http://schemas.openxmlformats.org/drawingml/2006/main" xmlns:r="http://schemas.openxmlformats.org/officeDocument/2006/relationships" xmlns:p="http://schemas.openxmlformats.org/presentationml/2006/main">
+  <p:cSld name="Slide 15">
+    <p:spTree>
+      <p:nvGrpSpPr>
+        <p:cNvPr id="1" name=""/>
+        <p:cNvGrpSpPr/>
+        <p:nvPr/>
+      </p:nvGrpSpPr>
+      <p:grpSpPr>
+        <a:xfrm>
+          <a:off x="0" y="0"/>
+          <a:ext cx="0" cy="0"/>
+          <a:chOff x="0" y="0"/>
+          <a:chExt cx="0" cy="0"/>
+        </a:xfrm>
+      </p:grpSpPr>
+      <p:sp>
+        <p:nvSpPr>
+          <p:cNvPr id="2" name="Text 5"/>
+          <p:cNvSpPr/>
+          <p:nvPr>
+            <p:ph idx="105" type="title" hasCustomPrompt="1"/>
+          </p:nvPr>
+        </p:nvSpPr>
+        <p:spPr>
+          <a:xfrm>
+            <a:off x="786384" y="329184"/>
+            <a:ext cx="7589520" cy="603504"/>
+          </a:xfrm>
+          <a:prstGeom prst="rect">
+            <a:avLst/>
+          </a:prstGeom>
+          <a:noFill/>
+          <a:ln/>
+        </p:spPr>
+        <p:txBody>
+          <a:bodyPr wrap="square" lIns="0" tIns="0" rIns="0" bIns="0" rtlCol="0" anchor="ctr"/>
+          <a:lstStyle/>
+          <a:p>
+            <a:pPr algn="l" indent="0" marL="0">
+              <a:buNone/>
+            </a:pPr>
+            <a:r>
+              <a:rPr lang="en-US" sz="3200" dirty="0">
+                <a:solidFill>
+                  <a:schemeClr val="tx2"/>
+                </a:solidFill>
+              </a:rPr>
+              <a:t>Respostas: perguntas 1 a 4</a:t>
+            </a:r>
+            <a:endParaRPr lang="en-US" sz="3200" dirty="0"/>
+          </a:p>
+        </p:txBody>
+      </p:sp>
+      <p:sp>
+        <p:nvSpPr>
+          <p:cNvPr id="9001" name="resposta"/>
+          <p:cNvSpPr/>
+          <p:nvPr/>
+        </p:nvSpPr>
+        <p:spPr>
+          <a:xfrm>
+            <a:off x="768096" y="1097280"/>
+            <a:ext cx="7607808" cy="749808"/>
+          </a:xfrm>
+          <a:prstGeom prst="roundRect">
+            <a:avLst>
+              <a:gd name="adj" fmla="val 8000"/>
+            </a:avLst>
+          </a:prstGeom>
+          <a:solidFill>
+            <a:srgbClr val="E3EFF1"/>
+          </a:solidFill>
+          <a:ln>
+            <a:noFill/>
+          </a:ln>
+        </p:spPr>
+        <p:txBody>
+          <a:bodyPr rtlCol="0" anchor="ctr"/>
+          <a:lstStyle/>
+          <a:p>
+            <a:endParaRPr lang="pt-BR"/>
+          </a:p>
+        </p:txBody>
+      </p:sp>
+      <p:sp>
+        <p:nvSpPr>
+          <p:cNvPr id="9002" name="numero"/>
+          <p:cNvSpPr/>
+          <p:nvPr/>
+        </p:nvSpPr>
+        <p:spPr>
+          <a:xfrm>
+            <a:off x="914400" y="1280160"/>
+            <a:ext cx="384048" cy="384048"/>
+          </a:xfrm>
+          <a:prstGeom prst="ellipse">
+            <a:avLst/>
+          </a:prstGeom>
+          <a:solidFill>
+            <a:srgbClr val="1185AA"/>
+          </a:solidFill>
+          <a:ln>
+            <a:noFill/>
+          </a:ln>
+        </p:spPr>
+        <p:txBody>
+          <a:bodyPr rtlCol="0" anchor="ctr"/>
+          <a:lstStyle/>
+          <a:p>
+            <a:endParaRPr lang="pt-BR"/>
+          </a:p>
+        </p:txBody>
+      </p:sp>
+      <p:sp>
+        <p:nvSpPr>
+          <p:cNvPr id="9003" name="texto"/>
+          <p:cNvSpPr txBox="1"/>
+          <p:nvPr/>
+        </p:nvSpPr>
+        <p:spPr>
+          <a:xfrm>
+            <a:off x="914400" y="1280160"/>
+            <a:ext cx="384048" cy="384048"/>
+          </a:xfrm>
+          <a:prstGeom prst="rect">
+            <a:avLst/>
+          </a:prstGeom>
+          <a:noFill/>
+        </p:spPr>
+        <p:txBody>
+          <a:bodyPr wrap="square" lIns="0" tIns="0" rIns="0" bIns="0" rtlCol="0" anchor="ctr">
+            <a:noAutofit/>
+          </a:bodyPr>
+          <a:lstStyle/>
+          <a:p>
+            <a:pPr marL="0" indent="0" algn="ctr">
+              <a:buNone/>
+            </a:pPr>
+            <a:r>
+              <a:rPr lang="pt-BR" sz="1400" b="1" dirty="0">
+                <a:solidFill>
+                  <a:srgbClr val="FFFFFF"/>
+                </a:solidFill>
+              </a:rPr>
+              <a:t>1</a:t>
+            </a:r>
+            <a:endParaRPr lang="pt-BR" sz="1400" dirty="0"/>
+          </a:p>
+        </p:txBody>
+      </p:sp>
+      <p:sp>
+        <p:nvSpPr>
+          <p:cNvPr id="9004" name="texto"/>
+          <p:cNvSpPr txBox="1"/>
+          <p:nvPr/>
+        </p:nvSpPr>
+        <p:spPr>
+          <a:xfrm>
+            <a:off x="1481328" y="1097280"/>
+            <a:ext cx="6729984" cy="749808"/>
+          </a:xfrm>
+          <a:prstGeom prst="rect">
+            <a:avLst/>
+          </a:prstGeom>
+          <a:noFill/>
+        </p:spPr>
+        <p:txBody>
+          <a:bodyPr wrap="square" lIns="0" tIns="0" rIns="0" bIns="0" rtlCol="0" anchor="ctr">
+            <a:noAutofit/>
+          </a:bodyPr>
+          <a:lstStyle/>
+          <a:p>
+            <a:pPr marL="0" indent="0">
+              <a:spcAft>
+                <a:spcPts val="200"/>
+              </a:spcAft>
+              <a:buNone/>
+            </a:pPr>
+            <a:r>
+              <a:rPr lang="pt-BR" sz="1300" b="1" dirty="0">
+                <a:solidFill>
+                  <a:srgbClr val="00397B"/>
+                </a:solidFill>
+              </a:rPr>
+              <a:t xml:space="preserve">Por que </a:t>
+            </a:r>
+            <a:r>
+              <a:rPr lang="pt-BR" sz="1150" b="1" dirty="0">
+                <a:solidFill>
+                  <a:srgbClr val="00397B"/>
+                </a:solidFill>
+                <a:latin typeface="Courier New" pitchFamily="49" charset="0"/>
+                <a:ea typeface="Courier New" pitchFamily="49" charset="0"/>
+                <a:cs typeface="Courier New" pitchFamily="49" charset="0"/>
+              </a:rPr>
+              <a:t>nota1</a:t>
+            </a:r>
+            <a:r>
+              <a:rPr lang="pt-BR" sz="1300" b="1" dirty="0">
+                <a:solidFill>
+                  <a:srgbClr val="00397B"/>
+                </a:solidFill>
+              </a:rPr>
+              <a:t xml:space="preserve"> fica em </a:t>
+            </a:r>
+            <a:r>
+              <a:rPr lang="pt-BR" sz="1150" b="1" dirty="0">
+                <a:solidFill>
+                  <a:srgbClr val="00397B"/>
+                </a:solidFill>
+                <a:latin typeface="Courier New" pitchFamily="49" charset="0"/>
+                <a:ea typeface="Courier New" pitchFamily="49" charset="0"/>
+                <a:cs typeface="Courier New" pitchFamily="49" charset="0"/>
+              </a:rPr>
+              <a:t>inscricao</a:t>
+            </a:r>
+            <a:r>
+              <a:rPr lang="pt-BR" sz="1300" b="1" dirty="0">
+                <a:solidFill>
+                  <a:srgbClr val="00397B"/>
+                </a:solidFill>
+              </a:rPr>
+              <a:t>?</a:t>
+            </a:r>
+            <a:endParaRPr lang="pt-BR" sz="1300" dirty="0"/>
+          </a:p>
+          <a:p>
+            <a:pPr marL="0" indent="0">
+              <a:buNone/>
+            </a:pPr>
+            <a:r>
+              <a:rPr lang="pt-BR" sz="1150" dirty="0">
+                <a:solidFill>
+                  <a:srgbClr val="3A3F44"/>
+                </a:solidFill>
+              </a:rPr>
+              <a:t xml:space="preserve">A nota não é do aluno (ele tem uma por disciplina) nem da disciplina (ela tem uma por aluno): é do encontro entre os dois, a tabela </a:t>
+            </a:r>
+            <a:r>
+              <a:rPr lang="pt-BR" sz="1000" dirty="0">
+                <a:solidFill>
+                  <a:srgbClr val="00397B"/>
+                </a:solidFill>
+                <a:latin typeface="Courier New" pitchFamily="49" charset="0"/>
+                <a:ea typeface="Courier New" pitchFamily="49" charset="0"/>
+                <a:cs typeface="Courier New" pitchFamily="49" charset="0"/>
+              </a:rPr>
+              <a:t>inscricao</a:t>
+            </a:r>
+            <a:r>
+              <a:rPr lang="pt-BR" sz="1150" dirty="0">
+                <a:solidFill>
+                  <a:srgbClr val="3A3F44"/>
+                </a:solidFill>
+              </a:rPr>
+              <a:t>.</a:t>
+            </a:r>
+            <a:endParaRPr lang="pt-BR" sz="1150" dirty="0"/>
+          </a:p>
+        </p:txBody>
+      </p:sp>
+      <p:sp>
+        <p:nvSpPr>
+          <p:cNvPr id="9005" name="resposta"/>
+          <p:cNvSpPr/>
+          <p:nvPr/>
+        </p:nvSpPr>
+        <p:spPr>
+          <a:xfrm>
+            <a:off x="768096" y="1965960"/>
+            <a:ext cx="7607808" cy="749808"/>
+          </a:xfrm>
+          <a:prstGeom prst="roundRect">
+            <a:avLst>
+              <a:gd name="adj" fmla="val 8000"/>
+            </a:avLst>
+          </a:prstGeom>
+          <a:solidFill>
+            <a:srgbClr val="E3EFF1"/>
+          </a:solidFill>
+          <a:ln>
+            <a:noFill/>
+          </a:ln>
+        </p:spPr>
+        <p:txBody>
+          <a:bodyPr rtlCol="0" anchor="ctr"/>
+          <a:lstStyle/>
+          <a:p>
+            <a:endParaRPr lang="pt-BR"/>
+          </a:p>
+        </p:txBody>
+      </p:sp>
+      <p:sp>
+        <p:nvSpPr>
+          <p:cNvPr id="9006" name="numero"/>
+          <p:cNvSpPr/>
+          <p:nvPr/>
+        </p:nvSpPr>
+        <p:spPr>
+          <a:xfrm>
+            <a:off x="914400" y="2148840"/>
+            <a:ext cx="384048" cy="384048"/>
+          </a:xfrm>
+          <a:prstGeom prst="ellipse">
+            <a:avLst/>
+          </a:prstGeom>
+          <a:solidFill>
+            <a:srgbClr val="1185AA"/>
+          </a:solidFill>
+          <a:ln>
+            <a:noFill/>
+          </a:ln>
+        </p:spPr>
+        <p:txBody>
+          <a:bodyPr rtlCol="0" anchor="ctr"/>
+          <a:lstStyle/>
+          <a:p>
+            <a:endParaRPr lang="pt-BR"/>
+          </a:p>
+        </p:txBody>
+      </p:sp>
+      <p:sp>
+        <p:nvSpPr>
+          <p:cNvPr id="9007" name="texto"/>
+          <p:cNvSpPr txBox="1"/>
+          <p:nvPr/>
+        </p:nvSpPr>
+        <p:spPr>
+          <a:xfrm>
+            <a:off x="914400" y="2148840"/>
+            <a:ext cx="384048" cy="384048"/>
+          </a:xfrm>
+          <a:prstGeom prst="rect">
+            <a:avLst/>
+          </a:prstGeom>
+          <a:noFill/>
+        </p:spPr>
+        <p:txBody>
+          <a:bodyPr wrap="square" lIns="0" tIns="0" rIns="0" bIns="0" rtlCol="0" anchor="ctr">
+            <a:noAutofit/>
+          </a:bodyPr>
+          <a:lstStyle/>
+          <a:p>
+            <a:pPr marL="0" indent="0" algn="ctr">
+              <a:buNone/>
+            </a:pPr>
+            <a:r>
+              <a:rPr lang="pt-BR" sz="1400" b="1" dirty="0">
+                <a:solidFill>
+                  <a:srgbClr val="FFFFFF"/>
+                </a:solidFill>
+              </a:rPr>
+              <a:t>2</a:t>
+            </a:r>
+            <a:endParaRPr lang="pt-BR" sz="1400" dirty="0"/>
+          </a:p>
+        </p:txBody>
+      </p:sp>
+      <p:sp>
+        <p:nvSpPr>
+          <p:cNvPr id="9008" name="texto"/>
+          <p:cNvSpPr txBox="1"/>
+          <p:nvPr/>
+        </p:nvSpPr>
+        <p:spPr>
+          <a:xfrm>
+            <a:off x="1481328" y="1965960"/>
+            <a:ext cx="6729984" cy="749808"/>
+          </a:xfrm>
+          <a:prstGeom prst="rect">
+            <a:avLst/>
+          </a:prstGeom>
+          <a:noFill/>
+        </p:spPr>
+        <p:txBody>
+          <a:bodyPr wrap="square" lIns="0" tIns="0" rIns="0" bIns="0" rtlCol="0" anchor="ctr">
+            <a:noAutofit/>
+          </a:bodyPr>
+          <a:lstStyle/>
+          <a:p>
+            <a:pPr marL="0" indent="0">
+              <a:spcAft>
+                <a:spcPts val="200"/>
+              </a:spcAft>
+              <a:buNone/>
+            </a:pPr>
+            <a:r>
+              <a:rPr lang="pt-BR" sz="1300" b="1" dirty="0">
+                <a:solidFill>
+                  <a:srgbClr val="00397B"/>
+                </a:solidFill>
+              </a:rPr>
+              <a:t xml:space="preserve">Por que </a:t>
+            </a:r>
+            <a:r>
+              <a:rPr lang="pt-BR" sz="1150" b="1" dirty="0">
+                <a:solidFill>
+                  <a:srgbClr val="00397B"/>
+                </a:solidFill>
+                <a:latin typeface="Courier New" pitchFamily="49" charset="0"/>
+                <a:ea typeface="Courier New" pitchFamily="49" charset="0"/>
+                <a:cs typeface="Courier New" pitchFamily="49" charset="0"/>
+              </a:rPr>
+              <a:t>PROTECT</a:t>
+            </a:r>
+            <a:r>
+              <a:rPr lang="pt-BR" sz="1300" b="1" dirty="0">
+                <a:solidFill>
+                  <a:srgbClr val="00397B"/>
+                </a:solidFill>
+              </a:rPr>
+              <a:t xml:space="preserve">, e não </a:t>
+            </a:r>
+            <a:r>
+              <a:rPr lang="pt-BR" sz="1150" b="1" dirty="0">
+                <a:solidFill>
+                  <a:srgbClr val="00397B"/>
+                </a:solidFill>
+                <a:latin typeface="Courier New" pitchFamily="49" charset="0"/>
+                <a:ea typeface="Courier New" pitchFamily="49" charset="0"/>
+                <a:cs typeface="Courier New" pitchFamily="49" charset="0"/>
+              </a:rPr>
+              <a:t>CASCADE</a:t>
+            </a:r>
+            <a:r>
+              <a:rPr lang="pt-BR" sz="1300" b="1" dirty="0">
+                <a:solidFill>
+                  <a:srgbClr val="00397B"/>
+                </a:solidFill>
+              </a:rPr>
+              <a:t>?</a:t>
+            </a:r>
+            <a:endParaRPr lang="pt-BR" sz="1300" dirty="0"/>
+          </a:p>
+          <a:p>
+            <a:pPr marL="0" indent="0">
+              <a:buNone/>
+            </a:pPr>
+            <a:r>
+              <a:rPr lang="pt-BR" sz="1000" dirty="0">
+                <a:solidFill>
+                  <a:srgbClr val="00397B"/>
+                </a:solidFill>
+                <a:latin typeface="Courier New" pitchFamily="49" charset="0"/>
+                <a:ea typeface="Courier New" pitchFamily="49" charset="0"/>
+                <a:cs typeface="Courier New" pitchFamily="49" charset="0"/>
+              </a:rPr>
+              <a:t>CASCADE</a:t>
+            </a:r>
+            <a:r>
+              <a:rPr lang="pt-BR" sz="1150" dirty="0">
+                <a:solidFill>
+                  <a:srgbClr val="3A3F44"/>
+                </a:solidFill>
+              </a:rPr>
+              <a:t xml:space="preserve"> apagaria inscrições e notas junto com o aluno, sem aviso. Com </a:t>
+            </a:r>
+            <a:r>
+              <a:rPr lang="pt-BR" sz="1000" dirty="0">
+                <a:solidFill>
+                  <a:srgbClr val="00397B"/>
+                </a:solidFill>
+                <a:latin typeface="Courier New" pitchFamily="49" charset="0"/>
+                <a:ea typeface="Courier New" pitchFamily="49" charset="0"/>
+                <a:cs typeface="Courier New" pitchFamily="49" charset="0"/>
+              </a:rPr>
+              <a:t>PROTECT</a:t>
+            </a:r>
+            <a:r>
+              <a:rPr lang="pt-BR" sz="1150" dirty="0">
+                <a:solidFill>
+                  <a:srgbClr val="3A3F44"/>
+                </a:solidFill>
+              </a:rPr>
+              <a:t xml:space="preserve"> o banco recusa (</a:t>
+            </a:r>
+            <a:r>
+              <a:rPr lang="pt-BR" sz="1000" dirty="0">
+                <a:solidFill>
+                  <a:srgbClr val="00397B"/>
+                </a:solidFill>
+                <a:latin typeface="Courier New" pitchFamily="49" charset="0"/>
+                <a:ea typeface="Courier New" pitchFamily="49" charset="0"/>
+                <a:cs typeface="Courier New" pitchFamily="49" charset="0"/>
+              </a:rPr>
+              <a:t>ProtectedError</a:t>
+            </a:r>
+            <a:r>
+              <a:rPr lang="pt-BR" sz="1150" dirty="0">
+                <a:solidFill>
+                  <a:srgbClr val="3A3F44"/>
+                </a:solidFill>
+              </a:rPr>
+              <a:t>) e a view transforma o erro em mensagem.</a:t>
+            </a:r>
+            <a:endParaRPr lang="pt-BR" sz="1150" dirty="0"/>
+          </a:p>
+        </p:txBody>
+      </p:sp>
+      <p:sp>
+        <p:nvSpPr>
+          <p:cNvPr id="9009" name="resposta"/>
+          <p:cNvSpPr/>
+          <p:nvPr/>
+        </p:nvSpPr>
+        <p:spPr>
+          <a:xfrm>
+            <a:off x="768096" y="2834640"/>
+            <a:ext cx="7607808" cy="749808"/>
+          </a:xfrm>
+          <a:prstGeom prst="roundRect">
+            <a:avLst>
+              <a:gd name="adj" fmla="val 8000"/>
+            </a:avLst>
+          </a:prstGeom>
+          <a:solidFill>
+            <a:srgbClr val="E3EFF1"/>
+          </a:solidFill>
+          <a:ln>
+            <a:noFill/>
+          </a:ln>
+        </p:spPr>
+        <p:txBody>
+          <a:bodyPr rtlCol="0" anchor="ctr"/>
+          <a:lstStyle/>
+          <a:p>
+            <a:endParaRPr lang="pt-BR"/>
+          </a:p>
+        </p:txBody>
+      </p:sp>
+      <p:sp>
+        <p:nvSpPr>
+          <p:cNvPr id="9010" name="numero"/>
+          <p:cNvSpPr/>
+          <p:nvPr/>
+        </p:nvSpPr>
+        <p:spPr>
+          <a:xfrm>
+            <a:off x="914400" y="3017520"/>
+            <a:ext cx="384048" cy="384048"/>
+          </a:xfrm>
+          <a:prstGeom prst="ellipse">
+            <a:avLst/>
+          </a:prstGeom>
+          <a:solidFill>
+            <a:srgbClr val="1185AA"/>
+          </a:solidFill>
+          <a:ln>
+            <a:noFill/>
+          </a:ln>
+        </p:spPr>
+        <p:txBody>
+          <a:bodyPr rtlCol="0" anchor="ctr"/>
+          <a:lstStyle/>
+          <a:p>
+            <a:endParaRPr lang="pt-BR"/>
+          </a:p>
+        </p:txBody>
+      </p:sp>
+      <p:sp>
+        <p:nvSpPr>
+          <p:cNvPr id="9011" name="texto"/>
+          <p:cNvSpPr txBox="1"/>
+          <p:nvPr/>
+        </p:nvSpPr>
+        <p:spPr>
+          <a:xfrm>
+            <a:off x="914400" y="3017520"/>
+            <a:ext cx="384048" cy="384048"/>
+          </a:xfrm>
+          <a:prstGeom prst="rect">
+            <a:avLst/>
+          </a:prstGeom>
+          <a:noFill/>
+        </p:spPr>
+        <p:txBody>
+          <a:bodyPr wrap="square" lIns="0" tIns="0" rIns="0" bIns="0" rtlCol="0" anchor="ctr">
+            <a:noAutofit/>
+          </a:bodyPr>
+          <a:lstStyle/>
+          <a:p>
+            <a:pPr marL="0" indent="0" algn="ctr">
+              <a:buNone/>
+            </a:pPr>
+            <a:r>
+              <a:rPr lang="pt-BR" sz="1400" b="1" dirty="0">
+                <a:solidFill>
+                  <a:srgbClr val="FFFFFF"/>
+                </a:solidFill>
+              </a:rPr>
+              <a:t>3</a:t>
+            </a:r>
+            <a:endParaRPr lang="pt-BR" sz="1400" dirty="0"/>
+          </a:p>
+        </p:txBody>
+      </p:sp>
+      <p:sp>
+        <p:nvSpPr>
+          <p:cNvPr id="9012" name="texto"/>
+          <p:cNvSpPr txBox="1"/>
+          <p:nvPr/>
+        </p:nvSpPr>
+        <p:spPr>
+          <a:xfrm>
+            <a:off x="1481328" y="2834640"/>
+            <a:ext cx="6729984" cy="749808"/>
+          </a:xfrm>
+          <a:prstGeom prst="rect">
+            <a:avLst/>
+          </a:prstGeom>
+          <a:noFill/>
+        </p:spPr>
+        <p:txBody>
+          <a:bodyPr wrap="square" lIns="0" tIns="0" rIns="0" bIns="0" rtlCol="0" anchor="ctr">
+            <a:noAutofit/>
+          </a:bodyPr>
+          <a:lstStyle/>
+          <a:p>
+            <a:pPr marL="0" indent="0">
+              <a:spcAft>
+                <a:spcPts val="200"/>
+              </a:spcAft>
+              <a:buNone/>
+            </a:pPr>
+            <a:r>
+              <a:rPr lang="pt-BR" sz="1300" b="1" dirty="0">
+                <a:solidFill>
+                  <a:srgbClr val="00397B"/>
+                </a:solidFill>
+              </a:rPr>
+              <a:t>Qual a única diferença entre criar e editar?</a:t>
+            </a:r>
+            <a:endParaRPr lang="pt-BR" sz="1300" dirty="0"/>
+          </a:p>
+          <a:p>
+            <a:pPr marL="0" indent="0">
+              <a:buNone/>
+            </a:pPr>
+            <a:r>
+              <a:rPr lang="pt-BR" sz="1150" dirty="0">
+                <a:solidFill>
+                  <a:srgbClr val="3A3F44"/>
+                </a:solidFill>
+              </a:rPr>
+              <a:t xml:space="preserve">Buscar o objeto com </a:t>
+            </a:r>
+            <a:r>
+              <a:rPr lang="pt-BR" sz="1000" dirty="0">
+                <a:solidFill>
+                  <a:srgbClr val="00397B"/>
+                </a:solidFill>
+                <a:latin typeface="Courier New" pitchFamily="49" charset="0"/>
+                <a:ea typeface="Courier New" pitchFamily="49" charset="0"/>
+                <a:cs typeface="Courier New" pitchFamily="49" charset="0"/>
+              </a:rPr>
+              <a:t>get_object_or_404</a:t>
+            </a:r>
+            <a:r>
+              <a:rPr lang="pt-BR" sz="1150" dirty="0">
+                <a:solidFill>
+                  <a:srgbClr val="3A3F44"/>
+                </a:solidFill>
+              </a:rPr>
+              <a:t xml:space="preserve"> e passar </a:t>
+            </a:r>
+            <a:r>
+              <a:rPr lang="pt-BR" sz="1000" dirty="0">
+                <a:solidFill>
+                  <a:srgbClr val="00397B"/>
+                </a:solidFill>
+                <a:latin typeface="Courier New" pitchFamily="49" charset="0"/>
+                <a:ea typeface="Courier New" pitchFamily="49" charset="0"/>
+                <a:cs typeface="Courier New" pitchFamily="49" charset="0"/>
+              </a:rPr>
+              <a:t>instance=</a:t>
+            </a:r>
+            <a:r>
+              <a:rPr lang="pt-BR" sz="1150" dirty="0">
+                <a:solidFill>
+                  <a:srgbClr val="3A3F44"/>
+                </a:solidFill>
+              </a:rPr>
+              <a:t xml:space="preserve"> ao form. Sem </a:t>
+            </a:r>
+            <a:r>
+              <a:rPr lang="pt-BR" sz="1000" dirty="0">
+                <a:solidFill>
+                  <a:srgbClr val="00397B"/>
+                </a:solidFill>
+                <a:latin typeface="Courier New" pitchFamily="49" charset="0"/>
+                <a:ea typeface="Courier New" pitchFamily="49" charset="0"/>
+                <a:cs typeface="Courier New" pitchFamily="49" charset="0"/>
+              </a:rPr>
+              <a:t>instance=</a:t>
+            </a:r>
+            <a:r>
+              <a:rPr lang="pt-BR" sz="1150" dirty="0">
+                <a:solidFill>
+                  <a:srgbClr val="3A3F44"/>
+                </a:solidFill>
+              </a:rPr>
+              <a:t xml:space="preserve">, o </a:t>
+            </a:r>
+            <a:r>
+              <a:rPr lang="pt-BR" sz="1000" dirty="0">
+                <a:solidFill>
+                  <a:srgbClr val="00397B"/>
+                </a:solidFill>
+                <a:latin typeface="Courier New" pitchFamily="49" charset="0"/>
+                <a:ea typeface="Courier New" pitchFamily="49" charset="0"/>
+                <a:cs typeface="Courier New" pitchFamily="49" charset="0"/>
+              </a:rPr>
+              <a:t>save()</a:t>
+            </a:r>
+            <a:r>
+              <a:rPr lang="pt-BR" sz="1150" dirty="0">
+                <a:solidFill>
+                  <a:srgbClr val="3A3F44"/>
+                </a:solidFill>
+              </a:rPr>
+              <a:t xml:space="preserve"> faz INSERT e cria outro registro.</a:t>
+            </a:r>
+            <a:endParaRPr lang="pt-BR" sz="1150" dirty="0"/>
+          </a:p>
+        </p:txBody>
+      </p:sp>
+      <p:sp>
+        <p:nvSpPr>
+          <p:cNvPr id="9013" name="resposta"/>
+          <p:cNvSpPr/>
+          <p:nvPr/>
+        </p:nvSpPr>
+        <p:spPr>
+          <a:xfrm>
+            <a:off x="768096" y="3703320"/>
+            <a:ext cx="7607808" cy="749808"/>
+          </a:xfrm>
+          <a:prstGeom prst="roundRect">
+            <a:avLst>
+              <a:gd name="adj" fmla="val 8000"/>
+            </a:avLst>
+          </a:prstGeom>
+          <a:solidFill>
+            <a:srgbClr val="E3EFF1"/>
+          </a:solidFill>
+          <a:ln>
+            <a:noFill/>
+          </a:ln>
+        </p:spPr>
+        <p:txBody>
+          <a:bodyPr rtlCol="0" anchor="ctr"/>
+          <a:lstStyle/>
+          <a:p>
+            <a:endParaRPr lang="pt-BR"/>
+          </a:p>
+        </p:txBody>
+      </p:sp>
+      <p:sp>
+        <p:nvSpPr>
+          <p:cNvPr id="9014" name="numero"/>
+          <p:cNvSpPr/>
+          <p:nvPr/>
+        </p:nvSpPr>
+        <p:spPr>
+          <a:xfrm>
+            <a:off x="914400" y="3886200"/>
+            <a:ext cx="384048" cy="384048"/>
+          </a:xfrm>
+          <a:prstGeom prst="ellipse">
+            <a:avLst/>
+          </a:prstGeom>
+          <a:solidFill>
+            <a:srgbClr val="1185AA"/>
+          </a:solidFill>
+          <a:ln>
+            <a:noFill/>
+          </a:ln>
+        </p:spPr>
+        <p:txBody>
+          <a:bodyPr rtlCol="0" anchor="ctr"/>
+          <a:lstStyle/>
+          <a:p>
+            <a:endParaRPr lang="pt-BR"/>
+          </a:p>
+        </p:txBody>
+      </p:sp>
+      <p:sp>
+        <p:nvSpPr>
+          <p:cNvPr id="9015" name="texto"/>
+          <p:cNvSpPr txBox="1"/>
+          <p:nvPr/>
+        </p:nvSpPr>
+        <p:spPr>
+          <a:xfrm>
+            <a:off x="914400" y="3886200"/>
+            <a:ext cx="384048" cy="384048"/>
+          </a:xfrm>
+          <a:prstGeom prst="rect">
+            <a:avLst/>
+          </a:prstGeom>
+          <a:noFill/>
+        </p:spPr>
+        <p:txBody>
+          <a:bodyPr wrap="square" lIns="0" tIns="0" rIns="0" bIns="0" rtlCol="0" anchor="ctr">
+            <a:noAutofit/>
+          </a:bodyPr>
+          <a:lstStyle/>
+          <a:p>
+            <a:pPr marL="0" indent="0" algn="ctr">
+              <a:buNone/>
+            </a:pPr>
+            <a:r>
+              <a:rPr lang="pt-BR" sz="1400" b="1" dirty="0">
+                <a:solidFill>
+                  <a:srgbClr val="FFFFFF"/>
+                </a:solidFill>
+              </a:rPr>
+              <a:t>4</a:t>
+            </a:r>
+            <a:endParaRPr lang="pt-BR" sz="1400" dirty="0"/>
+          </a:p>
+        </p:txBody>
+      </p:sp>
+      <p:sp>
+        <p:nvSpPr>
+          <p:cNvPr id="9016" name="texto"/>
+          <p:cNvSpPr txBox="1"/>
+          <p:nvPr/>
+        </p:nvSpPr>
+        <p:spPr>
+          <a:xfrm>
+            <a:off x="1481328" y="3703320"/>
+            <a:ext cx="6729984" cy="749808"/>
+          </a:xfrm>
+          <a:prstGeom prst="rect">
+            <a:avLst/>
+          </a:prstGeom>
+          <a:noFill/>
+        </p:spPr>
+        <p:txBody>
+          <a:bodyPr wrap="square" lIns="0" tIns="0" rIns="0" bIns="0" rtlCol="0" anchor="ctr">
+            <a:noAutofit/>
+          </a:bodyPr>
+          <a:lstStyle/>
+          <a:p>
+            <a:pPr marL="0" indent="0">
+              <a:spcAft>
+                <a:spcPts val="200"/>
+              </a:spcAft>
+              <a:buNone/>
+            </a:pPr>
+            <a:r>
+              <a:rPr lang="pt-BR" sz="1300" b="1" dirty="0">
+                <a:solidFill>
+                  <a:srgbClr val="00397B"/>
+                </a:solidFill>
+              </a:rPr>
+              <a:t>Por que redirecionar depois de salvar?</a:t>
+            </a:r>
+            <a:endParaRPr lang="pt-BR" sz="1300" dirty="0"/>
+          </a:p>
+          <a:p>
+            <a:pPr marL="0" indent="0">
+              <a:buNone/>
+            </a:pPr>
+            <a:r>
+              <a:rPr lang="pt-BR" sz="1150" dirty="0">
+                <a:solidFill>
+                  <a:srgbClr val="3A3F44"/>
+                </a:solidFill>
+              </a:rPr>
+              <a:t xml:space="preserve">POST/Redirect/GET: sem o </a:t>
+            </a:r>
+            <a:r>
+              <a:rPr lang="pt-BR" sz="1000" dirty="0">
+                <a:solidFill>
+                  <a:srgbClr val="00397B"/>
+                </a:solidFill>
+                <a:latin typeface="Courier New" pitchFamily="49" charset="0"/>
+                <a:ea typeface="Courier New" pitchFamily="49" charset="0"/>
+                <a:cs typeface="Courier New" pitchFamily="49" charset="0"/>
+              </a:rPr>
+              <a:t>redirect()</a:t>
+            </a:r>
+            <a:r>
+              <a:rPr lang="pt-BR" sz="1150" dirty="0">
+                <a:solidFill>
+                  <a:srgbClr val="3A3F44"/>
+                </a:solidFill>
+              </a:rPr>
+              <a:t>, o F5 reenvia o POST e duplica o cadastro. Com ele, o F5 repete só o GET da lista.</a:t>
+            </a:r>
+            <a:endParaRPr lang="pt-BR" sz="1150" dirty="0"/>
+          </a:p>
+        </p:txBody>
+      </p:sp>
+    </p:spTree>
+  </p:cSld>
+  <p:clrMapOvr>
+    <a:masterClrMapping/>
+  </p:clrMapOvr>
+</p:sld>
+</file>
+
+<file path=ppt/slides/slide25.xml><?xml version="1.0" encoding="utf-8"?>
+<p:sld xmlns:a="http://schemas.openxmlformats.org/drawingml/2006/main" xmlns:r="http://schemas.openxmlformats.org/officeDocument/2006/relationships" xmlns:p="http://schemas.openxmlformats.org/presentationml/2006/main">
+  <p:cSld name="Slide 15">
+    <p:spTree>
+      <p:nvGrpSpPr>
+        <p:cNvPr id="1" name=""/>
+        <p:cNvGrpSpPr/>
+        <p:nvPr/>
+      </p:nvGrpSpPr>
+      <p:grpSpPr>
+        <a:xfrm>
+          <a:off x="0" y="0"/>
+          <a:ext cx="0" cy="0"/>
+          <a:chOff x="0" y="0"/>
+          <a:chExt cx="0" cy="0"/>
+        </a:xfrm>
+      </p:grpSpPr>
+      <p:sp>
+        <p:nvSpPr>
+          <p:cNvPr id="2" name="Text 5"/>
+          <p:cNvSpPr/>
+          <p:nvPr>
+            <p:ph idx="105" type="title" hasCustomPrompt="1"/>
+          </p:nvPr>
+        </p:nvSpPr>
+        <p:spPr>
+          <a:xfrm>
+            <a:off x="786384" y="329184"/>
+            <a:ext cx="7589520" cy="603504"/>
+          </a:xfrm>
+          <a:prstGeom prst="rect">
+            <a:avLst/>
+          </a:prstGeom>
+          <a:noFill/>
+          <a:ln/>
+        </p:spPr>
+        <p:txBody>
+          <a:bodyPr wrap="square" lIns="0" tIns="0" rIns="0" bIns="0" rtlCol="0" anchor="ctr"/>
+          <a:lstStyle/>
+          <a:p>
+            <a:pPr algn="l" indent="0" marL="0">
+              <a:buNone/>
+            </a:pPr>
+            <a:r>
+              <a:rPr lang="en-US" sz="3200" dirty="0">
+                <a:solidFill>
+                  <a:schemeClr val="tx2"/>
+                </a:solidFill>
+              </a:rPr>
+              <a:t>Respostas: perguntas 5 a 8</a:t>
+            </a:r>
+            <a:endParaRPr lang="en-US" sz="3200" dirty="0"/>
+          </a:p>
+        </p:txBody>
+      </p:sp>
+      <p:sp>
+        <p:nvSpPr>
+          <p:cNvPr id="9017" name="resposta"/>
+          <p:cNvSpPr/>
+          <p:nvPr/>
+        </p:nvSpPr>
+        <p:spPr>
+          <a:xfrm>
+            <a:off x="768096" y="1097280"/>
+            <a:ext cx="7607808" cy="749808"/>
+          </a:xfrm>
+          <a:prstGeom prst="roundRect">
+            <a:avLst>
+              <a:gd name="adj" fmla="val 8000"/>
+            </a:avLst>
+          </a:prstGeom>
+          <a:solidFill>
+            <a:srgbClr val="E3EFF1"/>
+          </a:solidFill>
+          <a:ln>
+            <a:noFill/>
+          </a:ln>
+        </p:spPr>
+        <p:txBody>
+          <a:bodyPr rtlCol="0" anchor="ctr"/>
+          <a:lstStyle/>
+          <a:p>
+            <a:endParaRPr lang="pt-BR"/>
+          </a:p>
+        </p:txBody>
+      </p:sp>
+      <p:sp>
+        <p:nvSpPr>
+          <p:cNvPr id="9018" name="numero"/>
+          <p:cNvSpPr/>
+          <p:nvPr/>
+        </p:nvSpPr>
+        <p:spPr>
+          <a:xfrm>
+            <a:off x="914400" y="1280160"/>
+            <a:ext cx="384048" cy="384048"/>
+          </a:xfrm>
+          <a:prstGeom prst="ellipse">
+            <a:avLst/>
+          </a:prstGeom>
+          <a:solidFill>
+            <a:srgbClr val="1185AA"/>
+          </a:solidFill>
+          <a:ln>
+            <a:noFill/>
+          </a:ln>
+        </p:spPr>
+        <p:txBody>
+          <a:bodyPr rtlCol="0" anchor="ctr"/>
+          <a:lstStyle/>
+          <a:p>
+            <a:endParaRPr lang="pt-BR"/>
+          </a:p>
+        </p:txBody>
+      </p:sp>
+      <p:sp>
+        <p:nvSpPr>
+          <p:cNvPr id="9019" name="texto"/>
+          <p:cNvSpPr txBox="1"/>
+          <p:nvPr/>
+        </p:nvSpPr>
+        <p:spPr>
+          <a:xfrm>
+            <a:off x="914400" y="1280160"/>
+            <a:ext cx="384048" cy="384048"/>
+          </a:xfrm>
+          <a:prstGeom prst="rect">
+            <a:avLst/>
+          </a:prstGeom>
+          <a:noFill/>
+        </p:spPr>
+        <p:txBody>
+          <a:bodyPr wrap="square" lIns="0" tIns="0" rIns="0" bIns="0" rtlCol="0" anchor="ctr">
+            <a:noAutofit/>
+          </a:bodyPr>
+          <a:lstStyle/>
+          <a:p>
+            <a:pPr marL="0" indent="0" algn="ctr">
+              <a:buNone/>
+            </a:pPr>
+            <a:r>
+              <a:rPr lang="pt-BR" sz="1400" b="1" dirty="0">
+                <a:solidFill>
+                  <a:srgbClr val="FFFFFF"/>
+                </a:solidFill>
+              </a:rPr>
+              <a:t>5</a:t>
+            </a:r>
+            <a:endParaRPr lang="pt-BR" sz="1400" dirty="0"/>
+          </a:p>
+        </p:txBody>
+      </p:sp>
+      <p:sp>
+        <p:nvSpPr>
+          <p:cNvPr id="9020" name="texto"/>
+          <p:cNvSpPr txBox="1"/>
+          <p:nvPr/>
+        </p:nvSpPr>
+        <p:spPr>
+          <a:xfrm>
+            <a:off x="1481328" y="1097280"/>
+            <a:ext cx="6729984" cy="749808"/>
+          </a:xfrm>
+          <a:prstGeom prst="rect">
+            <a:avLst/>
+          </a:prstGeom>
+          <a:noFill/>
+        </p:spPr>
+        <p:txBody>
+          <a:bodyPr wrap="square" lIns="0" tIns="0" rIns="0" bIns="0" rtlCol="0" anchor="ctr">
+            <a:noAutofit/>
+          </a:bodyPr>
+          <a:lstStyle/>
+          <a:p>
+            <a:pPr marL="0" indent="0">
+              <a:spcAft>
+                <a:spcPts val="200"/>
+              </a:spcAft>
+              <a:buNone/>
+            </a:pPr>
+            <a:r>
+              <a:rPr lang="pt-BR" sz="1300" b="1" dirty="0">
+                <a:solidFill>
+                  <a:srgbClr val="00397B"/>
+                </a:solidFill>
+              </a:rPr>
+              <a:t>Por que a exclusão só acontece no POST?</a:t>
+            </a:r>
+            <a:endParaRPr lang="pt-BR" sz="1300" dirty="0"/>
+          </a:p>
+          <a:p>
+            <a:pPr marL="0" indent="0">
+              <a:buNone/>
+            </a:pPr>
+            <a:r>
+              <a:rPr lang="pt-BR" sz="1150" dirty="0">
+                <a:solidFill>
+                  <a:srgbClr val="3A3F44"/>
+                </a:solidFill>
+              </a:rPr>
+              <a:t xml:space="preserve">GET é para ler: robôs, pré-carregadores e links disparam GET sozinhos. O GET mostra a confirmação; o POST, com </a:t>
+            </a:r>
+            <a:r>
+              <a:rPr lang="pt-BR" sz="1000" dirty="0">
+                <a:solidFill>
+                  <a:srgbClr val="00397B"/>
+                </a:solidFill>
+                <a:latin typeface="Courier New" pitchFamily="49" charset="0"/>
+                <a:ea typeface="Courier New" pitchFamily="49" charset="0"/>
+                <a:cs typeface="Courier New" pitchFamily="49" charset="0"/>
+              </a:rPr>
+              <a:t>csrf_token</a:t>
+            </a:r>
+            <a:r>
+              <a:rPr lang="pt-BR" sz="1150" dirty="0">
+                <a:solidFill>
+                  <a:srgbClr val="3A3F44"/>
+                </a:solidFill>
+              </a:rPr>
+              <a:t>, exclui.</a:t>
+            </a:r>
+            <a:endParaRPr lang="pt-BR" sz="1150" dirty="0"/>
+          </a:p>
+        </p:txBody>
+      </p:sp>
+      <p:sp>
+        <p:nvSpPr>
+          <p:cNvPr id="9021" name="resposta"/>
+          <p:cNvSpPr/>
+          <p:nvPr/>
+        </p:nvSpPr>
+        <p:spPr>
+          <a:xfrm>
+            <a:off x="768096" y="1965960"/>
+            <a:ext cx="7607808" cy="749808"/>
+          </a:xfrm>
+          <a:prstGeom prst="roundRect">
+            <a:avLst>
+              <a:gd name="adj" fmla="val 8000"/>
+            </a:avLst>
+          </a:prstGeom>
+          <a:solidFill>
+            <a:srgbClr val="E3EFF1"/>
+          </a:solidFill>
+          <a:ln>
+            <a:noFill/>
+          </a:ln>
+        </p:spPr>
+        <p:txBody>
+          <a:bodyPr rtlCol="0" anchor="ctr"/>
+          <a:lstStyle/>
+          <a:p>
+            <a:endParaRPr lang="pt-BR"/>
+          </a:p>
+        </p:txBody>
+      </p:sp>
+      <p:sp>
+        <p:nvSpPr>
+          <p:cNvPr id="9022" name="numero"/>
+          <p:cNvSpPr/>
+          <p:nvPr/>
+        </p:nvSpPr>
+        <p:spPr>
+          <a:xfrm>
+            <a:off x="914400" y="2148840"/>
+            <a:ext cx="384048" cy="384048"/>
+          </a:xfrm>
+          <a:prstGeom prst="ellipse">
+            <a:avLst/>
+          </a:prstGeom>
+          <a:solidFill>
+            <a:srgbClr val="1185AA"/>
+          </a:solidFill>
+          <a:ln>
+            <a:noFill/>
+          </a:ln>
+        </p:spPr>
+        <p:txBody>
+          <a:bodyPr rtlCol="0" anchor="ctr"/>
+          <a:lstStyle/>
+          <a:p>
+            <a:endParaRPr lang="pt-BR"/>
+          </a:p>
+        </p:txBody>
+      </p:sp>
+      <p:sp>
+        <p:nvSpPr>
+          <p:cNvPr id="9023" name="texto"/>
+          <p:cNvSpPr txBox="1"/>
+          <p:nvPr/>
+        </p:nvSpPr>
+        <p:spPr>
+          <a:xfrm>
+            <a:off x="914400" y="2148840"/>
+            <a:ext cx="384048" cy="384048"/>
+          </a:xfrm>
+          <a:prstGeom prst="rect">
+            <a:avLst/>
+          </a:prstGeom>
+          <a:noFill/>
+        </p:spPr>
+        <p:txBody>
+          <a:bodyPr wrap="square" lIns="0" tIns="0" rIns="0" bIns="0" rtlCol="0" anchor="ctr">
+            <a:noAutofit/>
+          </a:bodyPr>
+          <a:lstStyle/>
+          <a:p>
+            <a:pPr marL="0" indent="0" algn="ctr">
+              <a:buNone/>
+            </a:pPr>
+            <a:r>
+              <a:rPr lang="pt-BR" sz="1400" b="1" dirty="0">
+                <a:solidFill>
+                  <a:srgbClr val="FFFFFF"/>
+                </a:solidFill>
+              </a:rPr>
+              <a:t>6</a:t>
+            </a:r>
+            <a:endParaRPr lang="pt-BR" sz="1400" dirty="0"/>
+          </a:p>
+        </p:txBody>
+      </p:sp>
+      <p:sp>
+        <p:nvSpPr>
+          <p:cNvPr id="9024" name="texto"/>
+          <p:cNvSpPr txBox="1"/>
+          <p:nvPr/>
+        </p:nvSpPr>
+        <p:spPr>
+          <a:xfrm>
+            <a:off x="1481328" y="1965960"/>
+            <a:ext cx="6729984" cy="749808"/>
+          </a:xfrm>
+          <a:prstGeom prst="rect">
+            <a:avLst/>
+          </a:prstGeom>
+          <a:noFill/>
+        </p:spPr>
+        <p:txBody>
+          <a:bodyPr wrap="square" lIns="0" tIns="0" rIns="0" bIns="0" rtlCol="0" anchor="ctr">
+            <a:noAutofit/>
+          </a:bodyPr>
+          <a:lstStyle/>
+          <a:p>
+            <a:pPr marL="0" indent="0">
+              <a:spcAft>
+                <a:spcPts val="200"/>
+              </a:spcAft>
+              <a:buNone/>
+            </a:pPr>
+            <a:r>
+              <a:rPr lang="pt-BR" sz="1300" b="1" dirty="0">
+                <a:solidFill>
+                  <a:srgbClr val="00397B"/>
+                </a:solidFill>
+              </a:rPr>
+              <a:t xml:space="preserve">O que o </a:t>
+            </a:r>
+            <a:r>
+              <a:rPr lang="pt-BR" sz="1150" b="1" dirty="0">
+                <a:solidFill>
+                  <a:srgbClr val="00397B"/>
+                </a:solidFill>
+                <a:latin typeface="Courier New" pitchFamily="49" charset="0"/>
+                <a:ea typeface="Courier New" pitchFamily="49" charset="0"/>
+                <a:cs typeface="Courier New" pitchFamily="49" charset="0"/>
+              </a:rPr>
+              <a:t>select_related</a:t>
+            </a:r>
+            <a:r>
+              <a:rPr lang="pt-BR" sz="1300" b="1" dirty="0">
+                <a:solidFill>
+                  <a:srgbClr val="00397B"/>
+                </a:solidFill>
+              </a:rPr>
+              <a:t xml:space="preserve"> evita?</a:t>
+            </a:r>
+            <a:endParaRPr lang="pt-BR" sz="1300" dirty="0"/>
+          </a:p>
+          <a:p>
+            <a:pPr marL="0" indent="0">
+              <a:buNone/>
+            </a:pPr>
+            <a:r>
+              <a:rPr lang="pt-BR" sz="1150" dirty="0">
+                <a:solidFill>
+                  <a:srgbClr val="3A3F44"/>
+                </a:solidFill>
+              </a:rPr>
+              <a:t xml:space="preserve">O N+1: uma consulta para a lista e mais uma por linha para cada chave estrangeira. Com </a:t>
+            </a:r>
+            <a:r>
+              <a:rPr lang="pt-BR" sz="1000" dirty="0">
+                <a:solidFill>
+                  <a:srgbClr val="00397B"/>
+                </a:solidFill>
+                <a:latin typeface="Courier New" pitchFamily="49" charset="0"/>
+                <a:ea typeface="Courier New" pitchFamily="49" charset="0"/>
+                <a:cs typeface="Courier New" pitchFamily="49" charset="0"/>
+              </a:rPr>
+              <a:t>select_related</a:t>
+            </a:r>
+            <a:r>
+              <a:rPr lang="pt-BR" sz="1150" dirty="0">
+                <a:solidFill>
+                  <a:srgbClr val="3A3F44"/>
+                </a:solidFill>
+              </a:rPr>
+              <a:t>, um JOIN traz tudo em 1 consulta.</a:t>
+            </a:r>
+            <a:endParaRPr lang="pt-BR" sz="1150" dirty="0"/>
+          </a:p>
+        </p:txBody>
+      </p:sp>
+      <p:sp>
+        <p:nvSpPr>
+          <p:cNvPr id="9025" name="resposta"/>
+          <p:cNvSpPr/>
+          <p:nvPr/>
+        </p:nvSpPr>
+        <p:spPr>
+          <a:xfrm>
+            <a:off x="768096" y="2834640"/>
+            <a:ext cx="7607808" cy="749808"/>
+          </a:xfrm>
+          <a:prstGeom prst="roundRect">
+            <a:avLst>
+              <a:gd name="adj" fmla="val 8000"/>
+            </a:avLst>
+          </a:prstGeom>
+          <a:solidFill>
+            <a:srgbClr val="E3EFF1"/>
+          </a:solidFill>
+          <a:ln>
+            <a:noFill/>
+          </a:ln>
+        </p:spPr>
+        <p:txBody>
+          <a:bodyPr rtlCol="0" anchor="ctr"/>
+          <a:lstStyle/>
+          <a:p>
+            <a:endParaRPr lang="pt-BR"/>
+          </a:p>
+        </p:txBody>
+      </p:sp>
+      <p:sp>
+        <p:nvSpPr>
+          <p:cNvPr id="9026" name="numero"/>
+          <p:cNvSpPr/>
+          <p:nvPr/>
+        </p:nvSpPr>
+        <p:spPr>
+          <a:xfrm>
+            <a:off x="914400" y="3017520"/>
+            <a:ext cx="384048" cy="384048"/>
+          </a:xfrm>
+          <a:prstGeom prst="ellipse">
+            <a:avLst/>
+          </a:prstGeom>
+          <a:solidFill>
+            <a:srgbClr val="1185AA"/>
+          </a:solidFill>
+          <a:ln>
+            <a:noFill/>
+          </a:ln>
+        </p:spPr>
+        <p:txBody>
+          <a:bodyPr rtlCol="0" anchor="ctr"/>
+          <a:lstStyle/>
+          <a:p>
+            <a:endParaRPr lang="pt-BR"/>
+          </a:p>
+        </p:txBody>
+      </p:sp>
+      <p:sp>
+        <p:nvSpPr>
+          <p:cNvPr id="9027" name="texto"/>
+          <p:cNvSpPr txBox="1"/>
+          <p:nvPr/>
+        </p:nvSpPr>
+        <p:spPr>
+          <a:xfrm>
+            <a:off x="914400" y="3017520"/>
+            <a:ext cx="384048" cy="384048"/>
+          </a:xfrm>
+          <a:prstGeom prst="rect">
+            <a:avLst/>
+          </a:prstGeom>
+          <a:noFill/>
+        </p:spPr>
+        <p:txBody>
+          <a:bodyPr wrap="square" lIns="0" tIns="0" rIns="0" bIns="0" rtlCol="0" anchor="ctr">
+            <a:noAutofit/>
+          </a:bodyPr>
+          <a:lstStyle/>
+          <a:p>
+            <a:pPr marL="0" indent="0" algn="ctr">
+              <a:buNone/>
+            </a:pPr>
+            <a:r>
+              <a:rPr lang="pt-BR" sz="1400" b="1" dirty="0">
+                <a:solidFill>
+                  <a:srgbClr val="FFFFFF"/>
+                </a:solidFill>
+              </a:rPr>
+              <a:t>7</a:t>
+            </a:r>
+            <a:endParaRPr lang="pt-BR" sz="1400" dirty="0"/>
+          </a:p>
+        </p:txBody>
+      </p:sp>
+      <p:sp>
+        <p:nvSpPr>
+          <p:cNvPr id="9028" name="texto"/>
+          <p:cNvSpPr txBox="1"/>
+          <p:nvPr/>
+        </p:nvSpPr>
+        <p:spPr>
+          <a:xfrm>
+            <a:off x="1481328" y="2834640"/>
+            <a:ext cx="6729984" cy="749808"/>
+          </a:xfrm>
+          <a:prstGeom prst="rect">
+            <a:avLst/>
+          </a:prstGeom>
+          <a:noFill/>
+        </p:spPr>
+        <p:txBody>
+          <a:bodyPr wrap="square" lIns="0" tIns="0" rIns="0" bIns="0" rtlCol="0" anchor="ctr">
+            <a:noAutofit/>
+          </a:bodyPr>
+          <a:lstStyle/>
+          <a:p>
+            <a:pPr marL="0" indent="0">
+              <a:spcAft>
+                <a:spcPts val="200"/>
+              </a:spcAft>
+              <a:buNone/>
+            </a:pPr>
+            <a:r>
+              <a:rPr lang="pt-BR" sz="1300" b="1" dirty="0">
+                <a:solidFill>
+                  <a:srgbClr val="00397B"/>
+                </a:solidFill>
+              </a:rPr>
+              <a:t>Onde ficou cada validação, e por quê ali?</a:t>
+            </a:r>
+            <a:endParaRPr lang="pt-BR" sz="1300" dirty="0"/>
+          </a:p>
+          <a:p>
+            <a:pPr marL="0" indent="0">
+              <a:buNone/>
+            </a:pPr>
+            <a:r>
+              <a:rPr lang="pt-BR" sz="1150" dirty="0">
+                <a:solidFill>
+                  <a:srgbClr val="3A3F44"/>
+                </a:solidFill>
+              </a:rPr>
+              <a:t>Integridade no modelo e no banco (</a:t>
+            </a:r>
+            <a:r>
+              <a:rPr lang="pt-BR" sz="1000" dirty="0">
+                <a:solidFill>
+                  <a:srgbClr val="00397B"/>
+                </a:solidFill>
+                <a:latin typeface="Courier New" pitchFamily="49" charset="0"/>
+                <a:ea typeface="Courier New" pitchFamily="49" charset="0"/>
+                <a:cs typeface="Courier New" pitchFamily="49" charset="0"/>
+              </a:rPr>
+              <a:t>unique</a:t>
+            </a:r>
+            <a:r>
+              <a:rPr lang="pt-BR" sz="1150" dirty="0">
+                <a:solidFill>
+                  <a:srgbClr val="3A3F44"/>
+                </a:solidFill>
+              </a:rPr>
+              <a:t xml:space="preserve">, </a:t>
+            </a:r>
+            <a:r>
+              <a:rPr lang="pt-BR" sz="1000" dirty="0">
+                <a:solidFill>
+                  <a:srgbClr val="00397B"/>
+                </a:solidFill>
+                <a:latin typeface="Courier New" pitchFamily="49" charset="0"/>
+                <a:ea typeface="Courier New" pitchFamily="49" charset="0"/>
+                <a:cs typeface="Courier New" pitchFamily="49" charset="0"/>
+              </a:rPr>
+              <a:t>validators</a:t>
+            </a:r>
+            <a:r>
+              <a:rPr lang="pt-BR" sz="1150" dirty="0">
+                <a:solidFill>
+                  <a:srgbClr val="3A3F44"/>
+                </a:solidFill>
+              </a:rPr>
+              <a:t xml:space="preserve">, </a:t>
+            </a:r>
+            <a:r>
+              <a:rPr lang="pt-BR" sz="1000" dirty="0">
+                <a:solidFill>
+                  <a:srgbClr val="00397B"/>
+                </a:solidFill>
+                <a:latin typeface="Courier New" pitchFamily="49" charset="0"/>
+                <a:ea typeface="Courier New" pitchFamily="49" charset="0"/>
+                <a:cs typeface="Courier New" pitchFamily="49" charset="0"/>
+              </a:rPr>
+              <a:t>PROTECT</a:t>
+            </a:r>
+            <a:r>
+              <a:rPr lang="pt-BR" sz="1150" dirty="0">
+                <a:solidFill>
+                  <a:srgbClr val="3A3F44"/>
+                </a:solidFill>
+              </a:rPr>
+              <a:t>), que vale para tela, admin e shell. Normalização e mensagem no form (</a:t>
+            </a:r>
+            <a:r>
+              <a:rPr lang="pt-BR" sz="1000" dirty="0">
+                <a:solidFill>
+                  <a:srgbClr val="00397B"/>
+                </a:solidFill>
+                <a:latin typeface="Courier New" pitchFamily="49" charset="0"/>
+                <a:ea typeface="Courier New" pitchFamily="49" charset="0"/>
+                <a:cs typeface="Courier New" pitchFamily="49" charset="0"/>
+              </a:rPr>
+              <a:t>clean_&lt;campo&gt;</a:t>
+            </a:r>
+            <a:r>
+              <a:rPr lang="pt-BR" sz="1150" dirty="0">
+                <a:solidFill>
+                  <a:srgbClr val="3A3F44"/>
+                </a:solidFill>
+              </a:rPr>
+              <a:t>). Fluxo na view.</a:t>
+            </a:r>
+            <a:endParaRPr lang="pt-BR" sz="1150" dirty="0"/>
+          </a:p>
+        </p:txBody>
+      </p:sp>
+      <p:sp>
+        <p:nvSpPr>
+          <p:cNvPr id="9029" name="resposta"/>
+          <p:cNvSpPr/>
+          <p:nvPr/>
+        </p:nvSpPr>
+        <p:spPr>
+          <a:xfrm>
+            <a:off x="768096" y="3703320"/>
+            <a:ext cx="7607808" cy="749808"/>
+          </a:xfrm>
+          <a:prstGeom prst="roundRect">
+            <a:avLst>
+              <a:gd name="adj" fmla="val 8000"/>
+            </a:avLst>
+          </a:prstGeom>
+          <a:solidFill>
+            <a:srgbClr val="E3EFF1"/>
+          </a:solidFill>
+          <a:ln>
+            <a:noFill/>
+          </a:ln>
+        </p:spPr>
+        <p:txBody>
+          <a:bodyPr rtlCol="0" anchor="ctr"/>
+          <a:lstStyle/>
+          <a:p>
+            <a:endParaRPr lang="pt-BR"/>
+          </a:p>
+        </p:txBody>
+      </p:sp>
+      <p:sp>
+        <p:nvSpPr>
+          <p:cNvPr id="9030" name="numero"/>
+          <p:cNvSpPr/>
+          <p:nvPr/>
+        </p:nvSpPr>
+        <p:spPr>
+          <a:xfrm>
+            <a:off x="914400" y="3886200"/>
+            <a:ext cx="384048" cy="384048"/>
+          </a:xfrm>
+          <a:prstGeom prst="ellipse">
+            <a:avLst/>
+          </a:prstGeom>
+          <a:solidFill>
+            <a:srgbClr val="1185AA"/>
+          </a:solidFill>
+          <a:ln>
+            <a:noFill/>
+          </a:ln>
+        </p:spPr>
+        <p:txBody>
+          <a:bodyPr rtlCol="0" anchor="ctr"/>
+          <a:lstStyle/>
+          <a:p>
+            <a:endParaRPr lang="pt-BR"/>
+          </a:p>
+        </p:txBody>
+      </p:sp>
+      <p:sp>
+        <p:nvSpPr>
+          <p:cNvPr id="9031" name="texto"/>
+          <p:cNvSpPr txBox="1"/>
+          <p:nvPr/>
+        </p:nvSpPr>
+        <p:spPr>
+          <a:xfrm>
+            <a:off x="914400" y="3886200"/>
+            <a:ext cx="384048" cy="384048"/>
+          </a:xfrm>
+          <a:prstGeom prst="rect">
+            <a:avLst/>
+          </a:prstGeom>
+          <a:noFill/>
+        </p:spPr>
+        <p:txBody>
+          <a:bodyPr wrap="square" lIns="0" tIns="0" rIns="0" bIns="0" rtlCol="0" anchor="ctr">
+            <a:noAutofit/>
+          </a:bodyPr>
+          <a:lstStyle/>
+          <a:p>
+            <a:pPr marL="0" indent="0" algn="ctr">
+              <a:buNone/>
+            </a:pPr>
+            <a:r>
+              <a:rPr lang="pt-BR" sz="1400" b="1" dirty="0">
+                <a:solidFill>
+                  <a:srgbClr val="FFFFFF"/>
+                </a:solidFill>
+              </a:rPr>
+              <a:t>8</a:t>
+            </a:r>
+            <a:endParaRPr lang="pt-BR" sz="1400" dirty="0"/>
+          </a:p>
+        </p:txBody>
+      </p:sp>
+      <p:sp>
+        <p:nvSpPr>
+          <p:cNvPr id="9032" name="texto"/>
+          <p:cNvSpPr txBox="1"/>
+          <p:nvPr/>
+        </p:nvSpPr>
+        <p:spPr>
+          <a:xfrm>
+            <a:off x="1481328" y="3703320"/>
+            <a:ext cx="6729984" cy="749808"/>
+          </a:xfrm>
+          <a:prstGeom prst="rect">
+            <a:avLst/>
+          </a:prstGeom>
+          <a:noFill/>
+        </p:spPr>
+        <p:txBody>
+          <a:bodyPr wrap="square" lIns="0" tIns="0" rIns="0" bIns="0" rtlCol="0" anchor="ctr">
+            <a:noAutofit/>
+          </a:bodyPr>
+          <a:lstStyle/>
+          <a:p>
+            <a:pPr marL="0" indent="0">
+              <a:spcAft>
+                <a:spcPts val="200"/>
+              </a:spcAft>
+              <a:buNone/>
+            </a:pPr>
+            <a:r>
+              <a:rPr lang="pt-BR" sz="1300" b="1" dirty="0">
+                <a:solidFill>
+                  <a:srgbClr val="00397B"/>
+                </a:solidFill>
+              </a:rPr>
+              <a:t>Esconder o link no menu protege a tela?</a:t>
+            </a:r>
+            <a:endParaRPr lang="pt-BR" sz="1300" dirty="0"/>
+          </a:p>
+          <a:p>
+            <a:pPr marL="0" indent="0">
+              <a:buNone/>
+            </a:pPr>
+            <a:r>
+              <a:rPr lang="pt-BR" sz="1150" dirty="0">
+                <a:solidFill>
+                  <a:srgbClr val="3A3F44"/>
+                </a:solidFill>
+              </a:rPr>
+              <a:t>Não: quem digita a URL chega na view do mesmo jeito. Esconder o link é cortesia; a proteção é o decorator na view (</a:t>
+            </a:r>
+            <a:r>
+              <a:rPr lang="pt-BR" sz="1000" dirty="0">
+                <a:solidFill>
+                  <a:srgbClr val="00397B"/>
+                </a:solidFill>
+                <a:latin typeface="Courier New" pitchFamily="49" charset="0"/>
+                <a:ea typeface="Courier New" pitchFamily="49" charset="0"/>
+                <a:cs typeface="Courier New" pitchFamily="49" charset="0"/>
+              </a:rPr>
+              <a:t>@login_required</a:t>
+            </a:r>
+            <a:r>
+              <a:rPr lang="pt-BR" sz="1150" dirty="0">
+                <a:solidFill>
+                  <a:srgbClr val="3A3F44"/>
+                </a:solidFill>
+              </a:rPr>
+              <a:t xml:space="preserve">, </a:t>
+            </a:r>
+            <a:r>
+              <a:rPr lang="pt-BR" sz="1000" dirty="0">
+                <a:solidFill>
+                  <a:srgbClr val="00397B"/>
+                </a:solidFill>
+                <a:latin typeface="Courier New" pitchFamily="49" charset="0"/>
+                <a:ea typeface="Courier New" pitchFamily="49" charset="0"/>
+                <a:cs typeface="Courier New" pitchFamily="49" charset="0"/>
+              </a:rPr>
+              <a:t>@somente_coordenacao</a:t>
+            </a:r>
+            <a:r>
+              <a:rPr lang="pt-BR" sz="1150" dirty="0">
+                <a:solidFill>
+                  <a:srgbClr val="3A3F44"/>
+                </a:solidFill>
+              </a:rPr>
+              <a:t>).</a:t>
+            </a:r>
+            <a:endParaRPr lang="pt-BR" sz="1150" dirty="0"/>
           </a:p>
         </p:txBody>
       </p:sp>
@@ -17556,13 +19302,13 @@
               <a:buNone/>
             </a:pPr>
             <a:r>
-              <a:rPr lang="en-US" sz="1300" dirty="0">
+              <a:rPr lang="en-US" sz="1150" dirty="0">
                 <a:solidFill>
                   <a:srgbClr val="00397B"/>
                 </a:solidFill>
-                <a:latin typeface="Consolas" pitchFamily="34" charset="0"/>
-                <a:ea typeface="Consolas" pitchFamily="34" charset="-122"/>
-                <a:cs typeface="Consolas" pitchFamily="34" charset="-120"/>
+                <a:latin typeface="Courier New" pitchFamily="49" charset="0"/>
+                <a:ea typeface="Courier New" pitchFamily="49" charset="-122"/>
+                <a:cs typeface="Courier New" pitchFamily="49" charset="-120"/>
               </a:rPr>
               <a:t>check --deploy</a:t>
             </a:r>
@@ -18464,38 +20210,38 @@
               <a:buNone/>
             </a:pPr>
             <a:r>
+              <a:rPr lang="en-US" sz="1150" dirty="0">
+                <a:solidFill>
+                  <a:srgbClr val="00397B"/>
+                </a:solidFill>
+                <a:latin typeface="Courier New" pitchFamily="49" charset="0"/>
+                <a:ea typeface="Courier New" pitchFamily="49" charset="-122"/>
+                <a:cs typeface="Courier New" pitchFamily="49" charset="-120"/>
+              </a:rPr>
+              <a:t>sqlite3</a:t>
+            </a:r>
+            <a:pPr indent="0" marL="0">
+              <a:buNone/>
+            </a:pPr>
+            <a:r>
               <a:rPr lang="en-US" sz="1300" dirty="0">
                 <a:solidFill>
+                  <a:srgbClr val="3A3F44"/>
+                </a:solidFill>
+              </a:rPr>
+              <a:t>, ORM. CRUD em ciclos curtos, com o </a:t>
+            </a:r>
+            <a:pPr indent="0" marL="0">
+              <a:buNone/>
+            </a:pPr>
+            <a:r>
+              <a:rPr lang="en-US" sz="1150" dirty="0">
+                <a:solidFill>
                   <a:srgbClr val="00397B"/>
                 </a:solidFill>
-                <a:latin typeface="Consolas" pitchFamily="34" charset="0"/>
-                <a:ea typeface="Consolas" pitchFamily="34" charset="-122"/>
-                <a:cs typeface="Consolas" pitchFamily="34" charset="-120"/>
-              </a:rPr>
-              <a:t>sqlite3</a:t>
-            </a:r>
-            <a:pPr indent="0" marL="0">
-              <a:buNone/>
-            </a:pPr>
-            <a:r>
-              <a:rPr lang="en-US" sz="1300" dirty="0">
-                <a:solidFill>
-                  <a:srgbClr val="3A3F44"/>
-                </a:solidFill>
-              </a:rPr>
-              <a:t>, ORM. CRUD em ciclos curtos, com o </a:t>
-            </a:r>
-            <a:pPr indent="0" marL="0">
-              <a:buNone/>
-            </a:pPr>
-            <a:r>
-              <a:rPr lang="en-US" sz="1300" dirty="0">
-                <a:solidFill>
-                  <a:srgbClr val="00397B"/>
-                </a:solidFill>
-                <a:latin typeface="Consolas" pitchFamily="34" charset="0"/>
-                <a:ea typeface="Consolas" pitchFamily="34" charset="-122"/>
-                <a:cs typeface="Consolas" pitchFamily="34" charset="-120"/>
+                <a:latin typeface="Courier New" pitchFamily="49" charset="0"/>
+                <a:ea typeface="Courier New" pitchFamily="49" charset="-122"/>
+                <a:cs typeface="Courier New" pitchFamily="49" charset="-120"/>
               </a:rPr>
               <a:t>verificar.py</a:t>
             </a:r>
@@ -19107,13 +20853,13 @@
                         <a:buNone/>
                       </a:pPr>
                       <a:r>
-                        <a:rPr lang="en-US" sz="1300" dirty="0">
+                        <a:rPr lang="en-US" sz="1150" dirty="0">
                           <a:solidFill>
                             <a:srgbClr val="00397B"/>
                           </a:solidFill>
-                          <a:latin typeface="Consolas" pitchFamily="34" charset="0"/>
-                          <a:ea typeface="Consolas" pitchFamily="34" charset="-122"/>
-                          <a:cs typeface="Consolas" pitchFamily="34" charset="-120"/>
+                          <a:latin typeface="Courier New" pitchFamily="49" charset="0"/>
+                          <a:ea typeface="Courier New" pitchFamily="49" charset="-122"/>
+                          <a:cs typeface="Courier New" pitchFamily="49" charset="-120"/>
                         </a:rPr>
                         <a:t>ENUNCIADO.md</a:t>
                       </a:r>
@@ -19270,13 +21016,13 @@
                         <a:buNone/>
                       </a:pPr>
                       <a:r>
-                        <a:rPr lang="en-US" sz="1300" dirty="0">
+                        <a:rPr lang="en-US" sz="1150" dirty="0">
                           <a:solidFill>
                             <a:srgbClr val="00397B"/>
                           </a:solidFill>
-                          <a:latin typeface="Consolas" pitchFamily="34" charset="0"/>
-                          <a:ea typeface="Consolas" pitchFamily="34" charset="-122"/>
-                          <a:cs typeface="Consolas" pitchFamily="34" charset="-120"/>
+                          <a:latin typeface="Courier New" pitchFamily="49" charset="0"/>
+                          <a:ea typeface="Courier New" pitchFamily="49" charset="-122"/>
+                          <a:cs typeface="Courier New" pitchFamily="49" charset="-120"/>
                         </a:rPr>
                         <a:t>models.py</a:t>
                       </a:r>
@@ -19295,13 +21041,13 @@
                         <a:buNone/>
                       </a:pPr>
                       <a:r>
-                        <a:rPr lang="en-US" sz="1300" dirty="0">
+                        <a:rPr lang="en-US" sz="1150" dirty="0">
                           <a:solidFill>
                             <a:srgbClr val="00397B"/>
                           </a:solidFill>
-                          <a:latin typeface="Consolas" pitchFamily="34" charset="0"/>
-                          <a:ea typeface="Consolas" pitchFamily="34" charset="-122"/>
-                          <a:cs typeface="Consolas" pitchFamily="34" charset="-120"/>
+                          <a:latin typeface="Courier New" pitchFamily="49" charset="0"/>
+                          <a:ea typeface="Courier New" pitchFamily="49" charset="-122"/>
+                          <a:cs typeface="Courier New" pitchFamily="49" charset="-120"/>
                         </a:rPr>
                         <a:t>modelo_dados.png</a:t>
                       </a:r>
@@ -19447,13 +21193,13 @@
                         <a:buNone/>
                       </a:pPr>
                       <a:r>
-                        <a:rPr lang="en-US" sz="1300" dirty="0">
+                        <a:rPr lang="en-US" sz="1150" dirty="0">
                           <a:solidFill>
                             <a:srgbClr val="00397B"/>
                           </a:solidFill>
-                          <a:latin typeface="Consolas" pitchFamily="34" charset="0"/>
-                          <a:ea typeface="Consolas" pitchFamily="34" charset="-122"/>
-                          <a:cs typeface="Consolas" pitchFamily="34" charset="-120"/>
+                          <a:latin typeface="Courier New" pitchFamily="49" charset="0"/>
+                          <a:ea typeface="Courier New" pitchFamily="49" charset="-122"/>
+                          <a:cs typeface="Courier New" pitchFamily="49" charset="-120"/>
                         </a:rPr>
                         <a:t>views.py</a:t>
                       </a:r>
@@ -19472,13 +21218,13 @@
                         <a:buNone/>
                       </a:pPr>
                       <a:r>
-                        <a:rPr lang="en-US" sz="1300" dirty="0">
+                        <a:rPr lang="en-US" sz="1150" dirty="0">
                           <a:solidFill>
                             <a:srgbClr val="00397B"/>
                           </a:solidFill>
-                          <a:latin typeface="Consolas" pitchFamily="34" charset="0"/>
-                          <a:ea typeface="Consolas" pitchFamily="34" charset="-122"/>
-                          <a:cs typeface="Consolas" pitchFamily="34" charset="-120"/>
+                          <a:latin typeface="Courier New" pitchFamily="49" charset="0"/>
+                          <a:ea typeface="Courier New" pitchFamily="49" charset="-122"/>
+                          <a:cs typeface="Courier New" pitchFamily="49" charset="-120"/>
                         </a:rPr>
                         <a:t>urls.py</a:t>
                       </a:r>
@@ -19635,13 +21381,13 @@
                         <a:buNone/>
                       </a:pPr>
                       <a:r>
-                        <a:rPr lang="en-US" sz="1300" dirty="0">
+                        <a:rPr lang="en-US" sz="1150" dirty="0">
                           <a:solidFill>
                             <a:srgbClr val="00397B"/>
                           </a:solidFill>
-                          <a:latin typeface="Consolas" pitchFamily="34" charset="0"/>
-                          <a:ea typeface="Consolas" pitchFamily="34" charset="-122"/>
-                          <a:cs typeface="Consolas" pitchFamily="34" charset="-120"/>
+                          <a:latin typeface="Courier New" pitchFamily="49" charset="0"/>
+                          <a:ea typeface="Courier New" pitchFamily="49" charset="-122"/>
+                          <a:cs typeface="Courier New" pitchFamily="49" charset="-120"/>
                         </a:rPr>
                         <a:t>ModelForm</a:t>
                       </a:r>
@@ -19660,13 +21406,13 @@
                         <a:buNone/>
                       </a:pPr>
                       <a:r>
-                        <a:rPr lang="en-US" sz="1300" dirty="0">
+                        <a:rPr lang="en-US" sz="1150" dirty="0">
                           <a:solidFill>
                             <a:srgbClr val="00397B"/>
                           </a:solidFill>
-                          <a:latin typeface="Consolas" pitchFamily="34" charset="0"/>
-                          <a:ea typeface="Consolas" pitchFamily="34" charset="-122"/>
-                          <a:cs typeface="Consolas" pitchFamily="34" charset="-120"/>
+                          <a:latin typeface="Courier New" pitchFamily="49" charset="0"/>
+                          <a:ea typeface="Courier New" pitchFamily="49" charset="-122"/>
+                          <a:cs typeface="Courier New" pitchFamily="49" charset="-120"/>
                         </a:rPr>
                         <a:t>admin.py</a:t>
                       </a:r>
@@ -19812,13 +21558,13 @@
                         <a:buNone/>
                       </a:pPr>
                       <a:r>
-                        <a:rPr lang="en-US" sz="1300" dirty="0">
+                        <a:rPr lang="en-US" sz="1150" dirty="0">
                           <a:solidFill>
                             <a:srgbClr val="00397B"/>
                           </a:solidFill>
-                          <a:latin typeface="Consolas" pitchFamily="34" charset="0"/>
-                          <a:ea typeface="Consolas" pitchFamily="34" charset="-122"/>
-                          <a:cs typeface="Consolas" pitchFamily="34" charset="-120"/>
+                          <a:latin typeface="Courier New" pitchFamily="49" charset="0"/>
+                          <a:ea typeface="Courier New" pitchFamily="49" charset="-122"/>
+                          <a:cs typeface="Courier New" pitchFamily="49" charset="-120"/>
                         </a:rPr>
                         <a:t>verificar.py</a:t>
                       </a:r>
@@ -19837,13 +21583,13 @@
                         <a:buNone/>
                       </a:pPr>
                       <a:r>
-                        <a:rPr lang="en-US" sz="1300" dirty="0">
+                        <a:rPr lang="en-US" sz="1150" dirty="0">
                           <a:solidFill>
                             <a:srgbClr val="00397B"/>
                           </a:solidFill>
-                          <a:latin typeface="Consolas" pitchFamily="34" charset="0"/>
-                          <a:ea typeface="Consolas" pitchFamily="34" charset="-122"/>
-                          <a:cs typeface="Consolas" pitchFamily="34" charset="-120"/>
+                          <a:latin typeface="Courier New" pitchFamily="49" charset="0"/>
+                          <a:ea typeface="Courier New" pitchFamily="49" charset="-122"/>
+                          <a:cs typeface="Courier New" pitchFamily="49" charset="-120"/>
                         </a:rPr>
                         <a:t>tests/</a:t>
                       </a:r>
@@ -20104,7 +21850,7 @@
           <a:ln/>
         </p:spPr>
         <p:txBody>
-          <a:bodyPr wrap="square" lIns="0" tIns="0" rIns="0" bIns="0" rtlCol="0" anchor="ctr"/>
+          <a:bodyPr wrap="none" lIns="0" tIns="0" rIns="0" bIns="0" rtlCol="0" anchor="ctr"/>
           <a:lstStyle/>
           <a:p>
             <a:pPr indent="0" marL="0">
@@ -20115,9 +21861,9 @@
                 <a:solidFill>
                   <a:srgbClr val="8B949E"/>
                 </a:solidFill>
-                <a:latin typeface="Consolas" pitchFamily="34" charset="0"/>
-                <a:ea typeface="Consolas" pitchFamily="34" charset="-122"/>
-                <a:cs typeface="Consolas" pitchFamily="34" charset="-120"/>
+                <a:latin typeface="Courier New" pitchFamily="49" charset="0"/>
+                <a:ea typeface="Courier New" pitchFamily="49" charset="-122"/>
+                <a:cs typeface="Courier New" pitchFamily="49" charset="-120"/>
               </a:rPr>
               <a:t>alunos.txt</a:t>
             </a:r>
@@ -20143,20 +21889,20 @@
           <a:ln/>
         </p:spPr>
         <p:txBody>
-          <a:bodyPr wrap="square" lIns="0" tIns="0" rIns="0" bIns="0" rtlCol="0" anchor="t"/>
-          <a:lstStyle/>
-          <a:p>
-            <a:pPr indent="0" marL="0">
-              <a:buNone/>
-            </a:pPr>
-            <a:r>
-              <a:rPr lang="en-US" sz="1000" dirty="0">
+          <a:bodyPr wrap="none" lIns="0" tIns="0" rIns="0" bIns="0" rtlCol="0" anchor="t"/>
+          <a:lstStyle/>
+          <a:p>
+            <a:pPr indent="0" marL="0">
+              <a:buNone/>
+            </a:pPr>
+            <a:r>
+              <a:rPr lang="en-US" sz="950" dirty="0">
                 <a:solidFill>
                   <a:srgbClr val="E6EDF3"/>
                 </a:solidFill>
-                <a:latin typeface="Consolas" pitchFamily="34" charset="0"/>
-                <a:ea typeface="Consolas" pitchFamily="34" charset="-122"/>
-                <a:cs typeface="Consolas" pitchFamily="34" charset="-120"/>
+                <a:latin typeface="Courier New" pitchFamily="49" charset="0"/>
+                <a:ea typeface="Courier New" pitchFamily="49" charset="-122"/>
+                <a:cs typeface="Courier New" pitchFamily="49" charset="-120"/>
               </a:rPr>
               <a:t>f = open(</a:t>
             </a:r>
@@ -20164,13 +21910,13 @@
               <a:buNone/>
             </a:pPr>
             <a:r>
-              <a:rPr lang="en-US" sz="1000" dirty="0">
+              <a:rPr lang="en-US" sz="950" dirty="0">
                 <a:solidFill>
                   <a:srgbClr val="F0C674"/>
                 </a:solidFill>
-                <a:latin typeface="Consolas" pitchFamily="34" charset="0"/>
-                <a:ea typeface="Consolas" pitchFamily="34" charset="-122"/>
-                <a:cs typeface="Consolas" pitchFamily="34" charset="-120"/>
+                <a:latin typeface="Courier New" pitchFamily="49" charset="0"/>
+                <a:ea typeface="Courier New" pitchFamily="49" charset="-122"/>
+                <a:cs typeface="Courier New" pitchFamily="49" charset="-120"/>
               </a:rPr>
               <a:t>"alunos.txt"</a:t>
             </a:r>
@@ -20178,13 +21924,13 @@
               <a:buNone/>
             </a:pPr>
             <a:r>
-              <a:rPr lang="en-US" sz="1000" dirty="0">
+              <a:rPr lang="en-US" sz="950" dirty="0">
                 <a:solidFill>
                   <a:srgbClr val="E6EDF3"/>
                 </a:solidFill>
-                <a:latin typeface="Consolas" pitchFamily="34" charset="0"/>
-                <a:ea typeface="Consolas" pitchFamily="34" charset="-122"/>
-                <a:cs typeface="Consolas" pitchFamily="34" charset="-120"/>
+                <a:latin typeface="Courier New" pitchFamily="49" charset="0"/>
+                <a:ea typeface="Courier New" pitchFamily="49" charset="-122"/>
+                <a:cs typeface="Courier New" pitchFamily="49" charset="-120"/>
               </a:rPr>
               <a:t>, </a:t>
             </a:r>
@@ -20192,13 +21938,13 @@
               <a:buNone/>
             </a:pPr>
             <a:r>
-              <a:rPr lang="en-US" sz="1000" dirty="0">
+              <a:rPr lang="en-US" sz="950" dirty="0">
                 <a:solidFill>
                   <a:srgbClr val="F0C674"/>
                 </a:solidFill>
-                <a:latin typeface="Consolas" pitchFamily="34" charset="0"/>
-                <a:ea typeface="Consolas" pitchFamily="34" charset="-122"/>
-                <a:cs typeface="Consolas" pitchFamily="34" charset="-120"/>
+                <a:latin typeface="Courier New" pitchFamily="49" charset="0"/>
+                <a:ea typeface="Courier New" pitchFamily="49" charset="-122"/>
+                <a:cs typeface="Courier New" pitchFamily="49" charset="-120"/>
               </a:rPr>
               <a:t>"a"</a:t>
             </a:r>
@@ -20206,30 +21952,30 @@
               <a:buNone/>
             </a:pPr>
             <a:r>
-              <a:rPr lang="en-US" sz="1000" dirty="0">
+              <a:rPr lang="en-US" sz="950" dirty="0">
                 <a:solidFill>
                   <a:srgbClr val="E6EDF3"/>
                 </a:solidFill>
-                <a:latin typeface="Consolas" pitchFamily="34" charset="0"/>
-                <a:ea typeface="Consolas" pitchFamily="34" charset="-122"/>
-                <a:cs typeface="Consolas" pitchFamily="34" charset="-120"/>
+                <a:latin typeface="Courier New" pitchFamily="49" charset="0"/>
+                <a:ea typeface="Courier New" pitchFamily="49" charset="-122"/>
+                <a:cs typeface="Courier New" pitchFamily="49" charset="-120"/>
               </a:rPr>
               <a:t>)</a:t>
             </a:r>
-            <a:endParaRPr lang="en-US" sz="1000" dirty="0"/>
-          </a:p>
-          <a:p>
-            <a:pPr indent="0" marL="0">
-              <a:buNone/>
-            </a:pPr>
-            <a:r>
-              <a:rPr lang="en-US" sz="1000" dirty="0">
+            <a:endParaRPr lang="en-US" sz="950" dirty="0"/>
+          </a:p>
+          <a:p>
+            <a:pPr indent="0" marL="0">
+              <a:buNone/>
+            </a:pPr>
+            <a:r>
+              <a:rPr lang="en-US" sz="950" dirty="0">
                 <a:solidFill>
                   <a:srgbClr val="E6EDF3"/>
                 </a:solidFill>
-                <a:latin typeface="Consolas" pitchFamily="34" charset="0"/>
-                <a:ea typeface="Consolas" pitchFamily="34" charset="-122"/>
-                <a:cs typeface="Consolas" pitchFamily="34" charset="-120"/>
+                <a:latin typeface="Courier New" pitchFamily="49" charset="0"/>
+                <a:ea typeface="Courier New" pitchFamily="49" charset="-122"/>
+                <a:cs typeface="Courier New" pitchFamily="49" charset="-120"/>
               </a:rPr>
               <a:t>f.write(f</a:t>
             </a:r>
@@ -20237,13 +21983,13 @@
               <a:buNone/>
             </a:pPr>
             <a:r>
-              <a:rPr lang="en-US" sz="1000" dirty="0">
+              <a:rPr lang="en-US" sz="950" dirty="0">
                 <a:solidFill>
                   <a:srgbClr val="F0C674"/>
                 </a:solidFill>
-                <a:latin typeface="Consolas" pitchFamily="34" charset="0"/>
-                <a:ea typeface="Consolas" pitchFamily="34" charset="-122"/>
-                <a:cs typeface="Consolas" pitchFamily="34" charset="-120"/>
+                <a:latin typeface="Courier New" pitchFamily="49" charset="0"/>
+                <a:ea typeface="Courier New" pitchFamily="49" charset="-122"/>
+                <a:cs typeface="Courier New" pitchFamily="49" charset="-120"/>
               </a:rPr>
               <a:t>"{mat};{nome}\n"</a:t>
             </a:r>
@@ -20251,34 +21997,34 @@
               <a:buNone/>
             </a:pPr>
             <a:r>
-              <a:rPr lang="en-US" sz="1000" dirty="0">
+              <a:rPr lang="en-US" sz="950" dirty="0">
                 <a:solidFill>
                   <a:srgbClr val="E6EDF3"/>
                 </a:solidFill>
-                <a:latin typeface="Consolas" pitchFamily="34" charset="0"/>
-                <a:ea typeface="Consolas" pitchFamily="34" charset="-122"/>
-                <a:cs typeface="Consolas" pitchFamily="34" charset="-120"/>
+                <a:latin typeface="Courier New" pitchFamily="49" charset="0"/>
+                <a:ea typeface="Courier New" pitchFamily="49" charset="-122"/>
+                <a:cs typeface="Courier New" pitchFamily="49" charset="-120"/>
               </a:rPr>
               <a:t>)</a:t>
             </a:r>
-            <a:endParaRPr lang="en-US" sz="1000" dirty="0"/>
-          </a:p>
-          <a:p>
-            <a:pPr indent="0" marL="0">
-              <a:buNone/>
-            </a:pPr>
-            <a:r>
-              <a:rPr lang="en-US" sz="1000" dirty="0">
+            <a:endParaRPr lang="en-US" sz="950" dirty="0"/>
+          </a:p>
+          <a:p>
+            <a:pPr indent="0" marL="0">
+              <a:buNone/>
+            </a:pPr>
+            <a:r>
+              <a:rPr lang="en-US" sz="950" dirty="0">
                 <a:solidFill>
                   <a:srgbClr val="E6EDF3"/>
                 </a:solidFill>
-                <a:latin typeface="Consolas" pitchFamily="34" charset="0"/>
-                <a:ea typeface="Consolas" pitchFamily="34" charset="-122"/>
-                <a:cs typeface="Consolas" pitchFamily="34" charset="-120"/>
+                <a:latin typeface="Courier New" pitchFamily="49" charset="0"/>
+                <a:ea typeface="Courier New" pitchFamily="49" charset="-122"/>
+                <a:cs typeface="Courier New" pitchFamily="49" charset="-120"/>
               </a:rPr>
               <a:t>f.close()</a:t>
             </a:r>
-            <a:endParaRPr lang="en-US" sz="1000" dirty="0"/>
+            <a:endParaRPr lang="en-US" sz="950" dirty="0"/>
           </a:p>
         </p:txBody>
       </p:sp>
@@ -20547,7 +22293,7 @@
           <a:ln/>
         </p:spPr>
         <p:txBody>
-          <a:bodyPr wrap="square" lIns="0" tIns="0" rIns="0" bIns="0" rtlCol="0" anchor="ctr"/>
+          <a:bodyPr wrap="none" lIns="0" tIns="0" rIns="0" bIns="0" rtlCol="0" anchor="ctr"/>
           <a:lstStyle/>
           <a:p>
             <a:pPr indent="0" marL="0">
@@ -20558,9 +22304,9 @@
                 <a:solidFill>
                   <a:srgbClr val="8B949E"/>
                 </a:solidFill>
-                <a:latin typeface="Consolas" pitchFamily="34" charset="0"/>
-                <a:ea typeface="Consolas" pitchFamily="34" charset="-122"/>
-                <a:cs typeface="Consolas" pitchFamily="34" charset="-120"/>
+                <a:latin typeface="Courier New" pitchFamily="49" charset="0"/>
+                <a:ea typeface="Courier New" pitchFamily="49" charset="-122"/>
+                <a:cs typeface="Courier New" pitchFamily="49" charset="-120"/>
               </a:rPr>
               <a:t>Entrega 1</a:t>
             </a:r>
@@ -20586,7 +22332,7 @@
           <a:ln/>
         </p:spPr>
         <p:txBody>
-          <a:bodyPr wrap="square" lIns="0" tIns="0" rIns="0" bIns="0" rtlCol="0" anchor="t"/>
+          <a:bodyPr wrap="none" lIns="0" tIns="0" rIns="0" bIns="0" rtlCol="0" anchor="t"/>
           <a:lstStyle/>
           <a:p>
             <a:pPr indent="0" marL="0">
@@ -20597,9 +22343,9 @@
                 <a:solidFill>
                   <a:srgbClr val="E6EDF3"/>
                 </a:solidFill>
-                <a:latin typeface="Consolas" pitchFamily="34" charset="0"/>
-                <a:ea typeface="Consolas" pitchFamily="34" charset="-122"/>
-                <a:cs typeface="Consolas" pitchFamily="34" charset="-120"/>
+                <a:latin typeface="Courier New" pitchFamily="49" charset="0"/>
+                <a:ea typeface="Courier New" pitchFamily="49" charset="-122"/>
+                <a:cs typeface="Courier New" pitchFamily="49" charset="-120"/>
               </a:rPr>
               <a:t>con.execute(</a:t>
             </a:r>
@@ -20614,9 +22360,9 @@
                 <a:solidFill>
                   <a:srgbClr val="E6EDF3"/>
                 </a:solidFill>
-                <a:latin typeface="Consolas" pitchFamily="34" charset="0"/>
-                <a:ea typeface="Consolas" pitchFamily="34" charset="-122"/>
-                <a:cs typeface="Consolas" pitchFamily="34" charset="-120"/>
+                <a:latin typeface="Courier New" pitchFamily="49" charset="0"/>
+                <a:ea typeface="Courier New" pitchFamily="49" charset="-122"/>
+                <a:cs typeface="Courier New" pitchFamily="49" charset="-120"/>
               </a:rPr>
               <a:t>  </a:t>
             </a:r>
@@ -20628,9 +22374,9 @@
                 <a:solidFill>
                   <a:srgbClr val="F0C674"/>
                 </a:solidFill>
-                <a:latin typeface="Consolas" pitchFamily="34" charset="0"/>
-                <a:ea typeface="Consolas" pitchFamily="34" charset="-122"/>
-                <a:cs typeface="Consolas" pitchFamily="34" charset="-120"/>
+                <a:latin typeface="Courier New" pitchFamily="49" charset="0"/>
+                <a:ea typeface="Courier New" pitchFamily="49" charset="-122"/>
+                <a:cs typeface="Courier New" pitchFamily="49" charset="-120"/>
               </a:rPr>
               <a:t>"INSERT INTO aluno"</a:t>
             </a:r>
@@ -20645,9 +22391,9 @@
                 <a:solidFill>
                   <a:srgbClr val="E6EDF3"/>
                 </a:solidFill>
-                <a:latin typeface="Consolas" pitchFamily="34" charset="0"/>
-                <a:ea typeface="Consolas" pitchFamily="34" charset="-122"/>
-                <a:cs typeface="Consolas" pitchFamily="34" charset="-120"/>
+                <a:latin typeface="Courier New" pitchFamily="49" charset="0"/>
+                <a:ea typeface="Courier New" pitchFamily="49" charset="-122"/>
+                <a:cs typeface="Courier New" pitchFamily="49" charset="-120"/>
               </a:rPr>
               <a:t>  </a:t>
             </a:r>
@@ -20659,9 +22405,9 @@
                 <a:solidFill>
                   <a:srgbClr val="F0C674"/>
                 </a:solidFill>
-                <a:latin typeface="Consolas" pitchFamily="34" charset="0"/>
-                <a:ea typeface="Consolas" pitchFamily="34" charset="-122"/>
-                <a:cs typeface="Consolas" pitchFamily="34" charset="-120"/>
+                <a:latin typeface="Courier New" pitchFamily="49" charset="0"/>
+                <a:ea typeface="Courier New" pitchFamily="49" charset="-122"/>
+                <a:cs typeface="Courier New" pitchFamily="49" charset="-120"/>
               </a:rPr>
               <a:t>" (matricula, nome)"</a:t>
             </a:r>
@@ -20676,9 +22422,9 @@
                 <a:solidFill>
                   <a:srgbClr val="E6EDF3"/>
                 </a:solidFill>
-                <a:latin typeface="Consolas" pitchFamily="34" charset="0"/>
-                <a:ea typeface="Consolas" pitchFamily="34" charset="-122"/>
-                <a:cs typeface="Consolas" pitchFamily="34" charset="-120"/>
+                <a:latin typeface="Courier New" pitchFamily="49" charset="0"/>
+                <a:ea typeface="Courier New" pitchFamily="49" charset="-122"/>
+                <a:cs typeface="Courier New" pitchFamily="49" charset="-120"/>
               </a:rPr>
               <a:t>  </a:t>
             </a:r>
@@ -20690,9 +22436,9 @@
                 <a:solidFill>
                   <a:srgbClr val="F0C674"/>
                 </a:solidFill>
-                <a:latin typeface="Consolas" pitchFamily="34" charset="0"/>
-                <a:ea typeface="Consolas" pitchFamily="34" charset="-122"/>
-                <a:cs typeface="Consolas" pitchFamily="34" charset="-120"/>
+                <a:latin typeface="Courier New" pitchFamily="49" charset="0"/>
+                <a:ea typeface="Courier New" pitchFamily="49" charset="-122"/>
+                <a:cs typeface="Courier New" pitchFamily="49" charset="-120"/>
               </a:rPr>
               <a:t>" VALUES (?, ?)"</a:t>
             </a:r>
@@ -20704,9 +22450,9 @@
                 <a:solidFill>
                   <a:srgbClr val="E6EDF3"/>
                 </a:solidFill>
-                <a:latin typeface="Consolas" pitchFamily="34" charset="0"/>
-                <a:ea typeface="Consolas" pitchFamily="34" charset="-122"/>
-                <a:cs typeface="Consolas" pitchFamily="34" charset="-120"/>
+                <a:latin typeface="Courier New" pitchFamily="49" charset="0"/>
+                <a:ea typeface="Courier New" pitchFamily="49" charset="-122"/>
+                <a:cs typeface="Courier New" pitchFamily="49" charset="-120"/>
               </a:rPr>
               <a:t>,</a:t>
             </a:r>
@@ -20721,9 +22467,9 @@
                 <a:solidFill>
                   <a:srgbClr val="E6EDF3"/>
                 </a:solidFill>
-                <a:latin typeface="Consolas" pitchFamily="34" charset="0"/>
-                <a:ea typeface="Consolas" pitchFamily="34" charset="-122"/>
-                <a:cs typeface="Consolas" pitchFamily="34" charset="-120"/>
+                <a:latin typeface="Courier New" pitchFamily="49" charset="0"/>
+                <a:ea typeface="Courier New" pitchFamily="49" charset="-122"/>
+                <a:cs typeface="Courier New" pitchFamily="49" charset="-120"/>
               </a:rPr>
               <a:t>  (mat, nome))</a:t>
             </a:r>
@@ -20738,9 +22484,9 @@
                 <a:solidFill>
                   <a:srgbClr val="E6EDF3"/>
                 </a:solidFill>
-                <a:latin typeface="Consolas" pitchFamily="34" charset="0"/>
-                <a:ea typeface="Consolas" pitchFamily="34" charset="-122"/>
-                <a:cs typeface="Consolas" pitchFamily="34" charset="-120"/>
+                <a:latin typeface="Courier New" pitchFamily="49" charset="0"/>
+                <a:ea typeface="Courier New" pitchFamily="49" charset="-122"/>
+                <a:cs typeface="Courier New" pitchFamily="49" charset="-120"/>
               </a:rPr>
               <a:t>con.commit()</a:t>
             </a:r>
@@ -20833,13 +22579,13 @@
               <a:buNone/>
             </a:pPr>
             <a:r>
-              <a:rPr lang="en-US" sz="1300" dirty="0">
+              <a:rPr lang="en-US" sz="1150" dirty="0">
                 <a:solidFill>
                   <a:srgbClr val="00397B"/>
                 </a:solidFill>
-                <a:latin typeface="Consolas" pitchFamily="34" charset="0"/>
-                <a:ea typeface="Consolas" pitchFamily="34" charset="-122"/>
-                <a:cs typeface="Consolas" pitchFamily="34" charset="-120"/>
+                <a:latin typeface="Courier New" pitchFamily="49" charset="0"/>
+                <a:ea typeface="Courier New" pitchFamily="49" charset="-122"/>
+                <a:cs typeface="Courier New" pitchFamily="49" charset="-120"/>
               </a:rPr>
               <a:t>UNIQUE</a:t>
             </a:r>
@@ -21038,7 +22784,7 @@
           <a:ln/>
         </p:spPr>
         <p:txBody>
-          <a:bodyPr wrap="square" lIns="0" tIns="0" rIns="0" bIns="0" rtlCol="0" anchor="ctr"/>
+          <a:bodyPr wrap="none" lIns="0" tIns="0" rIns="0" bIns="0" rtlCol="0" anchor="ctr"/>
           <a:lstStyle/>
           <a:p>
             <a:pPr indent="0" marL="0">
@@ -21049,9 +22795,9 @@
                 <a:solidFill>
                   <a:srgbClr val="8B949E"/>
                 </a:solidFill>
-                <a:latin typeface="Consolas" pitchFamily="34" charset="0"/>
-                <a:ea typeface="Consolas" pitchFamily="34" charset="-122"/>
-                <a:cs typeface="Consolas" pitchFamily="34" charset="-120"/>
+                <a:latin typeface="Courier New" pitchFamily="49" charset="0"/>
+                <a:ea typeface="Courier New" pitchFamily="49" charset="-122"/>
+                <a:cs typeface="Courier New" pitchFamily="49" charset="-120"/>
               </a:rPr>
               <a:t>Entrega 2</a:t>
             </a:r>
@@ -21077,7 +22823,7 @@
           <a:ln/>
         </p:spPr>
         <p:txBody>
-          <a:bodyPr wrap="square" lIns="0" tIns="0" rIns="0" bIns="0" rtlCol="0" anchor="t"/>
+          <a:bodyPr wrap="none" lIns="0" tIns="0" rIns="0" bIns="0" rtlCol="0" anchor="t"/>
           <a:lstStyle/>
           <a:p>
             <a:pPr indent="0" marL="0">
@@ -21088,9 +22834,9 @@
                 <a:solidFill>
                   <a:srgbClr val="E6EDF3"/>
                 </a:solidFill>
-                <a:latin typeface="Consolas" pitchFamily="34" charset="0"/>
-                <a:ea typeface="Consolas" pitchFamily="34" charset="-122"/>
-                <a:cs typeface="Consolas" pitchFamily="34" charset="-120"/>
+                <a:latin typeface="Courier New" pitchFamily="49" charset="0"/>
+                <a:ea typeface="Courier New" pitchFamily="49" charset="-122"/>
+                <a:cs typeface="Courier New" pitchFamily="49" charset="-120"/>
               </a:rPr>
               <a:t>Aluno.objects.create(</a:t>
             </a:r>
@@ -21105,9 +22851,9 @@
                 <a:solidFill>
                   <a:srgbClr val="E6EDF3"/>
                 </a:solidFill>
-                <a:latin typeface="Consolas" pitchFamily="34" charset="0"/>
-                <a:ea typeface="Consolas" pitchFamily="34" charset="-122"/>
-                <a:cs typeface="Consolas" pitchFamily="34" charset="-120"/>
+                <a:latin typeface="Courier New" pitchFamily="49" charset="0"/>
+                <a:ea typeface="Courier New" pitchFamily="49" charset="-122"/>
+                <a:cs typeface="Courier New" pitchFamily="49" charset="-120"/>
               </a:rPr>
               <a:t>    matricula=mat,</a:t>
             </a:r>
@@ -21122,9 +22868,9 @@
                 <a:solidFill>
                   <a:srgbClr val="E6EDF3"/>
                 </a:solidFill>
-                <a:latin typeface="Consolas" pitchFamily="34" charset="0"/>
-                <a:ea typeface="Consolas" pitchFamily="34" charset="-122"/>
-                <a:cs typeface="Consolas" pitchFamily="34" charset="-120"/>
+                <a:latin typeface="Courier New" pitchFamily="49" charset="0"/>
+                <a:ea typeface="Courier New" pitchFamily="49" charset="-122"/>
+                <a:cs typeface="Courier New" pitchFamily="49" charset="-120"/>
               </a:rPr>
               <a:t>    nome=nome)</a:t>
             </a:r>
@@ -22207,13 +23953,13 @@
                         <a:buNone/>
                       </a:pPr>
                       <a:r>
-                        <a:rPr lang="en-US" sz="1300" dirty="0">
+                        <a:rPr lang="en-US" sz="1150" dirty="0">
                           <a:solidFill>
                             <a:srgbClr val="00397B"/>
                           </a:solidFill>
-                          <a:latin typeface="Consolas" pitchFamily="34" charset="0"/>
-                          <a:ea typeface="Consolas" pitchFamily="34" charset="-122"/>
-                          <a:cs typeface="Consolas" pitchFamily="34" charset="-120"/>
+                          <a:latin typeface="Courier New" pitchFamily="49" charset="0"/>
+                          <a:ea typeface="Courier New" pitchFamily="49" charset="-122"/>
+                          <a:cs typeface="Courier New" pitchFamily="49" charset="-120"/>
                         </a:rPr>
                         <a:t>django.contrib.auth</a:t>
                       </a:r>

</xml_diff>